<commit_message>
Replace defense title slide with predefense cover
</commit_message>
<xml_diff>
--- a/final/Marianovskiy_VKR_ADAS_defense_final.pptx
+++ b/final/Marianovskiy_VKR_ADAS_defense_final.pptx
@@ -2,22 +2,22 @@
 <file path=ppt/presentation.xml><?xml version="1.0" encoding="utf-8"?>
 <p:presentation xmlns:p="http://schemas.openxmlformats.org/presentationml/2006/main">
   <p:sldMasterIdLst>
-    <p:sldMasterId xmlns:r="http://schemas.openxmlformats.org/officeDocument/2006/relationships" id="2147483648" r:id="Rd397611971234bee"/>
+    <p:sldMasterId xmlns:r="http://schemas.openxmlformats.org/officeDocument/2006/relationships" id="2147483648" r:id="Ra644b56182c14b82"/>
   </p:sldMasterIdLst>
   <p:notesMasterIdLst>
-    <p:notesMasterId xmlns:r="http://schemas.openxmlformats.org/officeDocument/2006/relationships" r:id="Rf2d6df0bf5bb4530"/>
+    <p:notesMasterId xmlns:r="http://schemas.openxmlformats.org/officeDocument/2006/relationships" r:id="R76a472fe55ab4dc5"/>
   </p:notesMasterIdLst>
   <p:sldIdLst>
-    <p:sldId xmlns:r="http://schemas.openxmlformats.org/officeDocument/2006/relationships" id="256" r:id="R999b663856ce4b19"/>
-    <p:sldId xmlns:r="http://schemas.openxmlformats.org/officeDocument/2006/relationships" id="257" r:id="Rb4cec9bc05854bc3"/>
-    <p:sldId xmlns:r="http://schemas.openxmlformats.org/officeDocument/2006/relationships" id="258" r:id="Rce60731ce8fe4c5c"/>
-    <p:sldId xmlns:r="http://schemas.openxmlformats.org/officeDocument/2006/relationships" id="259" r:id="Rec9a232d19ed4085"/>
-    <p:sldId xmlns:r="http://schemas.openxmlformats.org/officeDocument/2006/relationships" id="260" r:id="Rbaba2930bf0e4f0d"/>
-    <p:sldId xmlns:r="http://schemas.openxmlformats.org/officeDocument/2006/relationships" id="261" r:id="Ra9baf7921b64450e"/>
-    <p:sldId xmlns:r="http://schemas.openxmlformats.org/officeDocument/2006/relationships" id="262" r:id="R12bc53b5ee214632"/>
-    <p:sldId xmlns:r="http://schemas.openxmlformats.org/officeDocument/2006/relationships" id="263" r:id="R5278da47c28545a1"/>
-    <p:sldId xmlns:r="http://schemas.openxmlformats.org/officeDocument/2006/relationships" id="264" r:id="R1ef46f9de1574d90"/>
-    <p:sldId xmlns:r="http://schemas.openxmlformats.org/officeDocument/2006/relationships" id="265" r:id="R77e0cbb6e4aa41ca"/>
+    <p:sldId xmlns:r="http://schemas.openxmlformats.org/officeDocument/2006/relationships" id="256" r:id="R8478e05eb7bf4a5e"/>
+    <p:sldId xmlns:r="http://schemas.openxmlformats.org/officeDocument/2006/relationships" id="257" r:id="R48ec1ddf62704bf6"/>
+    <p:sldId xmlns:r="http://schemas.openxmlformats.org/officeDocument/2006/relationships" id="258" r:id="Raa3e6aa1e31743eb"/>
+    <p:sldId xmlns:r="http://schemas.openxmlformats.org/officeDocument/2006/relationships" id="259" r:id="R524177e72786411b"/>
+    <p:sldId xmlns:r="http://schemas.openxmlformats.org/officeDocument/2006/relationships" id="260" r:id="Ra516421690064d4a"/>
+    <p:sldId xmlns:r="http://schemas.openxmlformats.org/officeDocument/2006/relationships" id="261" r:id="R5e591596bf1847d5"/>
+    <p:sldId xmlns:r="http://schemas.openxmlformats.org/officeDocument/2006/relationships" id="262" r:id="R0142a38768f6466c"/>
+    <p:sldId xmlns:r="http://schemas.openxmlformats.org/officeDocument/2006/relationships" id="263" r:id="R3aebc35854fc4d43"/>
+    <p:sldId xmlns:r="http://schemas.openxmlformats.org/officeDocument/2006/relationships" id="264" r:id="Ref4c0801adc64b1d"/>
+    <p:sldId xmlns:r="http://schemas.openxmlformats.org/officeDocument/2006/relationships" id="265" r:id="Raae73d58eed74dd3"/>
   </p:sldIdLst>
   <p:sldSz cx="12192000" cy="6858000"/>
   <p:notesSz cx="6858000" cy="9144000"/>
@@ -544,16 +544,7 @@
         <p:txBody>
           <a:bodyPr xmlns:a="http://schemas.openxmlformats.org/drawingml/2006/main"/>
           <a:lstStyle xmlns:a="http://schemas.openxmlformats.org/drawingml/2006/main"/>
-          <a:p xmlns:a="http://schemas.openxmlformats.org/drawingml/2006/main">
-            <a:r>
-              <a:t>Начать с границы темы: работа не про полный автопилот, а про слой надежности восприятия ADAS.</a:t>
-            </a:r>
-          </a:p>
-          <a:p xmlns:a="http://schemas.openxmlformats.org/drawingml/2006/main">
-            <a:r>
-              <a:t>Сказать, что итогом является воспроизводимый прототип, обученный на реальных KITTI-аннотациях.</a:t>
-            </a:r>
-          </a:p>
+          <a:p xmlns:a="http://schemas.openxmlformats.org/drawingml/2006/main"/>
         </p:txBody>
       </p:sp>
       <p:sp>
@@ -1294,7 +1285,7 @@
   </p:cSld>
   <p:clrMap bg1="lt1" tx1="dk1" bg2="lt2" tx2="dk2" accent1="accent1" accent2="accent2" accent3="accent3" accent4="accent4" accent5="accent5" accent6="accent6" hlink="hlink" folHlink="folHlink"/>
   <p:sldLayoutIdLst>
-    <p:sldLayoutId xmlns:r="http://schemas.openxmlformats.org/officeDocument/2006/relationships" id="2147483649" r:id="R37a8570c2bda43e3"/>
+    <p:sldLayoutId xmlns:r="http://schemas.openxmlformats.org/officeDocument/2006/relationships" id="2147483649" r:id="R422659b84faf4131"/>
   </p:sldLayoutIdLst>
   <p:txStyles>
     <p:titleStyle>
@@ -1840,687 +1831,35 @@
       <p:grpSpPr>
         <a:xfrm xmlns:a="http://schemas.openxmlformats.org/drawingml/2006/main"/>
       </p:grpSpPr>
-      <p:sp>
-        <p:nvSpPr>
-          <p:cNvPr id="1" name="">
-            <a:extLst xmlns:a="http://schemas.openxmlformats.org/drawingml/2006/main">
-              <a:ext uri="{FF2B5EF4-FFF2-40B4-BE49-F238E27FC236}">
-                <a16:creationId xmlns:a16="http://schemas.microsoft.com/office/drawing/2014/main" id="{6C9F5676-CE82-4A48-AB66-0EBFEC787C40}"/>
-              </a:ext>
-            </a:extLst>
-          </p:cNvPr>
-          <p:cNvSpPr>
-            <a:spLocks xmlns:a="http://schemas.openxmlformats.org/drawingml/2006/main" noGrp="1"/>
-          </p:cNvSpPr>
-          <p:nvPr/>
-        </p:nvSpPr>
-        <p:spPr>
-          <a:xfrm xmlns:a="http://schemas.openxmlformats.org/drawingml/2006/main">
-            <a:off x="304800" y="228600"/>
-            <a:ext cx="11582400" cy="6172200"/>
-          </a:xfrm>
-          <a:prstGeom xmlns:a="http://schemas.openxmlformats.org/drawingml/2006/main" prst="roundRect">
-            <a:avLst>
-              <a:gd name="adj" fmla="val 4321"/>
-            </a:avLst>
-          </a:prstGeom>
-          <a:solidFill xmlns:a="http://schemas.openxmlformats.org/drawingml/2006/main">
-            <a:srgbClr val="2730B6"/>
-          </a:solidFill>
-          <a:ln xmlns:a="http://schemas.openxmlformats.org/drawingml/2006/main" w="0">
-            <a:solidFill>
-              <a:srgbClr val="2730B6"/>
-            </a:solidFill>
-            <a:prstDash val="solid"/>
-          </a:ln>
-        </p:spPr>
-      </p:sp>
-      <p:sp>
-        <p:nvSpPr>
-          <p:cNvPr id="2" name="">
-            <a:extLst xmlns:a="http://schemas.openxmlformats.org/drawingml/2006/main">
-              <a:ext uri="{FF2B5EF4-FFF2-40B4-BE49-F238E27FC236}">
-                <a16:creationId xmlns:a16="http://schemas.microsoft.com/office/drawing/2014/main" id="{6FB5FA7A-E7BB-4860-AF3F-A417E9A6145F}"/>
-              </a:ext>
-            </a:extLst>
-          </p:cNvPr>
-          <p:cNvSpPr>
-            <a:spLocks xmlns:a="http://schemas.openxmlformats.org/drawingml/2006/main" noGrp="1"/>
-          </p:cNvSpPr>
-          <p:nvPr/>
-        </p:nvSpPr>
-        <p:spPr>
-          <a:xfrm xmlns:a="http://schemas.openxmlformats.org/drawingml/2006/main">
-            <a:off x="8667750" y="1238250"/>
-            <a:ext cx="2000250" cy="2381250"/>
-          </a:xfrm>
-          <a:prstGeom xmlns:a="http://schemas.openxmlformats.org/drawingml/2006/main" prst="roundRect">
-            <a:avLst>
-              <a:gd name="adj" fmla="val 8571"/>
-            </a:avLst>
-          </a:prstGeom>
-          <a:solidFill xmlns:a="http://schemas.openxmlformats.org/drawingml/2006/main">
-            <a:srgbClr val="3F49D4"/>
-          </a:solidFill>
-          <a:ln xmlns:a="http://schemas.openxmlformats.org/drawingml/2006/main" w="9525">
-            <a:solidFill>
-              <a:srgbClr val="4F58DF"/>
-            </a:solidFill>
-            <a:prstDash val="solid"/>
-          </a:ln>
-        </p:spPr>
-      </p:sp>
-      <p:sp>
-        <p:nvSpPr>
-          <p:cNvPr id="3" name="">
-            <a:extLst xmlns:a="http://schemas.openxmlformats.org/drawingml/2006/main">
-              <a:ext uri="{FF2B5EF4-FFF2-40B4-BE49-F238E27FC236}">
-                <a16:creationId xmlns:a16="http://schemas.microsoft.com/office/drawing/2014/main" id="{BF2C54D3-A6E8-4D5E-A14B-8266258EBA06}"/>
-              </a:ext>
-            </a:extLst>
-          </p:cNvPr>
-          <p:cNvSpPr>
-            <a:spLocks xmlns:a="http://schemas.openxmlformats.org/drawingml/2006/main" noGrp="1"/>
-          </p:cNvSpPr>
-          <p:nvPr/>
-        </p:nvSpPr>
-        <p:spPr>
-          <a:xfrm xmlns:a="http://schemas.openxmlformats.org/drawingml/2006/main">
-            <a:off x="9096375" y="2114550"/>
-            <a:ext cx="1162050" cy="876300"/>
-          </a:xfrm>
-          <a:prstGeom xmlns:a="http://schemas.openxmlformats.org/drawingml/2006/main" prst="roundRect">
-            <a:avLst>
-              <a:gd name="adj" fmla="val 23913"/>
-            </a:avLst>
-          </a:prstGeom>
-          <a:solidFill xmlns:a="http://schemas.openxmlformats.org/drawingml/2006/main">
-            <a:srgbClr val="F8FAFC"/>
-          </a:solidFill>
-          <a:ln xmlns:a="http://schemas.openxmlformats.org/drawingml/2006/main" w="0">
-            <a:solidFill>
-              <a:srgbClr val="F8FAFC"/>
-            </a:solidFill>
-            <a:prstDash val="solid"/>
-          </a:ln>
-        </p:spPr>
-      </p:sp>
-      <p:sp>
-        <p:nvSpPr>
-          <p:cNvPr id="4" name="">
-            <a:extLst xmlns:a="http://schemas.openxmlformats.org/drawingml/2006/main">
-              <a:ext uri="{FF2B5EF4-FFF2-40B4-BE49-F238E27FC236}">
-                <a16:creationId xmlns:a16="http://schemas.microsoft.com/office/drawing/2014/main" id="{7B3887F0-AEE5-4C1D-93B7-9A4C589F98B3}"/>
-              </a:ext>
-            </a:extLst>
-          </p:cNvPr>
-          <p:cNvSpPr>
-            <a:spLocks xmlns:a="http://schemas.openxmlformats.org/drawingml/2006/main" noGrp="1"/>
-          </p:cNvSpPr>
-          <p:nvPr/>
-        </p:nvSpPr>
-        <p:spPr>
-          <a:xfrm xmlns:a="http://schemas.openxmlformats.org/drawingml/2006/main">
-            <a:off x="781050" y="400050"/>
-            <a:ext cx="876300" cy="552450"/>
-          </a:xfrm>
-          <a:prstGeom xmlns:a="http://schemas.openxmlformats.org/drawingml/2006/main" prst="roundRect">
-            <a:avLst>
-              <a:gd name="adj" fmla="val 10345"/>
-            </a:avLst>
-          </a:prstGeom>
-          <a:noFill xmlns:a="http://schemas.openxmlformats.org/drawingml/2006/main"/>
-          <a:ln xmlns:a="http://schemas.openxmlformats.org/drawingml/2006/main" w="19050">
-            <a:solidFill>
-              <a:srgbClr val="FFFFFF"/>
-            </a:solidFill>
-            <a:prstDash val="solid"/>
-          </a:ln>
-        </p:spPr>
-        <p:txBody>
-          <a:bodyPr xmlns:a="http://schemas.openxmlformats.org/drawingml/2006/main"/>
-          <a:lstStyle xmlns:a="http://schemas.openxmlformats.org/drawingml/2006/main"/>
-          <a:p xmlns:a="http://schemas.openxmlformats.org/drawingml/2006/main">
-            <a:pPr algn="ctr">
-              <a:defRPr sz="1125" b="1">
-                <a:solidFill>
-                  <a:srgbClr val="FFFFFF"/>
-                </a:solidFill>
-              </a:defRPr>
-            </a:pPr>
-            <a:r>
-              <a:rPr sz="1125" b="1">
-                <a:solidFill>
-                  <a:srgbClr val="FFFFFF"/>
-                </a:solidFill>
-              </a:rPr>
-              <a:t>ТГУ</a:t>
-            </a:r>
-          </a:p>
-        </p:txBody>
-      </p:sp>
-      <p:sp>
-        <p:nvSpPr>
-          <p:cNvPr id="5" name="">
-            <a:extLst xmlns:a="http://schemas.openxmlformats.org/drawingml/2006/main">
-              <a:ext uri="{FF2B5EF4-FFF2-40B4-BE49-F238E27FC236}">
-                <a16:creationId xmlns:a16="http://schemas.microsoft.com/office/drawing/2014/main" id="{1EF0D77C-7E9A-4276-B768-328E7D7D82A2}"/>
-              </a:ext>
-            </a:extLst>
-          </p:cNvPr>
-          <p:cNvSpPr>
-            <a:spLocks xmlns:a="http://schemas.openxmlformats.org/drawingml/2006/main" noGrp="1"/>
-          </p:cNvSpPr>
-          <p:nvPr/>
-        </p:nvSpPr>
-        <p:spPr>
-          <a:xfrm xmlns:a="http://schemas.openxmlformats.org/drawingml/2006/main">
-            <a:off x="1752600" y="428625"/>
-            <a:ext cx="1809750" cy="552450"/>
-          </a:xfrm>
-          <a:prstGeom xmlns:a="http://schemas.openxmlformats.org/drawingml/2006/main" prst="rect">
-            <a:avLst/>
-          </a:prstGeom>
-          <a:noFill xmlns:a="http://schemas.openxmlformats.org/drawingml/2006/main"/>
-          <a:ln xmlns:a="http://schemas.openxmlformats.org/drawingml/2006/main" w="0">
-            <a:noFill/>
-            <a:prstDash val="solid"/>
-          </a:ln>
-        </p:spPr>
-        <p:txBody>
-          <a:bodyPr xmlns:a="http://schemas.openxmlformats.org/drawingml/2006/main"/>
-          <a:lstStyle xmlns:a="http://schemas.openxmlformats.org/drawingml/2006/main"/>
-          <a:p xmlns:a="http://schemas.openxmlformats.org/drawingml/2006/main">
-            <a:pPr algn="l">
-              <a:defRPr sz="975" b="1">
-                <a:solidFill>
-                  <a:srgbClr val="FFFFFF"/>
-                </a:solidFill>
-              </a:defRPr>
-            </a:pPr>
-            <a:r>
-              <a:rPr sz="975" b="1">
-                <a:solidFill>
-                  <a:srgbClr val="FFFFFF"/>
-                </a:solidFill>
-              </a:rPr>
-              <a:t>Томский</a:t>
-            </a:r>
-          </a:p>
-          <a:p xmlns:a="http://schemas.openxmlformats.org/drawingml/2006/main">
-            <a:pPr algn="l">
-              <a:defRPr sz="975" b="1">
-                <a:solidFill>
-                  <a:srgbClr val="FFFFFF"/>
-                </a:solidFill>
-              </a:defRPr>
-            </a:pPr>
-            <a:r>
-              <a:rPr sz="975" b="1">
-                <a:solidFill>
-                  <a:srgbClr val="FFFFFF"/>
-                </a:solidFill>
-              </a:rPr>
-              <a:t>государственный</a:t>
-            </a:r>
-          </a:p>
-          <a:p xmlns:a="http://schemas.openxmlformats.org/drawingml/2006/main">
-            <a:pPr algn="l">
-              <a:defRPr sz="975" b="1">
-                <a:solidFill>
-                  <a:srgbClr val="FFFFFF"/>
-                </a:solidFill>
-              </a:defRPr>
-            </a:pPr>
-            <a:r>
-              <a:rPr sz="975" b="1">
-                <a:solidFill>
-                  <a:srgbClr val="FFFFFF"/>
-                </a:solidFill>
-              </a:rPr>
-              <a:t>университет</a:t>
-            </a:r>
-          </a:p>
-        </p:txBody>
-      </p:sp>
-      <p:sp>
-        <p:nvSpPr>
-          <p:cNvPr id="6" name="">
-            <a:extLst xmlns:a="http://schemas.openxmlformats.org/drawingml/2006/main">
-              <a:ext uri="{FF2B5EF4-FFF2-40B4-BE49-F238E27FC236}">
-                <a16:creationId xmlns:a16="http://schemas.microsoft.com/office/drawing/2014/main" id="{150A440D-D255-4C77-A32C-DE91CCB9A1BC}"/>
-              </a:ext>
-            </a:extLst>
-          </p:cNvPr>
-          <p:cNvSpPr>
-            <a:spLocks xmlns:a="http://schemas.openxmlformats.org/drawingml/2006/main" noGrp="1"/>
-          </p:cNvSpPr>
-          <p:nvPr/>
-        </p:nvSpPr>
-        <p:spPr>
-          <a:xfrm xmlns:a="http://schemas.openxmlformats.org/drawingml/2006/main">
-            <a:off x="3886200" y="400050"/>
-            <a:ext cx="876300" cy="552450"/>
-          </a:xfrm>
-          <a:prstGeom xmlns:a="http://schemas.openxmlformats.org/drawingml/2006/main" prst="roundRect">
-            <a:avLst>
-              <a:gd name="adj" fmla="val 10345"/>
-            </a:avLst>
-          </a:prstGeom>
-          <a:noFill xmlns:a="http://schemas.openxmlformats.org/drawingml/2006/main"/>
-          <a:ln xmlns:a="http://schemas.openxmlformats.org/drawingml/2006/main" w="19050">
-            <a:solidFill>
-              <a:srgbClr val="FFFFFF"/>
-            </a:solidFill>
-            <a:prstDash val="solid"/>
-          </a:ln>
-        </p:spPr>
-        <p:txBody>
-          <a:bodyPr xmlns:a="http://schemas.openxmlformats.org/drawingml/2006/main"/>
-          <a:lstStyle xmlns:a="http://schemas.openxmlformats.org/drawingml/2006/main"/>
-          <a:p xmlns:a="http://schemas.openxmlformats.org/drawingml/2006/main">
-            <a:pPr algn="ctr">
-              <a:defRPr sz="1125" b="1">
-                <a:solidFill>
-                  <a:srgbClr val="FFFFFF"/>
-                </a:solidFill>
-              </a:defRPr>
-            </a:pPr>
-            <a:r>
-              <a:rPr sz="1125" b="1">
-                <a:solidFill>
-                  <a:srgbClr val="FFFFFF"/>
-                </a:solidFill>
-              </a:rPr>
-              <a:t>IDO</a:t>
-            </a:r>
-          </a:p>
-        </p:txBody>
-      </p:sp>
-      <p:sp>
-        <p:nvSpPr>
-          <p:cNvPr id="7" name="">
-            <a:extLst xmlns:a="http://schemas.openxmlformats.org/drawingml/2006/main">
-              <a:ext uri="{FF2B5EF4-FFF2-40B4-BE49-F238E27FC236}">
-                <a16:creationId xmlns:a16="http://schemas.microsoft.com/office/drawing/2014/main" id="{07227BBE-81B8-44F3-AAC8-98B0B9991D4C}"/>
-              </a:ext>
-            </a:extLst>
-          </p:cNvPr>
-          <p:cNvSpPr>
-            <a:spLocks xmlns:a="http://schemas.openxmlformats.org/drawingml/2006/main" noGrp="1"/>
-          </p:cNvSpPr>
-          <p:nvPr/>
-        </p:nvSpPr>
-        <p:spPr>
-          <a:xfrm xmlns:a="http://schemas.openxmlformats.org/drawingml/2006/main">
-            <a:off x="723900" y="1504950"/>
-            <a:ext cx="7334250" cy="1428750"/>
-          </a:xfrm>
-          <a:prstGeom xmlns:a="http://schemas.openxmlformats.org/drawingml/2006/main" prst="rect">
-            <a:avLst/>
-          </a:prstGeom>
-          <a:noFill xmlns:a="http://schemas.openxmlformats.org/drawingml/2006/main"/>
-          <a:ln xmlns:a="http://schemas.openxmlformats.org/drawingml/2006/main" w="0">
-            <a:noFill/>
-            <a:prstDash val="solid"/>
-          </a:ln>
-        </p:spPr>
-        <p:txBody>
-          <a:bodyPr xmlns:a="http://schemas.openxmlformats.org/drawingml/2006/main"/>
-          <a:lstStyle xmlns:a="http://schemas.openxmlformats.org/drawingml/2006/main"/>
-          <a:p xmlns:a="http://schemas.openxmlformats.org/drawingml/2006/main">
-            <a:pPr algn="l">
-              <a:defRPr sz="2550" b="1">
-                <a:solidFill>
-                  <a:srgbClr val="FFFFFF"/>
-                </a:solidFill>
-              </a:defRPr>
-            </a:pPr>
-            <a:r>
-              <a:rPr sz="2550" b="1">
-                <a:solidFill>
-                  <a:srgbClr val="FFFFFF"/>
-                </a:solidFill>
-              </a:rPr>
-              <a:t>Разработка методов обнаружения и обработки редких и критических сценариев в мультимодальном восприятии систем ADAS</a:t>
-            </a:r>
-          </a:p>
-        </p:txBody>
-      </p:sp>
-      <p:sp>
-        <p:nvSpPr>
-          <p:cNvPr id="8" name="">
-            <a:extLst xmlns:a="http://schemas.openxmlformats.org/drawingml/2006/main">
-              <a:ext uri="{FF2B5EF4-FFF2-40B4-BE49-F238E27FC236}">
-                <a16:creationId xmlns:a16="http://schemas.microsoft.com/office/drawing/2014/main" id="{15CE670B-A3ED-4EB9-B844-32F2199D654A}"/>
-              </a:ext>
-            </a:extLst>
-          </p:cNvPr>
-          <p:cNvSpPr>
-            <a:spLocks xmlns:a="http://schemas.openxmlformats.org/drawingml/2006/main" noGrp="1"/>
-          </p:cNvSpPr>
-          <p:nvPr/>
-        </p:nvSpPr>
-        <p:spPr>
-          <a:xfrm xmlns:a="http://schemas.openxmlformats.org/drawingml/2006/main">
-            <a:off x="723900" y="3067050"/>
-            <a:ext cx="7239000" cy="400050"/>
-          </a:xfrm>
-          <a:prstGeom xmlns:a="http://schemas.openxmlformats.org/drawingml/2006/main" prst="rect">
-            <a:avLst/>
-          </a:prstGeom>
-          <a:noFill xmlns:a="http://schemas.openxmlformats.org/drawingml/2006/main"/>
-          <a:ln xmlns:a="http://schemas.openxmlformats.org/drawingml/2006/main" w="0">
-            <a:noFill/>
-            <a:prstDash val="solid"/>
-          </a:ln>
-        </p:spPr>
-        <p:txBody>
-          <a:bodyPr xmlns:a="http://schemas.openxmlformats.org/drawingml/2006/main"/>
-          <a:lstStyle xmlns:a="http://schemas.openxmlformats.org/drawingml/2006/main"/>
-          <a:p xmlns:a="http://schemas.openxmlformats.org/drawingml/2006/main">
-            <a:pPr algn="l">
-              <a:defRPr sz="1800" b="0">
-                <a:solidFill>
-                  <a:srgbClr val="DBEAFE"/>
-                </a:solidFill>
-              </a:defRPr>
-            </a:pPr>
-            <a:r>
-              <a:rPr sz="1800" b="0">
-                <a:solidFill>
-                  <a:srgbClr val="DBEAFE"/>
-                </a:solidFill>
-              </a:rPr>
-              <a:t>для повышения безопасности в сложных погодных и дорожных условиях</a:t>
-            </a:r>
-          </a:p>
-        </p:txBody>
-      </p:sp>
-      <p:sp>
-        <p:nvSpPr>
-          <p:cNvPr id="9" name="">
-            <a:extLst xmlns:a="http://schemas.openxmlformats.org/drawingml/2006/main">
-              <a:ext uri="{FF2B5EF4-FFF2-40B4-BE49-F238E27FC236}">
-                <a16:creationId xmlns:a16="http://schemas.microsoft.com/office/drawing/2014/main" id="{F6CA0A0A-19C9-4108-A771-9C95E4B22011}"/>
-              </a:ext>
-            </a:extLst>
-          </p:cNvPr>
-          <p:cNvSpPr>
-            <a:spLocks xmlns:a="http://schemas.openxmlformats.org/drawingml/2006/main" noGrp="1"/>
-          </p:cNvSpPr>
-          <p:nvPr/>
-        </p:nvSpPr>
-        <p:spPr>
-          <a:xfrm xmlns:a="http://schemas.openxmlformats.org/drawingml/2006/main">
-            <a:off x="723900" y="4095750"/>
-            <a:ext cx="4762500" cy="1219200"/>
-          </a:xfrm>
-          <a:prstGeom xmlns:a="http://schemas.openxmlformats.org/drawingml/2006/main" prst="roundRect">
-            <a:avLst>
-              <a:gd name="adj" fmla="val 6250"/>
-            </a:avLst>
-          </a:prstGeom>
-          <a:solidFill xmlns:a="http://schemas.openxmlformats.org/drawingml/2006/main">
-            <a:srgbClr val="FFFFFF"/>
-          </a:solidFill>
-          <a:ln xmlns:a="http://schemas.openxmlformats.org/drawingml/2006/main" w="11430">
-            <a:solidFill>
-              <a:srgbClr val="FFFFFF"/>
-            </a:solidFill>
-            <a:prstDash val="solid"/>
-          </a:ln>
-        </p:spPr>
-        <p:txBody>
-          <a:bodyPr xmlns:a="http://schemas.openxmlformats.org/drawingml/2006/main"/>
-          <a:lstStyle xmlns:a="http://schemas.openxmlformats.org/drawingml/2006/main"/>
-          <a:p xmlns:a="http://schemas.openxmlformats.org/drawingml/2006/main">
-            <a:pPr algn="ctr">
-              <a:defRPr sz="1575" b="1">
-                <a:solidFill>
-                  <a:srgbClr val="111827"/>
-                </a:solidFill>
-              </a:defRPr>
-            </a:pPr>
-            <a:r>
-              <a:rPr sz="1575" b="1">
-                <a:solidFill>
-                  <a:srgbClr val="111827"/>
-                </a:solidFill>
-              </a:rPr>
-              <a:t>Марьяновский Владислав Андреевич</a:t>
-            </a:r>
-          </a:p>
-          <a:p xmlns:a="http://schemas.openxmlformats.org/drawingml/2006/main">
-            <a:pPr algn="ctr">
-              <a:defRPr sz="1575" b="1">
-                <a:solidFill>
-                  <a:srgbClr val="111827"/>
-                </a:solidFill>
-              </a:defRPr>
-            </a:pPr>
-            <a:r>
-              <a:rPr sz="1575" b="1">
-                <a:solidFill>
-                  <a:srgbClr val="111827"/>
-                </a:solidFill>
-              </a:rPr>
-              <a:t>Группа 292405-1</a:t>
-            </a:r>
-          </a:p>
-          <a:p xmlns:a="http://schemas.openxmlformats.org/drawingml/2006/main">
-            <a:pPr algn="ctr">
-              <a:defRPr sz="1575" b="1">
-                <a:solidFill>
-                  <a:srgbClr val="111827"/>
-                </a:solidFill>
-              </a:defRPr>
-            </a:pPr>
-            <a:r>
-              <a:rPr sz="1575" b="1">
-                <a:solidFill>
-                  <a:srgbClr val="111827"/>
-                </a:solidFill>
-              </a:rPr>
-              <a:t>09.04.03 Прикладная информатика</a:t>
-            </a:r>
-          </a:p>
-        </p:txBody>
-      </p:sp>
-      <p:sp>
-        <p:nvSpPr>
-          <p:cNvPr id="10" name="">
-            <a:extLst xmlns:a="http://schemas.openxmlformats.org/drawingml/2006/main">
-              <a:ext uri="{FF2B5EF4-FFF2-40B4-BE49-F238E27FC236}">
-                <a16:creationId xmlns:a16="http://schemas.microsoft.com/office/drawing/2014/main" id="{C0443455-B291-4B6C-A4A8-09B690A877E8}"/>
-              </a:ext>
-            </a:extLst>
-          </p:cNvPr>
-          <p:cNvSpPr>
-            <a:spLocks xmlns:a="http://schemas.openxmlformats.org/drawingml/2006/main" noGrp="1"/>
-          </p:cNvSpPr>
-          <p:nvPr/>
-        </p:nvSpPr>
-        <p:spPr>
-          <a:xfrm xmlns:a="http://schemas.openxmlformats.org/drawingml/2006/main">
-            <a:off x="6000750" y="4095750"/>
-            <a:ext cx="4953000" cy="1219200"/>
-          </a:xfrm>
-          <a:prstGeom xmlns:a="http://schemas.openxmlformats.org/drawingml/2006/main" prst="roundRect">
-            <a:avLst>
-              <a:gd name="adj" fmla="val 6250"/>
-            </a:avLst>
-          </a:prstGeom>
-          <a:solidFill xmlns:a="http://schemas.openxmlformats.org/drawingml/2006/main">
-            <a:srgbClr val="EEF2FF"/>
-          </a:solidFill>
-          <a:ln xmlns:a="http://schemas.openxmlformats.org/drawingml/2006/main" w="11430">
-            <a:solidFill>
-              <a:srgbClr val="FFFFFF"/>
-            </a:solidFill>
-            <a:prstDash val="solid"/>
-          </a:ln>
-        </p:spPr>
-        <p:txBody>
-          <a:bodyPr xmlns:a="http://schemas.openxmlformats.org/drawingml/2006/main"/>
-          <a:lstStyle xmlns:a="http://schemas.openxmlformats.org/drawingml/2006/main"/>
-          <a:p xmlns:a="http://schemas.openxmlformats.org/drawingml/2006/main">
-            <a:pPr algn="ctr">
-              <a:defRPr sz="1575" b="1">
-                <a:solidFill>
-                  <a:srgbClr val="111827"/>
-                </a:solidFill>
-              </a:defRPr>
-            </a:pPr>
-            <a:r>
-              <a:rPr sz="1575" b="1">
-                <a:solidFill>
-                  <a:srgbClr val="111827"/>
-                </a:solidFill>
-              </a:rPr>
-              <a:t>НИ ТГУ · Институт дистанционного образования</a:t>
-            </a:r>
-          </a:p>
-          <a:p xmlns:a="http://schemas.openxmlformats.org/drawingml/2006/main">
-            <a:pPr algn="ctr">
-              <a:defRPr sz="1575" b="1">
-                <a:solidFill>
-                  <a:srgbClr val="111827"/>
-                </a:solidFill>
-              </a:defRPr>
-            </a:pPr>
-            <a:r>
-              <a:rPr sz="1575" b="1">
-                <a:solidFill>
-                  <a:srgbClr val="111827"/>
-                </a:solidFill>
-              </a:rPr>
-              <a:t>Профиль: компьютерное зрение и нейронные сети</a:t>
-            </a:r>
-          </a:p>
-          <a:p xmlns:a="http://schemas.openxmlformats.org/drawingml/2006/main">
-            <a:pPr algn="ctr">
-              <a:defRPr sz="1575" b="1">
-                <a:solidFill>
-                  <a:srgbClr val="111827"/>
-                </a:solidFill>
-              </a:defRPr>
-            </a:pPr>
-            <a:r>
-              <a:rPr sz="1575" b="1">
-                <a:solidFill>
-                  <a:srgbClr val="111827"/>
-                </a:solidFill>
-              </a:rPr>
-              <a:t>Томск · 2026</a:t>
-            </a:r>
-          </a:p>
-        </p:txBody>
-      </p:sp>
-      <p:sp>
-        <p:nvSpPr>
-          <p:cNvPr id="11" name="">
-            <a:extLst xmlns:a="http://schemas.openxmlformats.org/drawingml/2006/main">
-              <a:ext uri="{FF2B5EF4-FFF2-40B4-BE49-F238E27FC236}">
-                <a16:creationId xmlns:a16="http://schemas.microsoft.com/office/drawing/2014/main" id="{DEC9D754-9AC2-4B45-8231-25B06AC30D6C}"/>
-              </a:ext>
-            </a:extLst>
-          </p:cNvPr>
-          <p:cNvSpPr>
-            <a:spLocks xmlns:a="http://schemas.openxmlformats.org/drawingml/2006/main" noGrp="1"/>
-          </p:cNvSpPr>
-          <p:nvPr/>
-        </p:nvSpPr>
-        <p:spPr>
-          <a:xfrm xmlns:a="http://schemas.openxmlformats.org/drawingml/2006/main">
-            <a:off x="571500" y="6477000"/>
-            <a:ext cx="4000500" cy="228600"/>
-          </a:xfrm>
-          <a:prstGeom xmlns:a="http://schemas.openxmlformats.org/drawingml/2006/main" prst="rect">
-            <a:avLst/>
-          </a:prstGeom>
-          <a:noFill xmlns:a="http://schemas.openxmlformats.org/drawingml/2006/main"/>
-          <a:ln xmlns:a="http://schemas.openxmlformats.org/drawingml/2006/main" w="0">
-            <a:noFill/>
-            <a:prstDash val="solid"/>
-          </a:ln>
-        </p:spPr>
-        <p:txBody>
-          <a:bodyPr xmlns:a="http://schemas.openxmlformats.org/drawingml/2006/main"/>
-          <a:lstStyle xmlns:a="http://schemas.openxmlformats.org/drawingml/2006/main"/>
-          <a:p xmlns:a="http://schemas.openxmlformats.org/drawingml/2006/main">
-            <a:pPr algn="l">
-              <a:defRPr sz="975" b="0">
-                <a:solidFill>
-                  <a:srgbClr val="DBEAFE"/>
-                </a:solidFill>
-              </a:defRPr>
-            </a:pPr>
-            <a:r>
-              <a:rPr sz="975" b="0">
-                <a:solidFill>
-                  <a:srgbClr val="DBEAFE"/>
-                </a:solidFill>
-              </a:rPr>
-              <a:t>ADAS ScenarioGuard · ВКР · 2026</a:t>
-            </a:r>
-          </a:p>
-        </p:txBody>
-      </p:sp>
-      <p:sp>
-        <p:nvSpPr>
-          <p:cNvPr id="12" name="">
-            <a:extLst xmlns:a="http://schemas.openxmlformats.org/drawingml/2006/main">
-              <a:ext uri="{FF2B5EF4-FFF2-40B4-BE49-F238E27FC236}">
-                <a16:creationId xmlns:a16="http://schemas.microsoft.com/office/drawing/2014/main" id="{4ECEF874-623E-4B55-B7F5-6D554DC05297}"/>
-              </a:ext>
-            </a:extLst>
-          </p:cNvPr>
-          <p:cNvSpPr>
-            <a:spLocks xmlns:a="http://schemas.openxmlformats.org/drawingml/2006/main" noGrp="1"/>
-          </p:cNvSpPr>
-          <p:nvPr/>
-        </p:nvSpPr>
-        <p:spPr>
-          <a:xfrm xmlns:a="http://schemas.openxmlformats.org/drawingml/2006/main">
-            <a:off x="11239500" y="6477000"/>
-            <a:ext cx="381000" cy="228600"/>
-          </a:xfrm>
-          <a:prstGeom xmlns:a="http://schemas.openxmlformats.org/drawingml/2006/main" prst="rect">
-            <a:avLst/>
-          </a:prstGeom>
-          <a:noFill xmlns:a="http://schemas.openxmlformats.org/drawingml/2006/main"/>
-          <a:ln xmlns:a="http://schemas.openxmlformats.org/drawingml/2006/main" w="0">
-            <a:noFill/>
-            <a:prstDash val="solid"/>
-          </a:ln>
-        </p:spPr>
-        <p:txBody>
-          <a:bodyPr xmlns:a="http://schemas.openxmlformats.org/drawingml/2006/main"/>
-          <a:lstStyle xmlns:a="http://schemas.openxmlformats.org/drawingml/2006/main"/>
-          <a:p xmlns:a="http://schemas.openxmlformats.org/drawingml/2006/main">
-            <a:pPr algn="r">
-              <a:defRPr sz="975" b="0">
-                <a:solidFill>
-                  <a:srgbClr val="DBEAFE"/>
-                </a:solidFill>
-              </a:defRPr>
-            </a:pPr>
-            <a:r>
-              <a:rPr sz="975" b="0">
-                <a:solidFill>
-                  <a:srgbClr val="DBEAFE"/>
-                </a:solidFill>
-              </a:rPr>
-              <a:t>1</a:t>
-            </a:r>
-          </a:p>
-        </p:txBody>
-      </p:sp>
+      <p:pic>
+        <p:nvPicPr>
+          <p:cNvPr id="2" name=""/>
+          <p:cNvPicPr>
+            <a:picLocks xmlns:a="http://schemas.openxmlformats.org/drawingml/2006/main" noChangeAspect="1"/>
+          </p:cNvPicPr>
+          <p:nvPr/>
+        </p:nvPicPr>
+        <p:blipFill>
+          <a:blip xmlns:r="http://schemas.openxmlformats.org/officeDocument/2006/relationships" xmlns:a="http://schemas.openxmlformats.org/drawingml/2006/main" r:embed="R3c6034a429e14509"/>
+          <a:srcRect xmlns:a="http://schemas.openxmlformats.org/drawingml/2006/main" l="7" t="0" r="7" b="0"/>
+          <a:stretch xmlns:a="http://schemas.openxmlformats.org/drawingml/2006/main">
+            <a:fillRect l="0" t="0" r="0" b="0"/>
+          </a:stretch>
+        </p:blipFill>
+        <p:spPr>
+          <a:xfrm xmlns:a="http://schemas.openxmlformats.org/drawingml/2006/main">
+            <a:off x="0" y="0"/>
+            <a:ext cx="12192000" cy="6858000"/>
+          </a:xfrm>
+          <a:prstGeom xmlns:a="http://schemas.openxmlformats.org/drawingml/2006/main" prst="rect">
+            <a:avLst/>
+          </a:prstGeom>
+        </p:spPr>
+      </p:pic>
     </p:spTree>
     <p:extLst>
       <p:ext uri="{BB962C8B-B14F-4D97-AF65-F5344CB8AC3E}">
-        <p14:creationId xmlns:p14="http://schemas.microsoft.com/office/powerpoint/2010/main" val="1319114866"/>
+        <p14:creationId xmlns:p14="http://schemas.microsoft.com/office/powerpoint/2010/main" val="626212809"/>
       </p:ext>
     </p:extLst>
   </p:cSld>
@@ -2551,7 +1890,7 @@
           <p:cNvPr id="1" name="">
             <a:extLst xmlns:a="http://schemas.openxmlformats.org/drawingml/2006/main">
               <a:ext uri="{FF2B5EF4-FFF2-40B4-BE49-F238E27FC236}">
-                <a16:creationId xmlns:a16="http://schemas.microsoft.com/office/drawing/2014/main" id="{D39129F0-5C86-40BE-B01C-1336466A3753}"/>
+                <a16:creationId xmlns:a16="http://schemas.microsoft.com/office/drawing/2014/main" id="{A03F390F-CE89-460F-B094-F63FE9758B29}"/>
               </a:ext>
             </a:extLst>
           </p:cNvPr>
@@ -2584,7 +1923,7 @@
           <p:cNvPr id="2" name="">
             <a:extLst xmlns:a="http://schemas.openxmlformats.org/drawingml/2006/main">
               <a:ext uri="{FF2B5EF4-FFF2-40B4-BE49-F238E27FC236}">
-                <a16:creationId xmlns:a16="http://schemas.microsoft.com/office/drawing/2014/main" id="{96EC2515-0D5A-4D44-AFA1-E99FB8AB571E}"/>
+                <a16:creationId xmlns:a16="http://schemas.microsoft.com/office/drawing/2014/main" id="{63E4F2B6-F9F1-453D-B2D2-188C13704793}"/>
               </a:ext>
             </a:extLst>
           </p:cNvPr>
@@ -2617,7 +1956,7 @@
           <p:cNvPr id="3" name="">
             <a:extLst xmlns:a="http://schemas.openxmlformats.org/drawingml/2006/main">
               <a:ext uri="{FF2B5EF4-FFF2-40B4-BE49-F238E27FC236}">
-                <a16:creationId xmlns:a16="http://schemas.microsoft.com/office/drawing/2014/main" id="{4FB9B5B4-A54E-4E93-B591-81EA21249BA5}"/>
+                <a16:creationId xmlns:a16="http://schemas.microsoft.com/office/drawing/2014/main" id="{81A6B097-EFFD-41E7-A9FC-240F0DE86114}"/>
               </a:ext>
             </a:extLst>
           </p:cNvPr>
@@ -2667,7 +2006,7 @@
           <p:cNvPr id="4" name="">
             <a:extLst xmlns:a="http://schemas.openxmlformats.org/drawingml/2006/main">
               <a:ext uri="{FF2B5EF4-FFF2-40B4-BE49-F238E27FC236}">
-                <a16:creationId xmlns:a16="http://schemas.microsoft.com/office/drawing/2014/main" id="{BDC7F382-C580-4F85-95BD-92FAD7D23FF1}"/>
+                <a16:creationId xmlns:a16="http://schemas.microsoft.com/office/drawing/2014/main" id="{06670AC9-716D-4A7A-90B7-D4B5F39BE09E}"/>
               </a:ext>
             </a:extLst>
           </p:cNvPr>
@@ -2717,7 +2056,7 @@
           <p:cNvPr id="5" name="">
             <a:extLst xmlns:a="http://schemas.openxmlformats.org/drawingml/2006/main">
               <a:ext uri="{FF2B5EF4-FFF2-40B4-BE49-F238E27FC236}">
-                <a16:creationId xmlns:a16="http://schemas.microsoft.com/office/drawing/2014/main" id="{46343D92-A897-4690-AB52-82663C942098}"/>
+                <a16:creationId xmlns:a16="http://schemas.microsoft.com/office/drawing/2014/main" id="{70600F8E-8B29-41F9-B8C7-C362F066B8A4}"/>
               </a:ext>
             </a:extLst>
           </p:cNvPr>
@@ -2767,7 +2106,7 @@
           <p:cNvPr id="6" name="">
             <a:extLst xmlns:a="http://schemas.openxmlformats.org/drawingml/2006/main">
               <a:ext uri="{FF2B5EF4-FFF2-40B4-BE49-F238E27FC236}">
-                <a16:creationId xmlns:a16="http://schemas.microsoft.com/office/drawing/2014/main" id="{BB3D39B4-E099-48EA-9C89-8C4008DD300F}"/>
+                <a16:creationId xmlns:a16="http://schemas.microsoft.com/office/drawing/2014/main" id="{0CE5A1A3-10BD-4D02-AA69-3F5722DCCC2D}"/>
               </a:ext>
             </a:extLst>
           </p:cNvPr>
@@ -2800,7 +2139,7 @@
           <p:cNvPr id="7" name="">
             <a:extLst xmlns:a="http://schemas.openxmlformats.org/drawingml/2006/main">
               <a:ext uri="{FF2B5EF4-FFF2-40B4-BE49-F238E27FC236}">
-                <a16:creationId xmlns:a16="http://schemas.microsoft.com/office/drawing/2014/main" id="{11431CF0-CDD8-4D2E-BF16-5249D9A17EE5}"/>
+                <a16:creationId xmlns:a16="http://schemas.microsoft.com/office/drawing/2014/main" id="{8326F67C-26B6-4B3C-9679-AEB8D8C70932}"/>
               </a:ext>
             </a:extLst>
           </p:cNvPr>
@@ -2873,7 +2212,7 @@
           <p:cNvPr id="8" name="">
             <a:extLst xmlns:a="http://schemas.openxmlformats.org/drawingml/2006/main">
               <a:ext uri="{FF2B5EF4-FFF2-40B4-BE49-F238E27FC236}">
-                <a16:creationId xmlns:a16="http://schemas.microsoft.com/office/drawing/2014/main" id="{02DA9538-AAC0-4A03-9587-32EBAC82A24E}"/>
+                <a16:creationId xmlns:a16="http://schemas.microsoft.com/office/drawing/2014/main" id="{30FA06B1-C7B8-44F0-A9CA-99AA97D69A47}"/>
               </a:ext>
             </a:extLst>
           </p:cNvPr>
@@ -2946,7 +2285,7 @@
           <p:cNvPr id="9" name="">
             <a:extLst xmlns:a="http://schemas.openxmlformats.org/drawingml/2006/main">
               <a:ext uri="{FF2B5EF4-FFF2-40B4-BE49-F238E27FC236}">
-                <a16:creationId xmlns:a16="http://schemas.microsoft.com/office/drawing/2014/main" id="{46F9B332-E035-43D4-AAF7-200268C2FC7F}"/>
+                <a16:creationId xmlns:a16="http://schemas.microsoft.com/office/drawing/2014/main" id="{2200AF00-A6DA-42C5-ADE7-61CCDBB7276B}"/>
               </a:ext>
             </a:extLst>
           </p:cNvPr>
@@ -3019,7 +2358,7 @@
           <p:cNvPr id="10" name="">
             <a:extLst xmlns:a="http://schemas.openxmlformats.org/drawingml/2006/main">
               <a:ext uri="{FF2B5EF4-FFF2-40B4-BE49-F238E27FC236}">
-                <a16:creationId xmlns:a16="http://schemas.microsoft.com/office/drawing/2014/main" id="{103668FD-F210-48A6-96C3-D1C8D16E6518}"/>
+                <a16:creationId xmlns:a16="http://schemas.microsoft.com/office/drawing/2014/main" id="{47152A31-5B13-48EF-A677-5F715927DD21}"/>
               </a:ext>
             </a:extLst>
           </p:cNvPr>
@@ -3069,7 +2408,7 @@
           <p:cNvPr id="11" name="">
             <a:extLst xmlns:a="http://schemas.openxmlformats.org/drawingml/2006/main">
               <a:ext uri="{FF2B5EF4-FFF2-40B4-BE49-F238E27FC236}">
-                <a16:creationId xmlns:a16="http://schemas.microsoft.com/office/drawing/2014/main" id="{875AE1FB-A980-4035-88BC-C09847B7692F}"/>
+                <a16:creationId xmlns:a16="http://schemas.microsoft.com/office/drawing/2014/main" id="{F40221D7-32F9-4B41-AAE5-ECBE8632F9A6}"/>
               </a:ext>
             </a:extLst>
           </p:cNvPr>
@@ -3119,7 +2458,7 @@
           <p:cNvPr id="12" name="">
             <a:extLst xmlns:a="http://schemas.openxmlformats.org/drawingml/2006/main">
               <a:ext uri="{FF2B5EF4-FFF2-40B4-BE49-F238E27FC236}">
-                <a16:creationId xmlns:a16="http://schemas.microsoft.com/office/drawing/2014/main" id="{EE89F70D-911A-4CFB-926B-863508C12E5C}"/>
+                <a16:creationId xmlns:a16="http://schemas.microsoft.com/office/drawing/2014/main" id="{1A002555-7FA2-4283-9D8F-409F3EBE4E2D}"/>
               </a:ext>
             </a:extLst>
           </p:cNvPr>
@@ -3169,7 +2508,7 @@
           <p:cNvPr id="13" name="">
             <a:extLst xmlns:a="http://schemas.openxmlformats.org/drawingml/2006/main">
               <a:ext uri="{FF2B5EF4-FFF2-40B4-BE49-F238E27FC236}">
-                <a16:creationId xmlns:a16="http://schemas.microsoft.com/office/drawing/2014/main" id="{A44A3E52-0754-450C-8F98-24B0CF9594DC}"/>
+                <a16:creationId xmlns:a16="http://schemas.microsoft.com/office/drawing/2014/main" id="{E7B87548-4B95-4BED-8715-F9F12A5ECF9B}"/>
               </a:ext>
             </a:extLst>
           </p:cNvPr>
@@ -3219,7 +2558,7 @@
           <p:cNvPr id="14" name="">
             <a:extLst xmlns:a="http://schemas.openxmlformats.org/drawingml/2006/main">
               <a:ext uri="{FF2B5EF4-FFF2-40B4-BE49-F238E27FC236}">
-                <a16:creationId xmlns:a16="http://schemas.microsoft.com/office/drawing/2014/main" id="{8EE9EC82-395C-4A7F-A0A8-0B95E2F2915E}"/>
+                <a16:creationId xmlns:a16="http://schemas.microsoft.com/office/drawing/2014/main" id="{D7523F2D-A24A-4CE6-ABA8-D96647E59DA3}"/>
               </a:ext>
             </a:extLst>
           </p:cNvPr>
@@ -3269,7 +2608,7 @@
           <p:cNvPr id="15" name="">
             <a:extLst xmlns:a="http://schemas.openxmlformats.org/drawingml/2006/main">
               <a:ext uri="{FF2B5EF4-FFF2-40B4-BE49-F238E27FC236}">
-                <a16:creationId xmlns:a16="http://schemas.microsoft.com/office/drawing/2014/main" id="{81C0E639-3184-4DB9-B794-EB68E08444D8}"/>
+                <a16:creationId xmlns:a16="http://schemas.microsoft.com/office/drawing/2014/main" id="{B03BBDE1-0F16-4D8B-9BD8-D9D60413ABE9}"/>
               </a:ext>
             </a:extLst>
           </p:cNvPr>
@@ -3319,7 +2658,7 @@
           <p:cNvPr id="16" name="">
             <a:extLst xmlns:a="http://schemas.openxmlformats.org/drawingml/2006/main">
               <a:ext uri="{FF2B5EF4-FFF2-40B4-BE49-F238E27FC236}">
-                <a16:creationId xmlns:a16="http://schemas.microsoft.com/office/drawing/2014/main" id="{38883269-DBD2-4815-A187-787FB2919A89}"/>
+                <a16:creationId xmlns:a16="http://schemas.microsoft.com/office/drawing/2014/main" id="{730D0954-3B77-4A1B-A9BF-4F73C7F1DDEA}"/>
               </a:ext>
             </a:extLst>
           </p:cNvPr>
@@ -3369,7 +2708,7 @@
           <p:cNvPr id="17" name="">
             <a:extLst xmlns:a="http://schemas.openxmlformats.org/drawingml/2006/main">
               <a:ext uri="{FF2B5EF4-FFF2-40B4-BE49-F238E27FC236}">
-                <a16:creationId xmlns:a16="http://schemas.microsoft.com/office/drawing/2014/main" id="{26198B29-B008-450E-A4AC-4E482F8CE9F2}"/>
+                <a16:creationId xmlns:a16="http://schemas.microsoft.com/office/drawing/2014/main" id="{BFA248C2-D0AA-43B3-8D9A-6A5B63BDE09C}"/>
               </a:ext>
             </a:extLst>
           </p:cNvPr>
@@ -3417,7 +2756,7 @@
     </p:spTree>
     <p:extLst>
       <p:ext uri="{BB962C8B-B14F-4D97-AF65-F5344CB8AC3E}">
-        <p14:creationId xmlns:p14="http://schemas.microsoft.com/office/powerpoint/2010/main" val="1893856505"/>
+        <p14:creationId xmlns:p14="http://schemas.microsoft.com/office/powerpoint/2010/main" val="47410639"/>
       </p:ext>
     </p:extLst>
   </p:cSld>
@@ -3448,7 +2787,7 @@
           <p:cNvPr id="1" name="">
             <a:extLst xmlns:a="http://schemas.openxmlformats.org/drawingml/2006/main">
               <a:ext uri="{FF2B5EF4-FFF2-40B4-BE49-F238E27FC236}">
-                <a16:creationId xmlns:a16="http://schemas.microsoft.com/office/drawing/2014/main" id="{4B2DFD60-AD61-49CC-A13B-F5F1E7D0DDEB}"/>
+                <a16:creationId xmlns:a16="http://schemas.microsoft.com/office/drawing/2014/main" id="{89D47186-A17F-40E4-ACD2-DF1434EEC21A}"/>
               </a:ext>
             </a:extLst>
           </p:cNvPr>
@@ -3481,7 +2820,7 @@
           <p:cNvPr id="2" name="">
             <a:extLst xmlns:a="http://schemas.openxmlformats.org/drawingml/2006/main">
               <a:ext uri="{FF2B5EF4-FFF2-40B4-BE49-F238E27FC236}">
-                <a16:creationId xmlns:a16="http://schemas.microsoft.com/office/drawing/2014/main" id="{6074A9CB-C875-4278-BD4A-6A5DC14BF703}"/>
+                <a16:creationId xmlns:a16="http://schemas.microsoft.com/office/drawing/2014/main" id="{6EE3202C-FB8D-41C1-946D-555723A4DB67}"/>
               </a:ext>
             </a:extLst>
           </p:cNvPr>
@@ -3514,7 +2853,7 @@
           <p:cNvPr id="3" name="">
             <a:extLst xmlns:a="http://schemas.openxmlformats.org/drawingml/2006/main">
               <a:ext uri="{FF2B5EF4-FFF2-40B4-BE49-F238E27FC236}">
-                <a16:creationId xmlns:a16="http://schemas.microsoft.com/office/drawing/2014/main" id="{BA10B366-BF79-45E5-AB6A-769D126EBB34}"/>
+                <a16:creationId xmlns:a16="http://schemas.microsoft.com/office/drawing/2014/main" id="{6CF78C84-554F-443B-8E45-2909B94E6D11}"/>
               </a:ext>
             </a:extLst>
           </p:cNvPr>
@@ -3564,7 +2903,7 @@
           <p:cNvPr id="4" name="">
             <a:extLst xmlns:a="http://schemas.openxmlformats.org/drawingml/2006/main">
               <a:ext uri="{FF2B5EF4-FFF2-40B4-BE49-F238E27FC236}">
-                <a16:creationId xmlns:a16="http://schemas.microsoft.com/office/drawing/2014/main" id="{D0950881-C58A-456E-8C0D-0E43D8702593}"/>
+                <a16:creationId xmlns:a16="http://schemas.microsoft.com/office/drawing/2014/main" id="{D67E438D-5E49-43FF-8F7E-848DE3303D1E}"/>
               </a:ext>
             </a:extLst>
           </p:cNvPr>
@@ -3614,7 +2953,7 @@
           <p:cNvPr id="5" name="">
             <a:extLst xmlns:a="http://schemas.openxmlformats.org/drawingml/2006/main">
               <a:ext uri="{FF2B5EF4-FFF2-40B4-BE49-F238E27FC236}">
-                <a16:creationId xmlns:a16="http://schemas.microsoft.com/office/drawing/2014/main" id="{84E8CA72-4A81-4027-9319-05B62F44AC8E}"/>
+                <a16:creationId xmlns:a16="http://schemas.microsoft.com/office/drawing/2014/main" id="{CBAA012F-0B95-47A2-8DC3-05C4E259A5CF}"/>
               </a:ext>
             </a:extLst>
           </p:cNvPr>
@@ -3664,7 +3003,7 @@
           <p:cNvPr id="6" name="">
             <a:extLst xmlns:a="http://schemas.openxmlformats.org/drawingml/2006/main">
               <a:ext uri="{FF2B5EF4-FFF2-40B4-BE49-F238E27FC236}">
-                <a16:creationId xmlns:a16="http://schemas.microsoft.com/office/drawing/2014/main" id="{2E36F93D-8B77-4A0C-B099-8D6A58C2856A}"/>
+                <a16:creationId xmlns:a16="http://schemas.microsoft.com/office/drawing/2014/main" id="{D548B235-5F84-4AC4-B144-0F3C40260EE8}"/>
               </a:ext>
             </a:extLst>
           </p:cNvPr>
@@ -3697,7 +3036,7 @@
           <p:cNvPr id="7" name="">
             <a:extLst xmlns:a="http://schemas.openxmlformats.org/drawingml/2006/main">
               <a:ext uri="{FF2B5EF4-FFF2-40B4-BE49-F238E27FC236}">
-                <a16:creationId xmlns:a16="http://schemas.microsoft.com/office/drawing/2014/main" id="{4B15F87B-6EA7-4C69-9E90-E2E59AF57D65}"/>
+                <a16:creationId xmlns:a16="http://schemas.microsoft.com/office/drawing/2014/main" id="{DDB77D43-0204-40D2-B593-171844EB206A}"/>
               </a:ext>
             </a:extLst>
           </p:cNvPr>
@@ -3747,7 +3086,7 @@
           <p:cNvPr id="8" name="">
             <a:extLst xmlns:a="http://schemas.openxmlformats.org/drawingml/2006/main">
               <a:ext uri="{FF2B5EF4-FFF2-40B4-BE49-F238E27FC236}">
-                <a16:creationId xmlns:a16="http://schemas.microsoft.com/office/drawing/2014/main" id="{5B0CD91D-3A83-454A-BFFF-944AD3C59B2E}"/>
+                <a16:creationId xmlns:a16="http://schemas.microsoft.com/office/drawing/2014/main" id="{A0241DA1-92C6-46B3-81F4-99ABD4510C42}"/>
               </a:ext>
             </a:extLst>
           </p:cNvPr>
@@ -3797,7 +3136,7 @@
           <p:cNvPr id="9" name="">
             <a:extLst xmlns:a="http://schemas.openxmlformats.org/drawingml/2006/main">
               <a:ext uri="{FF2B5EF4-FFF2-40B4-BE49-F238E27FC236}">
-                <a16:creationId xmlns:a16="http://schemas.microsoft.com/office/drawing/2014/main" id="{92BF04BE-8C68-42C8-8771-68467CD2B199}"/>
+                <a16:creationId xmlns:a16="http://schemas.microsoft.com/office/drawing/2014/main" id="{EB5696A6-FA74-4278-8D6B-D08D4B27A349}"/>
               </a:ext>
             </a:extLst>
           </p:cNvPr>
@@ -3847,7 +3186,7 @@
           <p:cNvPr id="10" name="">
             <a:extLst xmlns:a="http://schemas.openxmlformats.org/drawingml/2006/main">
               <a:ext uri="{FF2B5EF4-FFF2-40B4-BE49-F238E27FC236}">
-                <a16:creationId xmlns:a16="http://schemas.microsoft.com/office/drawing/2014/main" id="{8F3F7FA8-13F6-44AA-89EC-4906B372BB42}"/>
+                <a16:creationId xmlns:a16="http://schemas.microsoft.com/office/drawing/2014/main" id="{A65E46EA-BC4A-4A21-8A27-7AE90F887D8B}"/>
               </a:ext>
             </a:extLst>
           </p:cNvPr>
@@ -3897,7 +3236,7 @@
           <p:cNvPr id="11" name="">
             <a:extLst xmlns:a="http://schemas.openxmlformats.org/drawingml/2006/main">
               <a:ext uri="{FF2B5EF4-FFF2-40B4-BE49-F238E27FC236}">
-                <a16:creationId xmlns:a16="http://schemas.microsoft.com/office/drawing/2014/main" id="{B5164B88-77A3-4F86-BCB9-246CE8C6853A}"/>
+                <a16:creationId xmlns:a16="http://schemas.microsoft.com/office/drawing/2014/main" id="{2D90F92D-FEE0-4BC8-8D1B-64BC2624D6E2}"/>
               </a:ext>
             </a:extLst>
           </p:cNvPr>
@@ -3947,7 +3286,7 @@
           <p:cNvPr id="12" name="">
             <a:extLst xmlns:a="http://schemas.openxmlformats.org/drawingml/2006/main">
               <a:ext uri="{FF2B5EF4-FFF2-40B4-BE49-F238E27FC236}">
-                <a16:creationId xmlns:a16="http://schemas.microsoft.com/office/drawing/2014/main" id="{462377A5-CC41-4764-89EA-782EC0271ADC}"/>
+                <a16:creationId xmlns:a16="http://schemas.microsoft.com/office/drawing/2014/main" id="{19CF1A67-A177-4EE9-B94A-1261F9A071F7}"/>
               </a:ext>
             </a:extLst>
           </p:cNvPr>
@@ -3997,7 +3336,7 @@
           <p:cNvPr id="13" name="">
             <a:extLst xmlns:a="http://schemas.openxmlformats.org/drawingml/2006/main">
               <a:ext uri="{FF2B5EF4-FFF2-40B4-BE49-F238E27FC236}">
-                <a16:creationId xmlns:a16="http://schemas.microsoft.com/office/drawing/2014/main" id="{23B19964-EE3E-494C-BB81-3B1FA865315A}"/>
+                <a16:creationId xmlns:a16="http://schemas.microsoft.com/office/drawing/2014/main" id="{9BD9B112-1BD7-4C86-9676-C199955E0CFA}"/>
               </a:ext>
             </a:extLst>
           </p:cNvPr>
@@ -4070,7 +3409,7 @@
           <p:cNvPr id="14" name="">
             <a:extLst xmlns:a="http://schemas.openxmlformats.org/drawingml/2006/main">
               <a:ext uri="{FF2B5EF4-FFF2-40B4-BE49-F238E27FC236}">
-                <a16:creationId xmlns:a16="http://schemas.microsoft.com/office/drawing/2014/main" id="{5FB65D4A-27ED-4777-8FD8-CAB9F8FE46AF}"/>
+                <a16:creationId xmlns:a16="http://schemas.microsoft.com/office/drawing/2014/main" id="{DDEBCE89-46D3-41DA-ABDF-3468B70F323E}"/>
               </a:ext>
             </a:extLst>
           </p:cNvPr>
@@ -4143,7 +3482,7 @@
           <p:cNvPr id="15" name="">
             <a:extLst xmlns:a="http://schemas.openxmlformats.org/drawingml/2006/main">
               <a:ext uri="{FF2B5EF4-FFF2-40B4-BE49-F238E27FC236}">
-                <a16:creationId xmlns:a16="http://schemas.microsoft.com/office/drawing/2014/main" id="{2BFE80FE-28F9-4D9E-B400-DE5C03A8CEEB}"/>
+                <a16:creationId xmlns:a16="http://schemas.microsoft.com/office/drawing/2014/main" id="{1223E719-65D1-44C8-98C4-827F31FDB4E9}"/>
               </a:ext>
             </a:extLst>
           </p:cNvPr>
@@ -4216,7 +3555,7 @@
           <p:cNvPr id="16" name="">
             <a:extLst xmlns:a="http://schemas.openxmlformats.org/drawingml/2006/main">
               <a:ext uri="{FF2B5EF4-FFF2-40B4-BE49-F238E27FC236}">
-                <a16:creationId xmlns:a16="http://schemas.microsoft.com/office/drawing/2014/main" id="{C430F818-801D-4E87-99A4-AED38ED3EAAD}"/>
+                <a16:creationId xmlns:a16="http://schemas.microsoft.com/office/drawing/2014/main" id="{E5957105-7793-4BFD-8CDB-E8FF1DBB360D}"/>
               </a:ext>
             </a:extLst>
           </p:cNvPr>
@@ -4266,7 +3605,7 @@
           <p:cNvPr id="17" name="">
             <a:extLst xmlns:a="http://schemas.openxmlformats.org/drawingml/2006/main">
               <a:ext uri="{FF2B5EF4-FFF2-40B4-BE49-F238E27FC236}">
-                <a16:creationId xmlns:a16="http://schemas.microsoft.com/office/drawing/2014/main" id="{99C7A987-4BEF-484F-A267-5A893BEEC995}"/>
+                <a16:creationId xmlns:a16="http://schemas.microsoft.com/office/drawing/2014/main" id="{382A2E24-99D7-4936-9D8F-3BEBA87E6E8A}"/>
               </a:ext>
             </a:extLst>
           </p:cNvPr>
@@ -4314,7 +3653,7 @@
     </p:spTree>
     <p:extLst>
       <p:ext uri="{BB962C8B-B14F-4D97-AF65-F5344CB8AC3E}">
-        <p14:creationId xmlns:p14="http://schemas.microsoft.com/office/powerpoint/2010/main" val="1604628897"/>
+        <p14:creationId xmlns:p14="http://schemas.microsoft.com/office/powerpoint/2010/main" val="839456318"/>
       </p:ext>
     </p:extLst>
   </p:cSld>
@@ -4345,7 +3684,7 @@
           <p:cNvPr id="1" name="">
             <a:extLst xmlns:a="http://schemas.openxmlformats.org/drawingml/2006/main">
               <a:ext uri="{FF2B5EF4-FFF2-40B4-BE49-F238E27FC236}">
-                <a16:creationId xmlns:a16="http://schemas.microsoft.com/office/drawing/2014/main" id="{4FD97BEF-80ED-478E-B033-25F86F59DDD2}"/>
+                <a16:creationId xmlns:a16="http://schemas.microsoft.com/office/drawing/2014/main" id="{6A553D68-94C7-433F-A307-051F495A127E}"/>
               </a:ext>
             </a:extLst>
           </p:cNvPr>
@@ -4378,7 +3717,7 @@
           <p:cNvPr id="2" name="">
             <a:extLst xmlns:a="http://schemas.openxmlformats.org/drawingml/2006/main">
               <a:ext uri="{FF2B5EF4-FFF2-40B4-BE49-F238E27FC236}">
-                <a16:creationId xmlns:a16="http://schemas.microsoft.com/office/drawing/2014/main" id="{377335AB-2F1D-4DE5-B85A-212113CDF350}"/>
+                <a16:creationId xmlns:a16="http://schemas.microsoft.com/office/drawing/2014/main" id="{CB2F06E3-27D8-4D0F-8266-348C4995F294}"/>
               </a:ext>
             </a:extLst>
           </p:cNvPr>
@@ -4411,7 +3750,7 @@
           <p:cNvPr id="3" name="">
             <a:extLst xmlns:a="http://schemas.openxmlformats.org/drawingml/2006/main">
               <a:ext uri="{FF2B5EF4-FFF2-40B4-BE49-F238E27FC236}">
-                <a16:creationId xmlns:a16="http://schemas.microsoft.com/office/drawing/2014/main" id="{4BD36D4F-982E-486A-A87A-7D1D656226C7}"/>
+                <a16:creationId xmlns:a16="http://schemas.microsoft.com/office/drawing/2014/main" id="{178F740A-8CAC-4E7B-9253-08000B151E3D}"/>
               </a:ext>
             </a:extLst>
           </p:cNvPr>
@@ -4461,7 +3800,7 @@
           <p:cNvPr id="4" name="">
             <a:extLst xmlns:a="http://schemas.openxmlformats.org/drawingml/2006/main">
               <a:ext uri="{FF2B5EF4-FFF2-40B4-BE49-F238E27FC236}">
-                <a16:creationId xmlns:a16="http://schemas.microsoft.com/office/drawing/2014/main" id="{2FCD2BEF-3A19-4BF6-BC18-E61721412FFB}"/>
+                <a16:creationId xmlns:a16="http://schemas.microsoft.com/office/drawing/2014/main" id="{6CDDAE4D-FDF1-48BA-A8E0-D055E8BCB0D5}"/>
               </a:ext>
             </a:extLst>
           </p:cNvPr>
@@ -4511,7 +3850,7 @@
           <p:cNvPr id="5" name="">
             <a:extLst xmlns:a="http://schemas.openxmlformats.org/drawingml/2006/main">
               <a:ext uri="{FF2B5EF4-FFF2-40B4-BE49-F238E27FC236}">
-                <a16:creationId xmlns:a16="http://schemas.microsoft.com/office/drawing/2014/main" id="{7C752C09-D76E-4F7E-A9E8-CE27D4934236}"/>
+                <a16:creationId xmlns:a16="http://schemas.microsoft.com/office/drawing/2014/main" id="{8FE2DD2B-8F83-4100-9431-A9C7B15BFD0B}"/>
               </a:ext>
             </a:extLst>
           </p:cNvPr>
@@ -4561,7 +3900,7 @@
           <p:cNvPr id="6" name="">
             <a:extLst xmlns:a="http://schemas.openxmlformats.org/drawingml/2006/main">
               <a:ext uri="{FF2B5EF4-FFF2-40B4-BE49-F238E27FC236}">
-                <a16:creationId xmlns:a16="http://schemas.microsoft.com/office/drawing/2014/main" id="{49D49E97-6164-4B9A-BC24-50D753466BDC}"/>
+                <a16:creationId xmlns:a16="http://schemas.microsoft.com/office/drawing/2014/main" id="{F8A46BC2-B3F5-4EE5-8368-F49BE73F65C6}"/>
               </a:ext>
             </a:extLst>
           </p:cNvPr>
@@ -4594,7 +3933,7 @@
           <p:cNvPr id="7" name="">
             <a:extLst xmlns:a="http://schemas.openxmlformats.org/drawingml/2006/main">
               <a:ext uri="{FF2B5EF4-FFF2-40B4-BE49-F238E27FC236}">
-                <a16:creationId xmlns:a16="http://schemas.microsoft.com/office/drawing/2014/main" id="{0D04AE34-53ED-431C-B8B6-2CDD98B355D5}"/>
+                <a16:creationId xmlns:a16="http://schemas.microsoft.com/office/drawing/2014/main" id="{69C9F0BD-0C5F-4F74-8560-0647907ABE6D}"/>
               </a:ext>
             </a:extLst>
           </p:cNvPr>
@@ -4667,7 +4006,7 @@
           <p:cNvPr id="8" name="">
             <a:extLst xmlns:a="http://schemas.openxmlformats.org/drawingml/2006/main">
               <a:ext uri="{FF2B5EF4-FFF2-40B4-BE49-F238E27FC236}">
-                <a16:creationId xmlns:a16="http://schemas.microsoft.com/office/drawing/2014/main" id="{ACC6D586-6611-4194-8D43-9D50B6A20AF3}"/>
+                <a16:creationId xmlns:a16="http://schemas.microsoft.com/office/drawing/2014/main" id="{2210B215-69D9-42DF-946D-0E69B334747E}"/>
               </a:ext>
             </a:extLst>
           </p:cNvPr>
@@ -4740,7 +4079,7 @@
           <p:cNvPr id="9" name="">
             <a:extLst xmlns:a="http://schemas.openxmlformats.org/drawingml/2006/main">
               <a:ext uri="{FF2B5EF4-FFF2-40B4-BE49-F238E27FC236}">
-                <a16:creationId xmlns:a16="http://schemas.microsoft.com/office/drawing/2014/main" id="{BA0E6E26-1A58-44A3-8A23-44EF6A13D803}"/>
+                <a16:creationId xmlns:a16="http://schemas.microsoft.com/office/drawing/2014/main" id="{11976134-2839-4008-B655-66E07271698A}"/>
               </a:ext>
             </a:extLst>
           </p:cNvPr>
@@ -4813,7 +4152,7 @@
           <p:cNvPr id="10" name="">
             <a:extLst xmlns:a="http://schemas.openxmlformats.org/drawingml/2006/main">
               <a:ext uri="{FF2B5EF4-FFF2-40B4-BE49-F238E27FC236}">
-                <a16:creationId xmlns:a16="http://schemas.microsoft.com/office/drawing/2014/main" id="{DB050B5E-A1F6-43AA-A197-8CD0712F49BE}"/>
+                <a16:creationId xmlns:a16="http://schemas.microsoft.com/office/drawing/2014/main" id="{CBA99BDA-01CC-4E39-99AD-A8D3C7ED3EC1}"/>
               </a:ext>
             </a:extLst>
           </p:cNvPr>
@@ -4863,7 +4202,7 @@
           <p:cNvPr id="11" name="">
             <a:extLst xmlns:a="http://schemas.openxmlformats.org/drawingml/2006/main">
               <a:ext uri="{FF2B5EF4-FFF2-40B4-BE49-F238E27FC236}">
-                <a16:creationId xmlns:a16="http://schemas.microsoft.com/office/drawing/2014/main" id="{07E126A1-1B57-4CF7-BE22-6E3136D8F115}"/>
+                <a16:creationId xmlns:a16="http://schemas.microsoft.com/office/drawing/2014/main" id="{2B555291-DFA3-45C3-9C73-435FFDE72F6F}"/>
               </a:ext>
             </a:extLst>
           </p:cNvPr>
@@ -4913,7 +4252,7 @@
           <p:cNvPr id="12" name="">
             <a:extLst xmlns:a="http://schemas.openxmlformats.org/drawingml/2006/main">
               <a:ext uri="{FF2B5EF4-FFF2-40B4-BE49-F238E27FC236}">
-                <a16:creationId xmlns:a16="http://schemas.microsoft.com/office/drawing/2014/main" id="{4CA242B9-816F-49AD-8598-0713BC358282}"/>
+                <a16:creationId xmlns:a16="http://schemas.microsoft.com/office/drawing/2014/main" id="{F5E67281-A453-47C8-AE8F-8697DC3975E6}"/>
               </a:ext>
             </a:extLst>
           </p:cNvPr>
@@ -4963,7 +4302,7 @@
           <p:cNvPr id="13" name="">
             <a:extLst xmlns:a="http://schemas.openxmlformats.org/drawingml/2006/main">
               <a:ext uri="{FF2B5EF4-FFF2-40B4-BE49-F238E27FC236}">
-                <a16:creationId xmlns:a16="http://schemas.microsoft.com/office/drawing/2014/main" id="{8A417164-8E62-4B65-A1FA-E249DA39D5C5}"/>
+                <a16:creationId xmlns:a16="http://schemas.microsoft.com/office/drawing/2014/main" id="{01BB40F2-691E-4304-8856-76A2E7B1BD11}"/>
               </a:ext>
             </a:extLst>
           </p:cNvPr>
@@ -5013,7 +4352,7 @@
           <p:cNvPr id="14" name="">
             <a:extLst xmlns:a="http://schemas.openxmlformats.org/drawingml/2006/main">
               <a:ext uri="{FF2B5EF4-FFF2-40B4-BE49-F238E27FC236}">
-                <a16:creationId xmlns:a16="http://schemas.microsoft.com/office/drawing/2014/main" id="{6E805FA4-647C-4373-B262-60300F620930}"/>
+                <a16:creationId xmlns:a16="http://schemas.microsoft.com/office/drawing/2014/main" id="{DEA1E794-E240-4098-AA94-2EA5E4324313}"/>
               </a:ext>
             </a:extLst>
           </p:cNvPr>
@@ -5063,7 +4402,7 @@
           <p:cNvPr id="15" name="">
             <a:extLst xmlns:a="http://schemas.openxmlformats.org/drawingml/2006/main">
               <a:ext uri="{FF2B5EF4-FFF2-40B4-BE49-F238E27FC236}">
-                <a16:creationId xmlns:a16="http://schemas.microsoft.com/office/drawing/2014/main" id="{DD70C278-D3D1-4531-BCDB-A470666E4314}"/>
+                <a16:creationId xmlns:a16="http://schemas.microsoft.com/office/drawing/2014/main" id="{5BEB625B-2050-4FEB-A632-3915D4CFC245}"/>
               </a:ext>
             </a:extLst>
           </p:cNvPr>
@@ -5113,7 +4452,7 @@
           <p:cNvPr id="16" name="">
             <a:extLst xmlns:a="http://schemas.openxmlformats.org/drawingml/2006/main">
               <a:ext uri="{FF2B5EF4-FFF2-40B4-BE49-F238E27FC236}">
-                <a16:creationId xmlns:a16="http://schemas.microsoft.com/office/drawing/2014/main" id="{529B9782-7029-4BDE-8595-B6BBEE44A107}"/>
+                <a16:creationId xmlns:a16="http://schemas.microsoft.com/office/drawing/2014/main" id="{6F08A541-1B74-4D85-BFF7-E77CE6D673A8}"/>
               </a:ext>
             </a:extLst>
           </p:cNvPr>
@@ -5163,7 +4502,7 @@
           <p:cNvPr id="17" name="">
             <a:extLst xmlns:a="http://schemas.openxmlformats.org/drawingml/2006/main">
               <a:ext uri="{FF2B5EF4-FFF2-40B4-BE49-F238E27FC236}">
-                <a16:creationId xmlns:a16="http://schemas.microsoft.com/office/drawing/2014/main" id="{5038B73E-542C-48E2-BB70-EF0E09EA076D}"/>
+                <a16:creationId xmlns:a16="http://schemas.microsoft.com/office/drawing/2014/main" id="{E64B2408-73BA-4E6D-99ED-05DEB51BB234}"/>
               </a:ext>
             </a:extLst>
           </p:cNvPr>
@@ -5211,7 +4550,7 @@
     </p:spTree>
     <p:extLst>
       <p:ext uri="{BB962C8B-B14F-4D97-AF65-F5344CB8AC3E}">
-        <p14:creationId xmlns:p14="http://schemas.microsoft.com/office/powerpoint/2010/main" val="1031747672"/>
+        <p14:creationId xmlns:p14="http://schemas.microsoft.com/office/powerpoint/2010/main" val="922235970"/>
       </p:ext>
     </p:extLst>
   </p:cSld>
@@ -5242,7 +4581,7 @@
           <p:cNvPr id="1" name="">
             <a:extLst xmlns:a="http://schemas.openxmlformats.org/drawingml/2006/main">
               <a:ext uri="{FF2B5EF4-FFF2-40B4-BE49-F238E27FC236}">
-                <a16:creationId xmlns:a16="http://schemas.microsoft.com/office/drawing/2014/main" id="{473DC357-FEE9-4D98-B35D-43099756E838}"/>
+                <a16:creationId xmlns:a16="http://schemas.microsoft.com/office/drawing/2014/main" id="{88E1561A-C8B2-460E-B2C5-3E3C66B71B21}"/>
               </a:ext>
             </a:extLst>
           </p:cNvPr>
@@ -5275,7 +4614,7 @@
           <p:cNvPr id="2" name="">
             <a:extLst xmlns:a="http://schemas.openxmlformats.org/drawingml/2006/main">
               <a:ext uri="{FF2B5EF4-FFF2-40B4-BE49-F238E27FC236}">
-                <a16:creationId xmlns:a16="http://schemas.microsoft.com/office/drawing/2014/main" id="{50B89005-8F42-4508-89D4-D6662EB6D678}"/>
+                <a16:creationId xmlns:a16="http://schemas.microsoft.com/office/drawing/2014/main" id="{071003EC-5ED7-4F0C-B80A-C6AFC6DDACB3}"/>
               </a:ext>
             </a:extLst>
           </p:cNvPr>
@@ -5308,7 +4647,7 @@
           <p:cNvPr id="3" name="">
             <a:extLst xmlns:a="http://schemas.openxmlformats.org/drawingml/2006/main">
               <a:ext uri="{FF2B5EF4-FFF2-40B4-BE49-F238E27FC236}">
-                <a16:creationId xmlns:a16="http://schemas.microsoft.com/office/drawing/2014/main" id="{000F2173-1AE5-4CD2-B6E4-130E7A58C878}"/>
+                <a16:creationId xmlns:a16="http://schemas.microsoft.com/office/drawing/2014/main" id="{7A8786B5-A18C-49B6-BDB9-8CEE7DD2CC2D}"/>
               </a:ext>
             </a:extLst>
           </p:cNvPr>
@@ -5358,7 +4697,7 @@
           <p:cNvPr id="4" name="">
             <a:extLst xmlns:a="http://schemas.openxmlformats.org/drawingml/2006/main">
               <a:ext uri="{FF2B5EF4-FFF2-40B4-BE49-F238E27FC236}">
-                <a16:creationId xmlns:a16="http://schemas.microsoft.com/office/drawing/2014/main" id="{820AC7AC-4C70-4B6C-8722-6B9FBE8C377C}"/>
+                <a16:creationId xmlns:a16="http://schemas.microsoft.com/office/drawing/2014/main" id="{4A3C3455-1E11-458B-BFE5-2E698302023D}"/>
               </a:ext>
             </a:extLst>
           </p:cNvPr>
@@ -5408,7 +4747,7 @@
           <p:cNvPr id="5" name="">
             <a:extLst xmlns:a="http://schemas.openxmlformats.org/drawingml/2006/main">
               <a:ext uri="{FF2B5EF4-FFF2-40B4-BE49-F238E27FC236}">
-                <a16:creationId xmlns:a16="http://schemas.microsoft.com/office/drawing/2014/main" id="{2F6637A4-04F5-4DF0-A422-3EEFB99163FE}"/>
+                <a16:creationId xmlns:a16="http://schemas.microsoft.com/office/drawing/2014/main" id="{DAD85349-9BDA-4C71-95BD-D7806CE42CBF}"/>
               </a:ext>
             </a:extLst>
           </p:cNvPr>
@@ -5458,7 +4797,7 @@
           <p:cNvPr id="6" name="">
             <a:extLst xmlns:a="http://schemas.openxmlformats.org/drawingml/2006/main">
               <a:ext uri="{FF2B5EF4-FFF2-40B4-BE49-F238E27FC236}">
-                <a16:creationId xmlns:a16="http://schemas.microsoft.com/office/drawing/2014/main" id="{985DDE7A-AB50-47E8-9E0F-2ED51D6A26AA}"/>
+                <a16:creationId xmlns:a16="http://schemas.microsoft.com/office/drawing/2014/main" id="{50143179-F7CB-4828-A75A-88586BE0774D}"/>
               </a:ext>
             </a:extLst>
           </p:cNvPr>
@@ -5495,7 +4834,7 @@
           <p:nvPr/>
         </p:nvPicPr>
         <p:blipFill>
-          <a:blip xmlns:r="http://schemas.openxmlformats.org/officeDocument/2006/relationships" xmlns:a="http://schemas.openxmlformats.org/drawingml/2006/main" r:embed="R4c212a5aa42b4f2b"/>
+          <a:blip xmlns:r="http://schemas.openxmlformats.org/officeDocument/2006/relationships" xmlns:a="http://schemas.openxmlformats.org/drawingml/2006/main" r:embed="Rc70bd3169750469f"/>
           <a:stretch xmlns:a="http://schemas.openxmlformats.org/drawingml/2006/main"/>
         </p:blipFill>
         <p:spPr>
@@ -5513,7 +4852,7 @@
           <p:cNvPr id="8" name="">
             <a:extLst xmlns:a="http://schemas.openxmlformats.org/drawingml/2006/main">
               <a:ext uri="{FF2B5EF4-FFF2-40B4-BE49-F238E27FC236}">
-                <a16:creationId xmlns:a16="http://schemas.microsoft.com/office/drawing/2014/main" id="{AC59EB0E-0F6F-4660-9D53-0D0642D44426}"/>
+                <a16:creationId xmlns:a16="http://schemas.microsoft.com/office/drawing/2014/main" id="{39B605EF-0151-4B20-8C30-2605D7512E2A}"/>
               </a:ext>
             </a:extLst>
           </p:cNvPr>
@@ -5563,7 +4902,7 @@
           <p:cNvPr id="9" name="">
             <a:extLst xmlns:a="http://schemas.openxmlformats.org/drawingml/2006/main">
               <a:ext uri="{FF2B5EF4-FFF2-40B4-BE49-F238E27FC236}">
-                <a16:creationId xmlns:a16="http://schemas.microsoft.com/office/drawing/2014/main" id="{B9AEB4A6-08AB-4ED4-BF91-F3F21C881A0C}"/>
+                <a16:creationId xmlns:a16="http://schemas.microsoft.com/office/drawing/2014/main" id="{A93D7919-6985-4E25-BA20-5002B17FBECA}"/>
               </a:ext>
             </a:extLst>
           </p:cNvPr>
@@ -5613,7 +4952,7 @@
           <p:cNvPr id="10" name="">
             <a:extLst xmlns:a="http://schemas.openxmlformats.org/drawingml/2006/main">
               <a:ext uri="{FF2B5EF4-FFF2-40B4-BE49-F238E27FC236}">
-                <a16:creationId xmlns:a16="http://schemas.microsoft.com/office/drawing/2014/main" id="{60C303E8-86A0-4D89-874F-907742B8294E}"/>
+                <a16:creationId xmlns:a16="http://schemas.microsoft.com/office/drawing/2014/main" id="{1C0B543C-27BD-4BCC-930B-4A208C8897F8}"/>
               </a:ext>
             </a:extLst>
           </p:cNvPr>
@@ -5663,7 +5002,7 @@
           <p:cNvPr id="11" name="">
             <a:extLst xmlns:a="http://schemas.openxmlformats.org/drawingml/2006/main">
               <a:ext uri="{FF2B5EF4-FFF2-40B4-BE49-F238E27FC236}">
-                <a16:creationId xmlns:a16="http://schemas.microsoft.com/office/drawing/2014/main" id="{EA923E98-4F89-4E15-9ED2-1655C39B0C30}"/>
+                <a16:creationId xmlns:a16="http://schemas.microsoft.com/office/drawing/2014/main" id="{5E82BE6D-5664-4498-AD04-4755C7658B0E}"/>
               </a:ext>
             </a:extLst>
           </p:cNvPr>
@@ -5713,7 +5052,7 @@
           <p:cNvPr id="12" name="">
             <a:extLst xmlns:a="http://schemas.openxmlformats.org/drawingml/2006/main">
               <a:ext uri="{FF2B5EF4-FFF2-40B4-BE49-F238E27FC236}">
-                <a16:creationId xmlns:a16="http://schemas.microsoft.com/office/drawing/2014/main" id="{9075D864-0FFF-426F-B7B4-7E14B3DD567A}"/>
+                <a16:creationId xmlns:a16="http://schemas.microsoft.com/office/drawing/2014/main" id="{2B1533AB-CE9D-41EE-830E-93B7FD5E9949}"/>
               </a:ext>
             </a:extLst>
           </p:cNvPr>
@@ -5763,7 +5102,7 @@
           <p:cNvPr id="13" name="">
             <a:extLst xmlns:a="http://schemas.openxmlformats.org/drawingml/2006/main">
               <a:ext uri="{FF2B5EF4-FFF2-40B4-BE49-F238E27FC236}">
-                <a16:creationId xmlns:a16="http://schemas.microsoft.com/office/drawing/2014/main" id="{05B4E214-1077-4B3C-A139-AE1587D45F39}"/>
+                <a16:creationId xmlns:a16="http://schemas.microsoft.com/office/drawing/2014/main" id="{542410E0-A920-456E-A766-CBF8723AD93C}"/>
               </a:ext>
             </a:extLst>
           </p:cNvPr>
@@ -5813,7 +5152,7 @@
           <p:cNvPr id="14" name="">
             <a:extLst xmlns:a="http://schemas.openxmlformats.org/drawingml/2006/main">
               <a:ext uri="{FF2B5EF4-FFF2-40B4-BE49-F238E27FC236}">
-                <a16:creationId xmlns:a16="http://schemas.microsoft.com/office/drawing/2014/main" id="{DA5EBBDC-A698-4337-A3C1-275241BE357D}"/>
+                <a16:creationId xmlns:a16="http://schemas.microsoft.com/office/drawing/2014/main" id="{9DBF1E3E-DB6F-462F-86C6-2D13BFAB8542}"/>
               </a:ext>
             </a:extLst>
           </p:cNvPr>
@@ -5863,7 +5202,7 @@
           <p:cNvPr id="15" name="">
             <a:extLst xmlns:a="http://schemas.openxmlformats.org/drawingml/2006/main">
               <a:ext uri="{FF2B5EF4-FFF2-40B4-BE49-F238E27FC236}">
-                <a16:creationId xmlns:a16="http://schemas.microsoft.com/office/drawing/2014/main" id="{11FDC992-2AD8-4731-B657-97A6006A858B}"/>
+                <a16:creationId xmlns:a16="http://schemas.microsoft.com/office/drawing/2014/main" id="{1999A53D-0F3A-4A86-B079-26D5D16153C2}"/>
               </a:ext>
             </a:extLst>
           </p:cNvPr>
@@ -5913,7 +5252,7 @@
           <p:cNvPr id="16" name="">
             <a:extLst xmlns:a="http://schemas.openxmlformats.org/drawingml/2006/main">
               <a:ext uri="{FF2B5EF4-FFF2-40B4-BE49-F238E27FC236}">
-                <a16:creationId xmlns:a16="http://schemas.microsoft.com/office/drawing/2014/main" id="{26A3EE11-A02A-4596-9E58-0E980DB30C33}"/>
+                <a16:creationId xmlns:a16="http://schemas.microsoft.com/office/drawing/2014/main" id="{E506AF41-D583-449E-8CD5-A59B77EA76D8}"/>
               </a:ext>
             </a:extLst>
           </p:cNvPr>
@@ -5963,7 +5302,7 @@
           <p:cNvPr id="17" name="">
             <a:extLst xmlns:a="http://schemas.openxmlformats.org/drawingml/2006/main">
               <a:ext uri="{FF2B5EF4-FFF2-40B4-BE49-F238E27FC236}">
-                <a16:creationId xmlns:a16="http://schemas.microsoft.com/office/drawing/2014/main" id="{B1D49AA4-67EC-4725-A178-E5E8D8BD5B13}"/>
+                <a16:creationId xmlns:a16="http://schemas.microsoft.com/office/drawing/2014/main" id="{F9ADDDEB-7FD6-4F63-9818-482DB5EA0606}"/>
               </a:ext>
             </a:extLst>
           </p:cNvPr>
@@ -6013,7 +5352,7 @@
           <p:cNvPr id="18" name="">
             <a:extLst xmlns:a="http://schemas.openxmlformats.org/drawingml/2006/main">
               <a:ext uri="{FF2B5EF4-FFF2-40B4-BE49-F238E27FC236}">
-                <a16:creationId xmlns:a16="http://schemas.microsoft.com/office/drawing/2014/main" id="{4CD24AB9-5883-47EB-AD6C-CD3E09E81454}"/>
+                <a16:creationId xmlns:a16="http://schemas.microsoft.com/office/drawing/2014/main" id="{BEE10190-13C1-4049-B787-0DC1FB5923BC}"/>
               </a:ext>
             </a:extLst>
           </p:cNvPr>
@@ -6061,7 +5400,7 @@
     </p:spTree>
     <p:extLst>
       <p:ext uri="{BB962C8B-B14F-4D97-AF65-F5344CB8AC3E}">
-        <p14:creationId xmlns:p14="http://schemas.microsoft.com/office/powerpoint/2010/main" val="770119070"/>
+        <p14:creationId xmlns:p14="http://schemas.microsoft.com/office/powerpoint/2010/main" val="177402652"/>
       </p:ext>
     </p:extLst>
   </p:cSld>
@@ -6092,7 +5431,7 @@
           <p:cNvPr id="1" name="">
             <a:extLst xmlns:a="http://schemas.openxmlformats.org/drawingml/2006/main">
               <a:ext uri="{FF2B5EF4-FFF2-40B4-BE49-F238E27FC236}">
-                <a16:creationId xmlns:a16="http://schemas.microsoft.com/office/drawing/2014/main" id="{F8BDF54F-A03D-4CDA-9CFE-FF93F3A7B542}"/>
+                <a16:creationId xmlns:a16="http://schemas.microsoft.com/office/drawing/2014/main" id="{FF453478-6457-4280-9BF2-A39B2AB3780E}"/>
               </a:ext>
             </a:extLst>
           </p:cNvPr>
@@ -6125,7 +5464,7 @@
           <p:cNvPr id="2" name="">
             <a:extLst xmlns:a="http://schemas.openxmlformats.org/drawingml/2006/main">
               <a:ext uri="{FF2B5EF4-FFF2-40B4-BE49-F238E27FC236}">
-                <a16:creationId xmlns:a16="http://schemas.microsoft.com/office/drawing/2014/main" id="{F14EF19C-7C8B-49EF-9BBD-FE82970E28E7}"/>
+                <a16:creationId xmlns:a16="http://schemas.microsoft.com/office/drawing/2014/main" id="{E4250C83-045C-49DB-8E1B-13BD020628D3}"/>
               </a:ext>
             </a:extLst>
           </p:cNvPr>
@@ -6158,7 +5497,7 @@
           <p:cNvPr id="3" name="">
             <a:extLst xmlns:a="http://schemas.openxmlformats.org/drawingml/2006/main">
               <a:ext uri="{FF2B5EF4-FFF2-40B4-BE49-F238E27FC236}">
-                <a16:creationId xmlns:a16="http://schemas.microsoft.com/office/drawing/2014/main" id="{CFB70D7A-9D37-44AD-8D0B-9F8E85937822}"/>
+                <a16:creationId xmlns:a16="http://schemas.microsoft.com/office/drawing/2014/main" id="{02EA3AD7-4D1B-43DC-A6E3-A37C250CF4BB}"/>
               </a:ext>
             </a:extLst>
           </p:cNvPr>
@@ -6208,7 +5547,7 @@
           <p:cNvPr id="4" name="">
             <a:extLst xmlns:a="http://schemas.openxmlformats.org/drawingml/2006/main">
               <a:ext uri="{FF2B5EF4-FFF2-40B4-BE49-F238E27FC236}">
-                <a16:creationId xmlns:a16="http://schemas.microsoft.com/office/drawing/2014/main" id="{274FD223-9A98-403B-AA8D-83172E46607F}"/>
+                <a16:creationId xmlns:a16="http://schemas.microsoft.com/office/drawing/2014/main" id="{12DB0A88-47CD-4F48-9D97-E9BD99128C4D}"/>
               </a:ext>
             </a:extLst>
           </p:cNvPr>
@@ -6258,7 +5597,7 @@
           <p:cNvPr id="5" name="">
             <a:extLst xmlns:a="http://schemas.openxmlformats.org/drawingml/2006/main">
               <a:ext uri="{FF2B5EF4-FFF2-40B4-BE49-F238E27FC236}">
-                <a16:creationId xmlns:a16="http://schemas.microsoft.com/office/drawing/2014/main" id="{E0BF35FC-F683-4796-81DD-BEEA68FC7C2E}"/>
+                <a16:creationId xmlns:a16="http://schemas.microsoft.com/office/drawing/2014/main" id="{0A5D623F-FA86-49EA-B672-B4481525CB26}"/>
               </a:ext>
             </a:extLst>
           </p:cNvPr>
@@ -6308,7 +5647,7 @@
           <p:cNvPr id="6" name="">
             <a:extLst xmlns:a="http://schemas.openxmlformats.org/drawingml/2006/main">
               <a:ext uri="{FF2B5EF4-FFF2-40B4-BE49-F238E27FC236}">
-                <a16:creationId xmlns:a16="http://schemas.microsoft.com/office/drawing/2014/main" id="{ED7D5B44-422D-4406-986E-309D14F1BBC1}"/>
+                <a16:creationId xmlns:a16="http://schemas.microsoft.com/office/drawing/2014/main" id="{48490944-1577-41AB-B0BB-67E533BC30B1}"/>
               </a:ext>
             </a:extLst>
           </p:cNvPr>
@@ -6341,7 +5680,7 @@
           <p:cNvPr id="7" name="">
             <a:extLst xmlns:a="http://schemas.openxmlformats.org/drawingml/2006/main">
               <a:ext uri="{FF2B5EF4-FFF2-40B4-BE49-F238E27FC236}">
-                <a16:creationId xmlns:a16="http://schemas.microsoft.com/office/drawing/2014/main" id="{D7600B2B-DCC8-4870-B6AC-C39E23593CFC}"/>
+                <a16:creationId xmlns:a16="http://schemas.microsoft.com/office/drawing/2014/main" id="{E9F32574-0B27-4B66-A833-088358CECC15}"/>
               </a:ext>
             </a:extLst>
           </p:cNvPr>
@@ -6431,7 +5770,7 @@
           <p:cNvPr id="8" name="">
             <a:extLst xmlns:a="http://schemas.openxmlformats.org/drawingml/2006/main">
               <a:ext uri="{FF2B5EF4-FFF2-40B4-BE49-F238E27FC236}">
-                <a16:creationId xmlns:a16="http://schemas.microsoft.com/office/drawing/2014/main" id="{6460942D-EC11-4A00-8491-7F3035A5898D}"/>
+                <a16:creationId xmlns:a16="http://schemas.microsoft.com/office/drawing/2014/main" id="{079F3F67-CD12-4354-8C0A-C9E300DA4B8A}"/>
               </a:ext>
             </a:extLst>
           </p:cNvPr>
@@ -6481,7 +5820,7 @@
           <p:cNvPr id="9" name="">
             <a:extLst xmlns:a="http://schemas.openxmlformats.org/drawingml/2006/main">
               <a:ext uri="{FF2B5EF4-FFF2-40B4-BE49-F238E27FC236}">
-                <a16:creationId xmlns:a16="http://schemas.microsoft.com/office/drawing/2014/main" id="{83190A7E-5AE4-4514-A27F-6E1A0046D939}"/>
+                <a16:creationId xmlns:a16="http://schemas.microsoft.com/office/drawing/2014/main" id="{ED94D913-D19B-44C4-91BD-EA8B19C53510}"/>
               </a:ext>
             </a:extLst>
           </p:cNvPr>
@@ -6571,7 +5910,7 @@
           <p:cNvPr id="10" name="">
             <a:extLst xmlns:a="http://schemas.openxmlformats.org/drawingml/2006/main">
               <a:ext uri="{FF2B5EF4-FFF2-40B4-BE49-F238E27FC236}">
-                <a16:creationId xmlns:a16="http://schemas.microsoft.com/office/drawing/2014/main" id="{F70CBAE4-8E46-46C8-ACAB-964CF802F388}"/>
+                <a16:creationId xmlns:a16="http://schemas.microsoft.com/office/drawing/2014/main" id="{C08383DC-ACF6-4B66-843D-22093241CA2B}"/>
               </a:ext>
             </a:extLst>
           </p:cNvPr>
@@ -6621,7 +5960,7 @@
           <p:cNvPr id="11" name="">
             <a:extLst xmlns:a="http://schemas.openxmlformats.org/drawingml/2006/main">
               <a:ext uri="{FF2B5EF4-FFF2-40B4-BE49-F238E27FC236}">
-                <a16:creationId xmlns:a16="http://schemas.microsoft.com/office/drawing/2014/main" id="{1DF20EE9-36F8-4EEA-9AA1-116F34BC15F4}"/>
+                <a16:creationId xmlns:a16="http://schemas.microsoft.com/office/drawing/2014/main" id="{556B4FAB-05FA-4DD0-B386-EE4141BD3080}"/>
               </a:ext>
             </a:extLst>
           </p:cNvPr>
@@ -6711,7 +6050,7 @@
           <p:cNvPr id="12" name="">
             <a:extLst xmlns:a="http://schemas.openxmlformats.org/drawingml/2006/main">
               <a:ext uri="{FF2B5EF4-FFF2-40B4-BE49-F238E27FC236}">
-                <a16:creationId xmlns:a16="http://schemas.microsoft.com/office/drawing/2014/main" id="{DE0652C4-EBDD-4A00-A251-C8E5FA9EF63A}"/>
+                <a16:creationId xmlns:a16="http://schemas.microsoft.com/office/drawing/2014/main" id="{FECF3BBB-6349-4D57-99AC-B48B6DA6DDEC}"/>
               </a:ext>
             </a:extLst>
           </p:cNvPr>
@@ -6761,7 +6100,7 @@
           <p:cNvPr id="13" name="">
             <a:extLst xmlns:a="http://schemas.openxmlformats.org/drawingml/2006/main">
               <a:ext uri="{FF2B5EF4-FFF2-40B4-BE49-F238E27FC236}">
-                <a16:creationId xmlns:a16="http://schemas.microsoft.com/office/drawing/2014/main" id="{2BFA612B-E0F4-4538-A111-919E4EA05191}"/>
+                <a16:creationId xmlns:a16="http://schemas.microsoft.com/office/drawing/2014/main" id="{8042C6AE-0F4B-4788-83AF-FC021C31A3F4}"/>
               </a:ext>
             </a:extLst>
           </p:cNvPr>
@@ -6851,7 +6190,7 @@
           <p:cNvPr id="14" name="">
             <a:extLst xmlns:a="http://schemas.openxmlformats.org/drawingml/2006/main">
               <a:ext uri="{FF2B5EF4-FFF2-40B4-BE49-F238E27FC236}">
-                <a16:creationId xmlns:a16="http://schemas.microsoft.com/office/drawing/2014/main" id="{98418164-5655-403F-8680-3FE58584E65E}"/>
+                <a16:creationId xmlns:a16="http://schemas.microsoft.com/office/drawing/2014/main" id="{5B1F2F27-40A4-42B1-89FB-E22269A87D78}"/>
               </a:ext>
             </a:extLst>
           </p:cNvPr>
@@ -6901,7 +6240,7 @@
           <p:cNvPr id="15" name="">
             <a:extLst xmlns:a="http://schemas.openxmlformats.org/drawingml/2006/main">
               <a:ext uri="{FF2B5EF4-FFF2-40B4-BE49-F238E27FC236}">
-                <a16:creationId xmlns:a16="http://schemas.microsoft.com/office/drawing/2014/main" id="{61714994-88CF-4E47-9C3B-ED78953F3F21}"/>
+                <a16:creationId xmlns:a16="http://schemas.microsoft.com/office/drawing/2014/main" id="{047023EF-26DA-41DB-B0C4-3A11735AF5FF}"/>
               </a:ext>
             </a:extLst>
           </p:cNvPr>
@@ -6991,7 +6330,7 @@
           <p:cNvPr id="16" name="">
             <a:extLst xmlns:a="http://schemas.openxmlformats.org/drawingml/2006/main">
               <a:ext uri="{FF2B5EF4-FFF2-40B4-BE49-F238E27FC236}">
-                <a16:creationId xmlns:a16="http://schemas.microsoft.com/office/drawing/2014/main" id="{5B877F9A-6415-4815-9964-AE5DE2E57FAA}"/>
+                <a16:creationId xmlns:a16="http://schemas.microsoft.com/office/drawing/2014/main" id="{85E31584-63A3-41BD-8E6B-E106EC1BA5D9}"/>
               </a:ext>
             </a:extLst>
           </p:cNvPr>
@@ -7064,7 +6403,7 @@
           <p:cNvPr id="17" name="">
             <a:extLst xmlns:a="http://schemas.openxmlformats.org/drawingml/2006/main">
               <a:ext uri="{FF2B5EF4-FFF2-40B4-BE49-F238E27FC236}">
-                <a16:creationId xmlns:a16="http://schemas.microsoft.com/office/drawing/2014/main" id="{4553FEE7-2291-400C-A2A6-453DDFBFEADE}"/>
+                <a16:creationId xmlns:a16="http://schemas.microsoft.com/office/drawing/2014/main" id="{D2D7C889-0C25-45F2-A9D6-8DF4802C1388}"/>
               </a:ext>
             </a:extLst>
           </p:cNvPr>
@@ -7154,7 +6493,7 @@
           <p:cNvPr id="18" name="">
             <a:extLst xmlns:a="http://schemas.openxmlformats.org/drawingml/2006/main">
               <a:ext uri="{FF2B5EF4-FFF2-40B4-BE49-F238E27FC236}">
-                <a16:creationId xmlns:a16="http://schemas.microsoft.com/office/drawing/2014/main" id="{5F7D113B-D3A6-4177-A4EB-2BE49E5820C1}"/>
+                <a16:creationId xmlns:a16="http://schemas.microsoft.com/office/drawing/2014/main" id="{58559EFA-2C06-4101-BC1D-EB4F82570759}"/>
               </a:ext>
             </a:extLst>
           </p:cNvPr>
@@ -7244,7 +6583,7 @@
           <p:cNvPr id="19" name="">
             <a:extLst xmlns:a="http://schemas.openxmlformats.org/drawingml/2006/main">
               <a:ext uri="{FF2B5EF4-FFF2-40B4-BE49-F238E27FC236}">
-                <a16:creationId xmlns:a16="http://schemas.microsoft.com/office/drawing/2014/main" id="{4603B9A3-8300-4D15-8F14-405EA03C1FCA}"/>
+                <a16:creationId xmlns:a16="http://schemas.microsoft.com/office/drawing/2014/main" id="{1D9FAC79-1617-45E4-81B1-B6A371FC068D}"/>
               </a:ext>
             </a:extLst>
           </p:cNvPr>
@@ -7294,7 +6633,7 @@
           <p:cNvPr id="20" name="">
             <a:extLst xmlns:a="http://schemas.openxmlformats.org/drawingml/2006/main">
               <a:ext uri="{FF2B5EF4-FFF2-40B4-BE49-F238E27FC236}">
-                <a16:creationId xmlns:a16="http://schemas.microsoft.com/office/drawing/2014/main" id="{555A67DB-2F18-47F2-BD18-8F7979E6BA73}"/>
+                <a16:creationId xmlns:a16="http://schemas.microsoft.com/office/drawing/2014/main" id="{966F98FC-74C7-470B-92AA-D2B962826EB9}"/>
               </a:ext>
             </a:extLst>
           </p:cNvPr>
@@ -7344,7 +6683,7 @@
           <p:cNvPr id="21" name="">
             <a:extLst xmlns:a="http://schemas.openxmlformats.org/drawingml/2006/main">
               <a:ext uri="{FF2B5EF4-FFF2-40B4-BE49-F238E27FC236}">
-                <a16:creationId xmlns:a16="http://schemas.microsoft.com/office/drawing/2014/main" id="{064DB6B4-DEC5-4F62-93E1-2C932DD7A02A}"/>
+                <a16:creationId xmlns:a16="http://schemas.microsoft.com/office/drawing/2014/main" id="{7C20E410-FAEE-4560-92F1-504D9120B854}"/>
               </a:ext>
             </a:extLst>
           </p:cNvPr>
@@ -7394,7 +6733,7 @@
           <p:cNvPr id="22" name="">
             <a:extLst xmlns:a="http://schemas.openxmlformats.org/drawingml/2006/main">
               <a:ext uri="{FF2B5EF4-FFF2-40B4-BE49-F238E27FC236}">
-                <a16:creationId xmlns:a16="http://schemas.microsoft.com/office/drawing/2014/main" id="{4B1C709C-367E-4086-9971-FD6F1CB19B1D}"/>
+                <a16:creationId xmlns:a16="http://schemas.microsoft.com/office/drawing/2014/main" id="{68A3716D-6D13-467A-84AF-73673535494D}"/>
               </a:ext>
             </a:extLst>
           </p:cNvPr>
@@ -7444,7 +6783,7 @@
           <p:cNvPr id="23" name="">
             <a:extLst xmlns:a="http://schemas.openxmlformats.org/drawingml/2006/main">
               <a:ext uri="{FF2B5EF4-FFF2-40B4-BE49-F238E27FC236}">
-                <a16:creationId xmlns:a16="http://schemas.microsoft.com/office/drawing/2014/main" id="{33FBA7E3-C536-492E-AC0C-E0F56F704C3B}"/>
+                <a16:creationId xmlns:a16="http://schemas.microsoft.com/office/drawing/2014/main" id="{653BB4B5-DAE1-465A-9CF2-DF40B84EF9A8}"/>
               </a:ext>
             </a:extLst>
           </p:cNvPr>
@@ -7492,7 +6831,7 @@
     </p:spTree>
     <p:extLst>
       <p:ext uri="{BB962C8B-B14F-4D97-AF65-F5344CB8AC3E}">
-        <p14:creationId xmlns:p14="http://schemas.microsoft.com/office/powerpoint/2010/main" val="954504016"/>
+        <p14:creationId xmlns:p14="http://schemas.microsoft.com/office/powerpoint/2010/main" val="836638747"/>
       </p:ext>
     </p:extLst>
   </p:cSld>
@@ -7523,7 +6862,7 @@
           <p:cNvPr id="1" name="">
             <a:extLst xmlns:a="http://schemas.openxmlformats.org/drawingml/2006/main">
               <a:ext uri="{FF2B5EF4-FFF2-40B4-BE49-F238E27FC236}">
-                <a16:creationId xmlns:a16="http://schemas.microsoft.com/office/drawing/2014/main" id="{9B2F9C98-ED36-47AE-8A9A-2596BF67ACDD}"/>
+                <a16:creationId xmlns:a16="http://schemas.microsoft.com/office/drawing/2014/main" id="{39A1E04F-1218-4B3C-BED4-2B49A2F3E763}"/>
               </a:ext>
             </a:extLst>
           </p:cNvPr>
@@ -7556,7 +6895,7 @@
           <p:cNvPr id="2" name="">
             <a:extLst xmlns:a="http://schemas.openxmlformats.org/drawingml/2006/main">
               <a:ext uri="{FF2B5EF4-FFF2-40B4-BE49-F238E27FC236}">
-                <a16:creationId xmlns:a16="http://schemas.microsoft.com/office/drawing/2014/main" id="{96220B87-B818-4D43-B7C3-85ED61719C3F}"/>
+                <a16:creationId xmlns:a16="http://schemas.microsoft.com/office/drawing/2014/main" id="{5BF50ECC-5E22-4D9D-9DF1-49F84360DADE}"/>
               </a:ext>
             </a:extLst>
           </p:cNvPr>
@@ -7589,7 +6928,7 @@
           <p:cNvPr id="3" name="">
             <a:extLst xmlns:a="http://schemas.openxmlformats.org/drawingml/2006/main">
               <a:ext uri="{FF2B5EF4-FFF2-40B4-BE49-F238E27FC236}">
-                <a16:creationId xmlns:a16="http://schemas.microsoft.com/office/drawing/2014/main" id="{DA987DED-C361-4679-8665-C937ED1B23B9}"/>
+                <a16:creationId xmlns:a16="http://schemas.microsoft.com/office/drawing/2014/main" id="{96895B87-0BB4-428E-868B-9DCCFE8BB0DE}"/>
               </a:ext>
             </a:extLst>
           </p:cNvPr>
@@ -7639,7 +6978,7 @@
           <p:cNvPr id="4" name="">
             <a:extLst xmlns:a="http://schemas.openxmlformats.org/drawingml/2006/main">
               <a:ext uri="{FF2B5EF4-FFF2-40B4-BE49-F238E27FC236}">
-                <a16:creationId xmlns:a16="http://schemas.microsoft.com/office/drawing/2014/main" id="{A7AEEB86-7815-4424-B9FD-61E5284561BF}"/>
+                <a16:creationId xmlns:a16="http://schemas.microsoft.com/office/drawing/2014/main" id="{152F3859-BB02-4279-94EF-15489B6683E9}"/>
               </a:ext>
             </a:extLst>
           </p:cNvPr>
@@ -7689,7 +7028,7 @@
           <p:cNvPr id="5" name="">
             <a:extLst xmlns:a="http://schemas.openxmlformats.org/drawingml/2006/main">
               <a:ext uri="{FF2B5EF4-FFF2-40B4-BE49-F238E27FC236}">
-                <a16:creationId xmlns:a16="http://schemas.microsoft.com/office/drawing/2014/main" id="{83BAAEB1-957D-4AA5-A822-4E5E952DA1F0}"/>
+                <a16:creationId xmlns:a16="http://schemas.microsoft.com/office/drawing/2014/main" id="{D51AFB68-8FF7-486C-9853-5B304BED38BD}"/>
               </a:ext>
             </a:extLst>
           </p:cNvPr>
@@ -7739,7 +7078,7 @@
           <p:cNvPr id="6" name="">
             <a:extLst xmlns:a="http://schemas.openxmlformats.org/drawingml/2006/main">
               <a:ext uri="{FF2B5EF4-FFF2-40B4-BE49-F238E27FC236}">
-                <a16:creationId xmlns:a16="http://schemas.microsoft.com/office/drawing/2014/main" id="{E701522A-2F12-433F-911E-CAD78651CDB0}"/>
+                <a16:creationId xmlns:a16="http://schemas.microsoft.com/office/drawing/2014/main" id="{393E2E16-7558-4624-99A2-B08D2983D0B0}"/>
               </a:ext>
             </a:extLst>
           </p:cNvPr>
@@ -7772,7 +7111,7 @@
           <p:cNvPr id="7" name="">
             <a:extLst xmlns:a="http://schemas.openxmlformats.org/drawingml/2006/main">
               <a:ext uri="{FF2B5EF4-FFF2-40B4-BE49-F238E27FC236}">
-                <a16:creationId xmlns:a16="http://schemas.microsoft.com/office/drawing/2014/main" id="{17F97BC1-C38B-4140-826D-EA74402C7E26}"/>
+                <a16:creationId xmlns:a16="http://schemas.microsoft.com/office/drawing/2014/main" id="{4B104EBF-CD1E-4617-9030-1D80B26AA0E0}"/>
               </a:ext>
             </a:extLst>
           </p:cNvPr>
@@ -7862,7 +7201,7 @@
           <p:cNvPr id="8" name="">
             <a:extLst xmlns:a="http://schemas.openxmlformats.org/drawingml/2006/main">
               <a:ext uri="{FF2B5EF4-FFF2-40B4-BE49-F238E27FC236}">
-                <a16:creationId xmlns:a16="http://schemas.microsoft.com/office/drawing/2014/main" id="{C72D75C1-8427-4B2D-B314-ED83AFCE8327}"/>
+                <a16:creationId xmlns:a16="http://schemas.microsoft.com/office/drawing/2014/main" id="{903BEEEB-6ABD-4DC1-823F-7273C510167E}"/>
               </a:ext>
             </a:extLst>
           </p:cNvPr>
@@ -7912,7 +7251,7 @@
           <p:cNvPr id="9" name="">
             <a:extLst xmlns:a="http://schemas.openxmlformats.org/drawingml/2006/main">
               <a:ext uri="{FF2B5EF4-FFF2-40B4-BE49-F238E27FC236}">
-                <a16:creationId xmlns:a16="http://schemas.microsoft.com/office/drawing/2014/main" id="{3DA369AC-5F79-4F0F-A28D-C4DECC88BD73}"/>
+                <a16:creationId xmlns:a16="http://schemas.microsoft.com/office/drawing/2014/main" id="{189CCFC4-32BA-4B95-966D-8883D12DDBE8}"/>
               </a:ext>
             </a:extLst>
           </p:cNvPr>
@@ -8002,7 +7341,7 @@
           <p:cNvPr id="10" name="">
             <a:extLst xmlns:a="http://schemas.openxmlformats.org/drawingml/2006/main">
               <a:ext uri="{FF2B5EF4-FFF2-40B4-BE49-F238E27FC236}">
-                <a16:creationId xmlns:a16="http://schemas.microsoft.com/office/drawing/2014/main" id="{D1AD06C8-CA22-4A33-9E27-944D95ADEDE9}"/>
+                <a16:creationId xmlns:a16="http://schemas.microsoft.com/office/drawing/2014/main" id="{09D90D0D-A08D-40EC-8B2D-09B7FFCE18CC}"/>
               </a:ext>
             </a:extLst>
           </p:cNvPr>
@@ -8052,7 +7391,7 @@
           <p:cNvPr id="11" name="">
             <a:extLst xmlns:a="http://schemas.openxmlformats.org/drawingml/2006/main">
               <a:ext uri="{FF2B5EF4-FFF2-40B4-BE49-F238E27FC236}">
-                <a16:creationId xmlns:a16="http://schemas.microsoft.com/office/drawing/2014/main" id="{222423EA-B884-4C41-A2D0-E71BA0325481}"/>
+                <a16:creationId xmlns:a16="http://schemas.microsoft.com/office/drawing/2014/main" id="{BF5E672A-B6EE-48B9-B4B3-B3FB1B9B4E55}"/>
               </a:ext>
             </a:extLst>
           </p:cNvPr>
@@ -8142,7 +7481,7 @@
           <p:cNvPr id="12" name="">
             <a:extLst xmlns:a="http://schemas.openxmlformats.org/drawingml/2006/main">
               <a:ext uri="{FF2B5EF4-FFF2-40B4-BE49-F238E27FC236}">
-                <a16:creationId xmlns:a16="http://schemas.microsoft.com/office/drawing/2014/main" id="{3F37E069-A9E2-4FFF-86E3-6E997E6527C3}"/>
+                <a16:creationId xmlns:a16="http://schemas.microsoft.com/office/drawing/2014/main" id="{B48C794C-AFC5-4115-8350-76EF89BACB55}"/>
               </a:ext>
             </a:extLst>
           </p:cNvPr>
@@ -8192,7 +7531,7 @@
           <p:cNvPr id="13" name="">
             <a:extLst xmlns:a="http://schemas.openxmlformats.org/drawingml/2006/main">
               <a:ext uri="{FF2B5EF4-FFF2-40B4-BE49-F238E27FC236}">
-                <a16:creationId xmlns:a16="http://schemas.microsoft.com/office/drawing/2014/main" id="{67CACC6E-9B55-4526-8FC9-1F98AB66F881}"/>
+                <a16:creationId xmlns:a16="http://schemas.microsoft.com/office/drawing/2014/main" id="{76125E12-4432-4DA3-AF96-FF4F21A23E2B}"/>
               </a:ext>
             </a:extLst>
           </p:cNvPr>
@@ -8282,7 +7621,7 @@
           <p:cNvPr id="14" name="">
             <a:extLst xmlns:a="http://schemas.openxmlformats.org/drawingml/2006/main">
               <a:ext uri="{FF2B5EF4-FFF2-40B4-BE49-F238E27FC236}">
-                <a16:creationId xmlns:a16="http://schemas.microsoft.com/office/drawing/2014/main" id="{84BCF8AD-0F83-440B-83AC-B07C02A38804}"/>
+                <a16:creationId xmlns:a16="http://schemas.microsoft.com/office/drawing/2014/main" id="{15CCF3B1-CF28-4431-92BE-5DB84329B1B0}"/>
               </a:ext>
             </a:extLst>
           </p:cNvPr>
@@ -8332,7 +7671,7 @@
           <p:cNvPr id="15" name="">
             <a:extLst xmlns:a="http://schemas.openxmlformats.org/drawingml/2006/main">
               <a:ext uri="{FF2B5EF4-FFF2-40B4-BE49-F238E27FC236}">
-                <a16:creationId xmlns:a16="http://schemas.microsoft.com/office/drawing/2014/main" id="{66C511B2-F22B-4CD0-A955-293160C910EA}"/>
+                <a16:creationId xmlns:a16="http://schemas.microsoft.com/office/drawing/2014/main" id="{BAF88C9A-47CC-4B7B-8B08-E260C8F2E0EF}"/>
               </a:ext>
             </a:extLst>
           </p:cNvPr>
@@ -8422,7 +7761,7 @@
           <p:cNvPr id="16" name="">
             <a:extLst xmlns:a="http://schemas.openxmlformats.org/drawingml/2006/main">
               <a:ext uri="{FF2B5EF4-FFF2-40B4-BE49-F238E27FC236}">
-                <a16:creationId xmlns:a16="http://schemas.microsoft.com/office/drawing/2014/main" id="{62ABB3D4-6348-423C-B044-A8DE39911A99}"/>
+                <a16:creationId xmlns:a16="http://schemas.microsoft.com/office/drawing/2014/main" id="{7EE25DCA-FD46-4E2C-A587-5DE478133D5E}"/>
               </a:ext>
             </a:extLst>
           </p:cNvPr>
@@ -8512,7 +7851,7 @@
           <p:cNvPr id="17" name="">
             <a:extLst xmlns:a="http://schemas.openxmlformats.org/drawingml/2006/main">
               <a:ext uri="{FF2B5EF4-FFF2-40B4-BE49-F238E27FC236}">
-                <a16:creationId xmlns:a16="http://schemas.microsoft.com/office/drawing/2014/main" id="{694717AA-F897-407A-A993-27CD374E9174}"/>
+                <a16:creationId xmlns:a16="http://schemas.microsoft.com/office/drawing/2014/main" id="{4247D6AF-208E-4E1A-AB69-876373E2F2ED}"/>
               </a:ext>
             </a:extLst>
           </p:cNvPr>
@@ -8602,7 +7941,7 @@
           <p:cNvPr id="18" name="">
             <a:extLst xmlns:a="http://schemas.openxmlformats.org/drawingml/2006/main">
               <a:ext uri="{FF2B5EF4-FFF2-40B4-BE49-F238E27FC236}">
-                <a16:creationId xmlns:a16="http://schemas.microsoft.com/office/drawing/2014/main" id="{4EEC684C-64F9-486C-AA65-AF85841952B2}"/>
+                <a16:creationId xmlns:a16="http://schemas.microsoft.com/office/drawing/2014/main" id="{0AC59324-A3E1-457D-BBFF-4524787E1545}"/>
               </a:ext>
             </a:extLst>
           </p:cNvPr>
@@ -8692,7 +8031,7 @@
           <p:cNvPr id="19" name="">
             <a:extLst xmlns:a="http://schemas.openxmlformats.org/drawingml/2006/main">
               <a:ext uri="{FF2B5EF4-FFF2-40B4-BE49-F238E27FC236}">
-                <a16:creationId xmlns:a16="http://schemas.microsoft.com/office/drawing/2014/main" id="{0E6E9F5B-C048-4402-87E7-5FF8C8A2619A}"/>
+                <a16:creationId xmlns:a16="http://schemas.microsoft.com/office/drawing/2014/main" id="{7E358FED-A60E-4081-90E8-EF89A48C3B44}"/>
               </a:ext>
             </a:extLst>
           </p:cNvPr>
@@ -8742,7 +8081,7 @@
           <p:cNvPr id="20" name="">
             <a:extLst xmlns:a="http://schemas.openxmlformats.org/drawingml/2006/main">
               <a:ext uri="{FF2B5EF4-FFF2-40B4-BE49-F238E27FC236}">
-                <a16:creationId xmlns:a16="http://schemas.microsoft.com/office/drawing/2014/main" id="{8BB57AED-205F-4610-B9A8-108AECC0EF52}"/>
+                <a16:creationId xmlns:a16="http://schemas.microsoft.com/office/drawing/2014/main" id="{9A1B00AD-6195-4082-9872-C1B3A708D167}"/>
               </a:ext>
             </a:extLst>
           </p:cNvPr>
@@ -8792,7 +8131,7 @@
           <p:cNvPr id="21" name="">
             <a:extLst xmlns:a="http://schemas.openxmlformats.org/drawingml/2006/main">
               <a:ext uri="{FF2B5EF4-FFF2-40B4-BE49-F238E27FC236}">
-                <a16:creationId xmlns:a16="http://schemas.microsoft.com/office/drawing/2014/main" id="{FE2C7D61-81B4-404D-BF7A-374D80095775}"/>
+                <a16:creationId xmlns:a16="http://schemas.microsoft.com/office/drawing/2014/main" id="{BDF1328F-4205-49A4-A52E-DC87E78E18CB}"/>
               </a:ext>
             </a:extLst>
           </p:cNvPr>
@@ -8840,7 +8179,7 @@
     </p:spTree>
     <p:extLst>
       <p:ext uri="{BB962C8B-B14F-4D97-AF65-F5344CB8AC3E}">
-        <p14:creationId xmlns:p14="http://schemas.microsoft.com/office/powerpoint/2010/main" val="1156167075"/>
+        <p14:creationId xmlns:p14="http://schemas.microsoft.com/office/powerpoint/2010/main" val="1797131423"/>
       </p:ext>
     </p:extLst>
   </p:cSld>
@@ -8871,7 +8210,7 @@
           <p:cNvPr id="1" name="">
             <a:extLst xmlns:a="http://schemas.openxmlformats.org/drawingml/2006/main">
               <a:ext uri="{FF2B5EF4-FFF2-40B4-BE49-F238E27FC236}">
-                <a16:creationId xmlns:a16="http://schemas.microsoft.com/office/drawing/2014/main" id="{8715D809-CB12-4DD7-80DF-04064C8FCABC}"/>
+                <a16:creationId xmlns:a16="http://schemas.microsoft.com/office/drawing/2014/main" id="{9BCA5B21-AF06-4BFB-8718-12328EFDFB72}"/>
               </a:ext>
             </a:extLst>
           </p:cNvPr>
@@ -8904,7 +8243,7 @@
           <p:cNvPr id="2" name="">
             <a:extLst xmlns:a="http://schemas.openxmlformats.org/drawingml/2006/main">
               <a:ext uri="{FF2B5EF4-FFF2-40B4-BE49-F238E27FC236}">
-                <a16:creationId xmlns:a16="http://schemas.microsoft.com/office/drawing/2014/main" id="{191B5C88-EA59-4BEA-BB3B-D142A5C34897}"/>
+                <a16:creationId xmlns:a16="http://schemas.microsoft.com/office/drawing/2014/main" id="{3FDEF52D-8C06-4AFA-8662-6239C4FB6276}"/>
               </a:ext>
             </a:extLst>
           </p:cNvPr>
@@ -8937,7 +8276,7 @@
           <p:cNvPr id="3" name="">
             <a:extLst xmlns:a="http://schemas.openxmlformats.org/drawingml/2006/main">
               <a:ext uri="{FF2B5EF4-FFF2-40B4-BE49-F238E27FC236}">
-                <a16:creationId xmlns:a16="http://schemas.microsoft.com/office/drawing/2014/main" id="{BB7B1DE4-5C5F-4E58-8F3F-351DD19D1871}"/>
+                <a16:creationId xmlns:a16="http://schemas.microsoft.com/office/drawing/2014/main" id="{A4762E20-73F5-487B-AC72-B7F02A67F2EE}"/>
               </a:ext>
             </a:extLst>
           </p:cNvPr>
@@ -8987,7 +8326,7 @@
           <p:cNvPr id="4" name="">
             <a:extLst xmlns:a="http://schemas.openxmlformats.org/drawingml/2006/main">
               <a:ext uri="{FF2B5EF4-FFF2-40B4-BE49-F238E27FC236}">
-                <a16:creationId xmlns:a16="http://schemas.microsoft.com/office/drawing/2014/main" id="{AA9CA6DB-FAEE-4621-9BFE-070B964C9A9E}"/>
+                <a16:creationId xmlns:a16="http://schemas.microsoft.com/office/drawing/2014/main" id="{4F95CFB0-12FA-47F0-BA62-04604DB8C4B9}"/>
               </a:ext>
             </a:extLst>
           </p:cNvPr>
@@ -9037,7 +8376,7 @@
           <p:cNvPr id="5" name="">
             <a:extLst xmlns:a="http://schemas.openxmlformats.org/drawingml/2006/main">
               <a:ext uri="{FF2B5EF4-FFF2-40B4-BE49-F238E27FC236}">
-                <a16:creationId xmlns:a16="http://schemas.microsoft.com/office/drawing/2014/main" id="{A1AFE6C3-49B3-4B0B-A62A-828BEABF6305}"/>
+                <a16:creationId xmlns:a16="http://schemas.microsoft.com/office/drawing/2014/main" id="{D61507D1-1CB4-452A-8640-A45FB31AE605}"/>
               </a:ext>
             </a:extLst>
           </p:cNvPr>
@@ -9087,7 +8426,7 @@
           <p:cNvPr id="6" name="">
             <a:extLst xmlns:a="http://schemas.openxmlformats.org/drawingml/2006/main">
               <a:ext uri="{FF2B5EF4-FFF2-40B4-BE49-F238E27FC236}">
-                <a16:creationId xmlns:a16="http://schemas.microsoft.com/office/drawing/2014/main" id="{9FF57643-FB2C-4F5F-BEA6-DA7BD6D746E0}"/>
+                <a16:creationId xmlns:a16="http://schemas.microsoft.com/office/drawing/2014/main" id="{C1BD4D97-792E-46B3-8741-B9760BDCDBBF}"/>
               </a:ext>
             </a:extLst>
           </p:cNvPr>
@@ -9120,7 +8459,7 @@
           <p:cNvPr id="7" name="">
             <a:extLst xmlns:a="http://schemas.openxmlformats.org/drawingml/2006/main">
               <a:ext uri="{FF2B5EF4-FFF2-40B4-BE49-F238E27FC236}">
-                <a16:creationId xmlns:a16="http://schemas.microsoft.com/office/drawing/2014/main" id="{29978003-9C8D-4249-8395-0F651D308895}"/>
+                <a16:creationId xmlns:a16="http://schemas.microsoft.com/office/drawing/2014/main" id="{EDAFB348-A953-440E-B6D4-1732DAF9F837}"/>
               </a:ext>
             </a:extLst>
           </p:cNvPr>
@@ -9193,7 +8532,7 @@
           <p:cNvPr id="8" name="">
             <a:extLst xmlns:a="http://schemas.openxmlformats.org/drawingml/2006/main">
               <a:ext uri="{FF2B5EF4-FFF2-40B4-BE49-F238E27FC236}">
-                <a16:creationId xmlns:a16="http://schemas.microsoft.com/office/drawing/2014/main" id="{AF535099-6B88-45B9-BF09-7CD422FBF5F9}"/>
+                <a16:creationId xmlns:a16="http://schemas.microsoft.com/office/drawing/2014/main" id="{41CC40F0-1D64-450B-85D2-09CCC4AE2557}"/>
               </a:ext>
             </a:extLst>
           </p:cNvPr>
@@ -9266,7 +8605,7 @@
           <p:cNvPr id="9" name="">
             <a:extLst xmlns:a="http://schemas.openxmlformats.org/drawingml/2006/main">
               <a:ext uri="{FF2B5EF4-FFF2-40B4-BE49-F238E27FC236}">
-                <a16:creationId xmlns:a16="http://schemas.microsoft.com/office/drawing/2014/main" id="{CE4997C0-9726-4EF2-8737-21F5753EAB59}"/>
+                <a16:creationId xmlns:a16="http://schemas.microsoft.com/office/drawing/2014/main" id="{FE9E6C39-A8E2-4A2F-A1A3-117F298EA719}"/>
               </a:ext>
             </a:extLst>
           </p:cNvPr>
@@ -9339,7 +8678,7 @@
           <p:cNvPr id="10" name="">
             <a:extLst xmlns:a="http://schemas.openxmlformats.org/drawingml/2006/main">
               <a:ext uri="{FF2B5EF4-FFF2-40B4-BE49-F238E27FC236}">
-                <a16:creationId xmlns:a16="http://schemas.microsoft.com/office/drawing/2014/main" id="{79AEC0C3-F06B-4E64-BD7B-EAC2818F1F13}"/>
+                <a16:creationId xmlns:a16="http://schemas.microsoft.com/office/drawing/2014/main" id="{74A3A819-9AC4-4A04-93EA-D7E79433DA2C}"/>
               </a:ext>
             </a:extLst>
           </p:cNvPr>
@@ -9412,7 +8751,7 @@
           <p:cNvPr id="11" name="">
             <a:extLst xmlns:a="http://schemas.openxmlformats.org/drawingml/2006/main">
               <a:ext uri="{FF2B5EF4-FFF2-40B4-BE49-F238E27FC236}">
-                <a16:creationId xmlns:a16="http://schemas.microsoft.com/office/drawing/2014/main" id="{5BD2AA9C-F383-40C1-AA15-917DF6CF5B8E}"/>
+                <a16:creationId xmlns:a16="http://schemas.microsoft.com/office/drawing/2014/main" id="{B81A3423-3CAB-4F80-8A21-F5A37F18CD6D}"/>
               </a:ext>
             </a:extLst>
           </p:cNvPr>
@@ -9462,7 +8801,7 @@
           <p:cNvPr id="12" name="">
             <a:extLst xmlns:a="http://schemas.openxmlformats.org/drawingml/2006/main">
               <a:ext uri="{FF2B5EF4-FFF2-40B4-BE49-F238E27FC236}">
-                <a16:creationId xmlns:a16="http://schemas.microsoft.com/office/drawing/2014/main" id="{AED3A9DE-C41B-4B12-9FBD-CCDD681046DD}"/>
+                <a16:creationId xmlns:a16="http://schemas.microsoft.com/office/drawing/2014/main" id="{AA72A28B-BE1D-4630-8C32-E8617A5512FF}"/>
               </a:ext>
             </a:extLst>
           </p:cNvPr>
@@ -9512,7 +8851,7 @@
           <p:cNvPr id="13" name="">
             <a:extLst xmlns:a="http://schemas.openxmlformats.org/drawingml/2006/main">
               <a:ext uri="{FF2B5EF4-FFF2-40B4-BE49-F238E27FC236}">
-                <a16:creationId xmlns:a16="http://schemas.microsoft.com/office/drawing/2014/main" id="{8B6911A4-5411-4006-84A8-95B7929A6A3D}"/>
+                <a16:creationId xmlns:a16="http://schemas.microsoft.com/office/drawing/2014/main" id="{567BFC6A-30DF-4F2E-887E-27DD4DD5E7CE}"/>
               </a:ext>
             </a:extLst>
           </p:cNvPr>
@@ -9562,7 +8901,7 @@
           <p:cNvPr id="14" name="">
             <a:extLst xmlns:a="http://schemas.openxmlformats.org/drawingml/2006/main">
               <a:ext uri="{FF2B5EF4-FFF2-40B4-BE49-F238E27FC236}">
-                <a16:creationId xmlns:a16="http://schemas.microsoft.com/office/drawing/2014/main" id="{AE875712-8334-4CF2-A65F-F072846CB3DE}"/>
+                <a16:creationId xmlns:a16="http://schemas.microsoft.com/office/drawing/2014/main" id="{306D1AFC-E109-4244-8678-28A061994D35}"/>
               </a:ext>
             </a:extLst>
           </p:cNvPr>
@@ -9612,7 +8951,7 @@
           <p:cNvPr id="15" name="">
             <a:extLst xmlns:a="http://schemas.openxmlformats.org/drawingml/2006/main">
               <a:ext uri="{FF2B5EF4-FFF2-40B4-BE49-F238E27FC236}">
-                <a16:creationId xmlns:a16="http://schemas.microsoft.com/office/drawing/2014/main" id="{3348C4CC-E392-4813-9D5A-4F81974D7D3D}"/>
+                <a16:creationId xmlns:a16="http://schemas.microsoft.com/office/drawing/2014/main" id="{EF4A1466-73EC-47D1-8E0E-AC42199E1B4D}"/>
               </a:ext>
             </a:extLst>
           </p:cNvPr>
@@ -9662,7 +9001,7 @@
           <p:cNvPr id="16" name="">
             <a:extLst xmlns:a="http://schemas.openxmlformats.org/drawingml/2006/main">
               <a:ext uri="{FF2B5EF4-FFF2-40B4-BE49-F238E27FC236}">
-                <a16:creationId xmlns:a16="http://schemas.microsoft.com/office/drawing/2014/main" id="{B02B42BB-700D-477F-823B-B557B61A1C08}"/>
+                <a16:creationId xmlns:a16="http://schemas.microsoft.com/office/drawing/2014/main" id="{D723D8FC-CB4C-4FF2-A26B-E919C2C05D35}"/>
               </a:ext>
             </a:extLst>
           </p:cNvPr>
@@ -9712,7 +9051,7 @@
           <p:cNvPr id="17" name="">
             <a:extLst xmlns:a="http://schemas.openxmlformats.org/drawingml/2006/main">
               <a:ext uri="{FF2B5EF4-FFF2-40B4-BE49-F238E27FC236}">
-                <a16:creationId xmlns:a16="http://schemas.microsoft.com/office/drawing/2014/main" id="{EEE13325-3DA4-4EDC-AEAD-113691DF186E}"/>
+                <a16:creationId xmlns:a16="http://schemas.microsoft.com/office/drawing/2014/main" id="{75A56ECC-F66D-4B69-B478-F9480E4567FD}"/>
               </a:ext>
             </a:extLst>
           </p:cNvPr>
@@ -9762,7 +9101,7 @@
           <p:cNvPr id="18" name="">
             <a:extLst xmlns:a="http://schemas.openxmlformats.org/drawingml/2006/main">
               <a:ext uri="{FF2B5EF4-FFF2-40B4-BE49-F238E27FC236}">
-                <a16:creationId xmlns:a16="http://schemas.microsoft.com/office/drawing/2014/main" id="{4BE7DFFD-FE42-4989-A53F-B65F65789375}"/>
+                <a16:creationId xmlns:a16="http://schemas.microsoft.com/office/drawing/2014/main" id="{20F659C3-91BE-459D-95AF-7747D6AA4ABE}"/>
               </a:ext>
             </a:extLst>
           </p:cNvPr>
@@ -9810,7 +9149,7 @@
     </p:spTree>
     <p:extLst>
       <p:ext uri="{BB962C8B-B14F-4D97-AF65-F5344CB8AC3E}">
-        <p14:creationId xmlns:p14="http://schemas.microsoft.com/office/powerpoint/2010/main" val="1590057028"/>
+        <p14:creationId xmlns:p14="http://schemas.microsoft.com/office/powerpoint/2010/main" val="1840370542"/>
       </p:ext>
     </p:extLst>
   </p:cSld>
@@ -9841,7 +9180,7 @@
           <p:cNvPr id="1" name="">
             <a:extLst xmlns:a="http://schemas.openxmlformats.org/drawingml/2006/main">
               <a:ext uri="{FF2B5EF4-FFF2-40B4-BE49-F238E27FC236}">
-                <a16:creationId xmlns:a16="http://schemas.microsoft.com/office/drawing/2014/main" id="{9DD08D88-B2E9-433C-BDF8-6FDEAB1A410D}"/>
+                <a16:creationId xmlns:a16="http://schemas.microsoft.com/office/drawing/2014/main" id="{7ABB204B-B51F-48AF-9D5B-CDFB802200F1}"/>
               </a:ext>
             </a:extLst>
           </p:cNvPr>
@@ -9874,7 +9213,7 @@
           <p:cNvPr id="2" name="">
             <a:extLst xmlns:a="http://schemas.openxmlformats.org/drawingml/2006/main">
               <a:ext uri="{FF2B5EF4-FFF2-40B4-BE49-F238E27FC236}">
-                <a16:creationId xmlns:a16="http://schemas.microsoft.com/office/drawing/2014/main" id="{2DE583B8-030D-47D5-BA16-5B52850F13B4}"/>
+                <a16:creationId xmlns:a16="http://schemas.microsoft.com/office/drawing/2014/main" id="{07DB763A-B72D-4F9A-B9EB-80FC8346A2FB}"/>
               </a:ext>
             </a:extLst>
           </p:cNvPr>
@@ -9907,7 +9246,7 @@
           <p:cNvPr id="3" name="">
             <a:extLst xmlns:a="http://schemas.openxmlformats.org/drawingml/2006/main">
               <a:ext uri="{FF2B5EF4-FFF2-40B4-BE49-F238E27FC236}">
-                <a16:creationId xmlns:a16="http://schemas.microsoft.com/office/drawing/2014/main" id="{DB09C7FA-1762-41EB-9D1C-7F6F8370ED32}"/>
+                <a16:creationId xmlns:a16="http://schemas.microsoft.com/office/drawing/2014/main" id="{9F44F04C-904A-4622-A5BC-3D66C0678117}"/>
               </a:ext>
             </a:extLst>
           </p:cNvPr>
@@ -9957,7 +9296,7 @@
           <p:cNvPr id="4" name="">
             <a:extLst xmlns:a="http://schemas.openxmlformats.org/drawingml/2006/main">
               <a:ext uri="{FF2B5EF4-FFF2-40B4-BE49-F238E27FC236}">
-                <a16:creationId xmlns:a16="http://schemas.microsoft.com/office/drawing/2014/main" id="{E98B1949-160B-4872-AF59-0EAA121FEF35}"/>
+                <a16:creationId xmlns:a16="http://schemas.microsoft.com/office/drawing/2014/main" id="{710BDB90-49ED-431B-B276-333D7E810816}"/>
               </a:ext>
             </a:extLst>
           </p:cNvPr>
@@ -10007,7 +9346,7 @@
           <p:cNvPr id="5" name="">
             <a:extLst xmlns:a="http://schemas.openxmlformats.org/drawingml/2006/main">
               <a:ext uri="{FF2B5EF4-FFF2-40B4-BE49-F238E27FC236}">
-                <a16:creationId xmlns:a16="http://schemas.microsoft.com/office/drawing/2014/main" id="{985DB350-8A47-4FBD-A163-0180D83741F6}"/>
+                <a16:creationId xmlns:a16="http://schemas.microsoft.com/office/drawing/2014/main" id="{D909E167-849B-4E76-9ED6-532053FDA8B6}"/>
               </a:ext>
             </a:extLst>
           </p:cNvPr>
@@ -10057,7 +9396,7 @@
           <p:cNvPr id="6" name="">
             <a:extLst xmlns:a="http://schemas.openxmlformats.org/drawingml/2006/main">
               <a:ext uri="{FF2B5EF4-FFF2-40B4-BE49-F238E27FC236}">
-                <a16:creationId xmlns:a16="http://schemas.microsoft.com/office/drawing/2014/main" id="{9D91F65C-E10E-4318-AF4F-A632C39F871D}"/>
+                <a16:creationId xmlns:a16="http://schemas.microsoft.com/office/drawing/2014/main" id="{E4CDE3F1-3851-4A1B-A30D-2751959D0A30}"/>
               </a:ext>
             </a:extLst>
           </p:cNvPr>
@@ -10094,7 +9433,7 @@
           <p:nvPr/>
         </p:nvPicPr>
         <p:blipFill>
-          <a:blip xmlns:r="http://schemas.openxmlformats.org/officeDocument/2006/relationships" xmlns:a="http://schemas.openxmlformats.org/drawingml/2006/main" r:embed="R8605fb3f3d6a4c81"/>
+          <a:blip xmlns:r="http://schemas.openxmlformats.org/officeDocument/2006/relationships" xmlns:a="http://schemas.openxmlformats.org/drawingml/2006/main" r:embed="Rbae0463816004ce6"/>
           <a:stretch xmlns:a="http://schemas.openxmlformats.org/drawingml/2006/main"/>
         </p:blipFill>
         <p:spPr>
@@ -10116,7 +9455,7 @@
           <p:nvPr/>
         </p:nvPicPr>
         <p:blipFill>
-          <a:blip xmlns:r="http://schemas.openxmlformats.org/officeDocument/2006/relationships" xmlns:a="http://schemas.openxmlformats.org/drawingml/2006/main" r:embed="R8243dd4cc14f4647"/>
+          <a:blip xmlns:r="http://schemas.openxmlformats.org/officeDocument/2006/relationships" xmlns:a="http://schemas.openxmlformats.org/drawingml/2006/main" r:embed="R4680dce22fea4f87"/>
           <a:stretch xmlns:a="http://schemas.openxmlformats.org/drawingml/2006/main"/>
         </p:blipFill>
         <p:spPr>
@@ -10134,7 +9473,7 @@
           <p:cNvPr id="9" name="">
             <a:extLst xmlns:a="http://schemas.openxmlformats.org/drawingml/2006/main">
               <a:ext uri="{FF2B5EF4-FFF2-40B4-BE49-F238E27FC236}">
-                <a16:creationId xmlns:a16="http://schemas.microsoft.com/office/drawing/2014/main" id="{ED8879B8-7F07-40EF-8109-4876BD9D1C46}"/>
+                <a16:creationId xmlns:a16="http://schemas.microsoft.com/office/drawing/2014/main" id="{3EBE6B27-622C-4304-B8CD-E026D1842150}"/>
               </a:ext>
             </a:extLst>
           </p:cNvPr>
@@ -10184,7 +9523,7 @@
           <p:cNvPr id="10" name="">
             <a:extLst xmlns:a="http://schemas.openxmlformats.org/drawingml/2006/main">
               <a:ext uri="{FF2B5EF4-FFF2-40B4-BE49-F238E27FC236}">
-                <a16:creationId xmlns:a16="http://schemas.microsoft.com/office/drawing/2014/main" id="{AE36F1C7-AFF5-4773-A780-A52AD03DBD2E}"/>
+                <a16:creationId xmlns:a16="http://schemas.microsoft.com/office/drawing/2014/main" id="{A9875317-F603-4AAB-8589-363757D1E080}"/>
               </a:ext>
             </a:extLst>
           </p:cNvPr>
@@ -10234,7 +9573,7 @@
           <p:cNvPr id="11" name="">
             <a:extLst xmlns:a="http://schemas.openxmlformats.org/drawingml/2006/main">
               <a:ext uri="{FF2B5EF4-FFF2-40B4-BE49-F238E27FC236}">
-                <a16:creationId xmlns:a16="http://schemas.microsoft.com/office/drawing/2014/main" id="{2456D069-A154-4EE9-9E02-2C69D6AD4B57}"/>
+                <a16:creationId xmlns:a16="http://schemas.microsoft.com/office/drawing/2014/main" id="{251CAB95-2734-4012-84C5-4227A4DF1A54}"/>
               </a:ext>
             </a:extLst>
           </p:cNvPr>
@@ -10282,7 +9621,7 @@
     </p:spTree>
     <p:extLst>
       <p:ext uri="{BB962C8B-B14F-4D97-AF65-F5344CB8AC3E}">
-        <p14:creationId xmlns:p14="http://schemas.microsoft.com/office/powerpoint/2010/main" val="214338349"/>
+        <p14:creationId xmlns:p14="http://schemas.microsoft.com/office/powerpoint/2010/main" val="2027460347"/>
       </p:ext>
     </p:extLst>
   </p:cSld>
@@ -10313,7 +9652,7 @@
           <p:cNvPr id="1" name="">
             <a:extLst xmlns:a="http://schemas.openxmlformats.org/drawingml/2006/main">
               <a:ext uri="{FF2B5EF4-FFF2-40B4-BE49-F238E27FC236}">
-                <a16:creationId xmlns:a16="http://schemas.microsoft.com/office/drawing/2014/main" id="{76940EC9-F67B-4C1B-B888-F6505A70F5CF}"/>
+                <a16:creationId xmlns:a16="http://schemas.microsoft.com/office/drawing/2014/main" id="{9F27E282-E35B-4425-A9BA-F2615A773C9B}"/>
               </a:ext>
             </a:extLst>
           </p:cNvPr>
@@ -10346,7 +9685,7 @@
           <p:cNvPr id="2" name="">
             <a:extLst xmlns:a="http://schemas.openxmlformats.org/drawingml/2006/main">
               <a:ext uri="{FF2B5EF4-FFF2-40B4-BE49-F238E27FC236}">
-                <a16:creationId xmlns:a16="http://schemas.microsoft.com/office/drawing/2014/main" id="{FC3A32C2-5C12-46FF-80D1-6C2635EDD544}"/>
+                <a16:creationId xmlns:a16="http://schemas.microsoft.com/office/drawing/2014/main" id="{5EF28BC0-ABC9-4B87-84EB-78313CC66D18}"/>
               </a:ext>
             </a:extLst>
           </p:cNvPr>
@@ -10379,7 +9718,7 @@
           <p:cNvPr id="3" name="">
             <a:extLst xmlns:a="http://schemas.openxmlformats.org/drawingml/2006/main">
               <a:ext uri="{FF2B5EF4-FFF2-40B4-BE49-F238E27FC236}">
-                <a16:creationId xmlns:a16="http://schemas.microsoft.com/office/drawing/2014/main" id="{69E5B0EB-BF59-40D5-BE1B-930325FDB5C3}"/>
+                <a16:creationId xmlns:a16="http://schemas.microsoft.com/office/drawing/2014/main" id="{0233269A-9448-4CBD-9D0D-E7E971DF1BDE}"/>
               </a:ext>
             </a:extLst>
           </p:cNvPr>
@@ -10429,7 +9768,7 @@
           <p:cNvPr id="4" name="">
             <a:extLst xmlns:a="http://schemas.openxmlformats.org/drawingml/2006/main">
               <a:ext uri="{FF2B5EF4-FFF2-40B4-BE49-F238E27FC236}">
-                <a16:creationId xmlns:a16="http://schemas.microsoft.com/office/drawing/2014/main" id="{0C65932C-E090-44B8-B8B3-0292FD556266}"/>
+                <a16:creationId xmlns:a16="http://schemas.microsoft.com/office/drawing/2014/main" id="{1BC4D69C-E2CF-463C-803B-466A05A01938}"/>
               </a:ext>
             </a:extLst>
           </p:cNvPr>
@@ -10479,7 +9818,7 @@
           <p:cNvPr id="5" name="">
             <a:extLst xmlns:a="http://schemas.openxmlformats.org/drawingml/2006/main">
               <a:ext uri="{FF2B5EF4-FFF2-40B4-BE49-F238E27FC236}">
-                <a16:creationId xmlns:a16="http://schemas.microsoft.com/office/drawing/2014/main" id="{8F83C945-9863-4C55-8271-D30DB4EF6DDE}"/>
+                <a16:creationId xmlns:a16="http://schemas.microsoft.com/office/drawing/2014/main" id="{0B989576-EB8A-42E7-B839-350AD591E044}"/>
               </a:ext>
             </a:extLst>
           </p:cNvPr>
@@ -10529,7 +9868,7 @@
           <p:cNvPr id="6" name="">
             <a:extLst xmlns:a="http://schemas.openxmlformats.org/drawingml/2006/main">
               <a:ext uri="{FF2B5EF4-FFF2-40B4-BE49-F238E27FC236}">
-                <a16:creationId xmlns:a16="http://schemas.microsoft.com/office/drawing/2014/main" id="{740D586F-54F9-435F-B637-569141B049A1}"/>
+                <a16:creationId xmlns:a16="http://schemas.microsoft.com/office/drawing/2014/main" id="{72217F6C-CA62-4A06-A44A-F61ADD922131}"/>
               </a:ext>
             </a:extLst>
           </p:cNvPr>
@@ -10566,7 +9905,7 @@
           <p:nvPr/>
         </p:nvPicPr>
         <p:blipFill>
-          <a:blip xmlns:r="http://schemas.openxmlformats.org/officeDocument/2006/relationships" xmlns:a="http://schemas.openxmlformats.org/drawingml/2006/main" r:embed="Rd2a5a6fee06549f8"/>
+          <a:blip xmlns:r="http://schemas.openxmlformats.org/officeDocument/2006/relationships" xmlns:a="http://schemas.openxmlformats.org/drawingml/2006/main" r:embed="Rb8c43e95394a46c4"/>
           <a:stretch xmlns:a="http://schemas.openxmlformats.org/drawingml/2006/main"/>
         </p:blipFill>
         <p:spPr>
@@ -10588,7 +9927,7 @@
           <p:nvPr/>
         </p:nvPicPr>
         <p:blipFill>
-          <a:blip xmlns:r="http://schemas.openxmlformats.org/officeDocument/2006/relationships" xmlns:a="http://schemas.openxmlformats.org/drawingml/2006/main" r:embed="Radad2be5cc7447e7"/>
+          <a:blip xmlns:r="http://schemas.openxmlformats.org/officeDocument/2006/relationships" xmlns:a="http://schemas.openxmlformats.org/drawingml/2006/main" r:embed="R932d2cc19c0c4bd9"/>
           <a:stretch xmlns:a="http://schemas.openxmlformats.org/drawingml/2006/main"/>
         </p:blipFill>
         <p:spPr>
@@ -10606,7 +9945,7 @@
           <p:cNvPr id="9" name="">
             <a:extLst xmlns:a="http://schemas.openxmlformats.org/drawingml/2006/main">
               <a:ext uri="{FF2B5EF4-FFF2-40B4-BE49-F238E27FC236}">
-                <a16:creationId xmlns:a16="http://schemas.microsoft.com/office/drawing/2014/main" id="{0519E0B8-D1EA-4DB4-8F87-9332D44DD185}"/>
+                <a16:creationId xmlns:a16="http://schemas.microsoft.com/office/drawing/2014/main" id="{ECBFA49F-F4C7-4840-B585-28D016A40392}"/>
               </a:ext>
             </a:extLst>
           </p:cNvPr>
@@ -10656,7 +9995,7 @@
           <p:cNvPr id="10" name="">
             <a:extLst xmlns:a="http://schemas.openxmlformats.org/drawingml/2006/main">
               <a:ext uri="{FF2B5EF4-FFF2-40B4-BE49-F238E27FC236}">
-                <a16:creationId xmlns:a16="http://schemas.microsoft.com/office/drawing/2014/main" id="{FBB7B468-7E70-447C-BD5B-CEFDD37EC683}"/>
+                <a16:creationId xmlns:a16="http://schemas.microsoft.com/office/drawing/2014/main" id="{B6681A35-0E0B-4028-918D-87EAE7116A38}"/>
               </a:ext>
             </a:extLst>
           </p:cNvPr>
@@ -10706,7 +10045,7 @@
           <p:cNvPr id="11" name="">
             <a:extLst xmlns:a="http://schemas.openxmlformats.org/drawingml/2006/main">
               <a:ext uri="{FF2B5EF4-FFF2-40B4-BE49-F238E27FC236}">
-                <a16:creationId xmlns:a16="http://schemas.microsoft.com/office/drawing/2014/main" id="{FA83EB7B-E984-4633-87CB-DCFC9D0A3E0D}"/>
+                <a16:creationId xmlns:a16="http://schemas.microsoft.com/office/drawing/2014/main" id="{35F41270-5A5B-4A6F-BF70-8E7CA6626997}"/>
               </a:ext>
             </a:extLst>
           </p:cNvPr>
@@ -10756,7 +10095,7 @@
           <p:cNvPr id="12" name="">
             <a:extLst xmlns:a="http://schemas.openxmlformats.org/drawingml/2006/main">
               <a:ext uri="{FF2B5EF4-FFF2-40B4-BE49-F238E27FC236}">
-                <a16:creationId xmlns:a16="http://schemas.microsoft.com/office/drawing/2014/main" id="{22A147EB-B7C5-4713-86E0-7C6B4070904C}"/>
+                <a16:creationId xmlns:a16="http://schemas.microsoft.com/office/drawing/2014/main" id="{8DEDA2AA-04E3-4D3E-8B24-E15B7B445A4A}"/>
               </a:ext>
             </a:extLst>
           </p:cNvPr>
@@ -10806,7 +10145,7 @@
           <p:cNvPr id="13" name="">
             <a:extLst xmlns:a="http://schemas.openxmlformats.org/drawingml/2006/main">
               <a:ext uri="{FF2B5EF4-FFF2-40B4-BE49-F238E27FC236}">
-                <a16:creationId xmlns:a16="http://schemas.microsoft.com/office/drawing/2014/main" id="{91D34437-32CF-4B6C-8635-F389AA29EA37}"/>
+                <a16:creationId xmlns:a16="http://schemas.microsoft.com/office/drawing/2014/main" id="{9E2A2AF4-F476-49ED-94BA-42A65E1DD6C0}"/>
               </a:ext>
             </a:extLst>
           </p:cNvPr>
@@ -10856,7 +10195,7 @@
           <p:cNvPr id="14" name="">
             <a:extLst xmlns:a="http://schemas.openxmlformats.org/drawingml/2006/main">
               <a:ext uri="{FF2B5EF4-FFF2-40B4-BE49-F238E27FC236}">
-                <a16:creationId xmlns:a16="http://schemas.microsoft.com/office/drawing/2014/main" id="{4127DADC-93F8-4917-8C29-A4C3A94281E1}"/>
+                <a16:creationId xmlns:a16="http://schemas.microsoft.com/office/drawing/2014/main" id="{CC94488B-9748-4F2D-B6F1-ECA94E776B28}"/>
               </a:ext>
             </a:extLst>
           </p:cNvPr>
@@ -10906,7 +10245,7 @@
           <p:cNvPr id="15" name="">
             <a:extLst xmlns:a="http://schemas.openxmlformats.org/drawingml/2006/main">
               <a:ext uri="{FF2B5EF4-FFF2-40B4-BE49-F238E27FC236}">
-                <a16:creationId xmlns:a16="http://schemas.microsoft.com/office/drawing/2014/main" id="{64E063AA-4585-44D6-980B-F8FBC3F04F62}"/>
+                <a16:creationId xmlns:a16="http://schemas.microsoft.com/office/drawing/2014/main" id="{0B3CA7FC-57CA-4206-8AFE-9B0D9DB7D8C0}"/>
               </a:ext>
             </a:extLst>
           </p:cNvPr>
@@ -10956,7 +10295,7 @@
           <p:cNvPr id="16" name="">
             <a:extLst xmlns:a="http://schemas.openxmlformats.org/drawingml/2006/main">
               <a:ext uri="{FF2B5EF4-FFF2-40B4-BE49-F238E27FC236}">
-                <a16:creationId xmlns:a16="http://schemas.microsoft.com/office/drawing/2014/main" id="{437E42EE-971C-473A-BC4A-D1800DB952C8}"/>
+                <a16:creationId xmlns:a16="http://schemas.microsoft.com/office/drawing/2014/main" id="{0708F80C-E6CA-459A-A48E-2DFB04BB9358}"/>
               </a:ext>
             </a:extLst>
           </p:cNvPr>
@@ -11004,7 +10343,7 @@
     </p:spTree>
     <p:extLst>
       <p:ext uri="{BB962C8B-B14F-4D97-AF65-F5344CB8AC3E}">
-        <p14:creationId xmlns:p14="http://schemas.microsoft.com/office/powerpoint/2010/main" val="19905190"/>
+        <p14:creationId xmlns:p14="http://schemas.microsoft.com/office/powerpoint/2010/main" val="496628497"/>
       </p:ext>
     </p:extLst>
   </p:cSld>

</xml_diff>

<commit_message>
Remove unused GPU hardware references
</commit_message>
<xml_diff>
--- a/final/Marianovskiy_VKR_ADAS_defense_final.pptx
+++ b/final/Marianovskiy_VKR_ADAS_defense_final.pptx
@@ -2,22 +2,22 @@
 <file path=ppt/presentation.xml><?xml version="1.0" encoding="utf-8"?>
 <p:presentation xmlns:p="http://schemas.openxmlformats.org/presentationml/2006/main">
   <p:sldMasterIdLst>
-    <p:sldMasterId xmlns:r="http://schemas.openxmlformats.org/officeDocument/2006/relationships" id="2147483648" r:id="Ra644b56182c14b82"/>
+    <p:sldMasterId xmlns:r="http://schemas.openxmlformats.org/officeDocument/2006/relationships" id="2147483648" r:id="R9aae7d2ba2774388"/>
   </p:sldMasterIdLst>
   <p:notesMasterIdLst>
-    <p:notesMasterId xmlns:r="http://schemas.openxmlformats.org/officeDocument/2006/relationships" r:id="R76a472fe55ab4dc5"/>
+    <p:notesMasterId xmlns:r="http://schemas.openxmlformats.org/officeDocument/2006/relationships" r:id="R58d3fa63c4e84653"/>
   </p:notesMasterIdLst>
   <p:sldIdLst>
-    <p:sldId xmlns:r="http://schemas.openxmlformats.org/officeDocument/2006/relationships" id="256" r:id="R8478e05eb7bf4a5e"/>
-    <p:sldId xmlns:r="http://schemas.openxmlformats.org/officeDocument/2006/relationships" id="257" r:id="R48ec1ddf62704bf6"/>
-    <p:sldId xmlns:r="http://schemas.openxmlformats.org/officeDocument/2006/relationships" id="258" r:id="Raa3e6aa1e31743eb"/>
-    <p:sldId xmlns:r="http://schemas.openxmlformats.org/officeDocument/2006/relationships" id="259" r:id="R524177e72786411b"/>
-    <p:sldId xmlns:r="http://schemas.openxmlformats.org/officeDocument/2006/relationships" id="260" r:id="Ra516421690064d4a"/>
-    <p:sldId xmlns:r="http://schemas.openxmlformats.org/officeDocument/2006/relationships" id="261" r:id="R5e591596bf1847d5"/>
-    <p:sldId xmlns:r="http://schemas.openxmlformats.org/officeDocument/2006/relationships" id="262" r:id="R0142a38768f6466c"/>
-    <p:sldId xmlns:r="http://schemas.openxmlformats.org/officeDocument/2006/relationships" id="263" r:id="R3aebc35854fc4d43"/>
-    <p:sldId xmlns:r="http://schemas.openxmlformats.org/officeDocument/2006/relationships" id="264" r:id="Ref4c0801adc64b1d"/>
-    <p:sldId xmlns:r="http://schemas.openxmlformats.org/officeDocument/2006/relationships" id="265" r:id="Raae73d58eed74dd3"/>
+    <p:sldId xmlns:r="http://schemas.openxmlformats.org/officeDocument/2006/relationships" id="256" r:id="R80ec1fc4697545ca"/>
+    <p:sldId xmlns:r="http://schemas.openxmlformats.org/officeDocument/2006/relationships" id="257" r:id="R509acdea8d824c4e"/>
+    <p:sldId xmlns:r="http://schemas.openxmlformats.org/officeDocument/2006/relationships" id="258" r:id="Rb270e860558445d8"/>
+    <p:sldId xmlns:r="http://schemas.openxmlformats.org/officeDocument/2006/relationships" id="259" r:id="Rfcbabc10124d4710"/>
+    <p:sldId xmlns:r="http://schemas.openxmlformats.org/officeDocument/2006/relationships" id="260" r:id="Re4ad861c7ff644f6"/>
+    <p:sldId xmlns:r="http://schemas.openxmlformats.org/officeDocument/2006/relationships" id="261" r:id="R7c9d3970c6eb43a0"/>
+    <p:sldId xmlns:r="http://schemas.openxmlformats.org/officeDocument/2006/relationships" id="262" r:id="R24cc5b64aab04d19"/>
+    <p:sldId xmlns:r="http://schemas.openxmlformats.org/officeDocument/2006/relationships" id="263" r:id="R90c5b178f2e64769"/>
+    <p:sldId xmlns:r="http://schemas.openxmlformats.org/officeDocument/2006/relationships" id="264" r:id="R2d7907affbd84acd"/>
+    <p:sldId xmlns:r="http://schemas.openxmlformats.org/officeDocument/2006/relationships" id="265" r:id="Rd966c30b35784476"/>
   </p:sldIdLst>
   <p:sldSz cx="12192000" cy="6858000"/>
   <p:notesSz cx="6858000" cy="9144000"/>
@@ -992,7 +992,7 @@
           </a:p>
           <a:p xmlns:a="http://schemas.openxmlformats.org/drawingml/2006/main">
             <a:r>
-              <a:t>GPU RX7700XT можно назвать только как ресурс будущего этапа. Текущие метрики получены на табличной модели и не зависят от GPU.</a:t>
+              <a:t>Текущие метрики получены на табличной модели и не зависят от будущего raw sensor контура.</a:t>
             </a:r>
           </a:p>
         </p:txBody>
@@ -1285,7 +1285,7 @@
   </p:cSld>
   <p:clrMap bg1="lt1" tx1="dk1" bg2="lt2" tx2="dk2" accent1="accent1" accent2="accent2" accent3="accent3" accent4="accent4" accent5="accent5" accent6="accent6" hlink="hlink" folHlink="folHlink"/>
   <p:sldLayoutIdLst>
-    <p:sldLayoutId xmlns:r="http://schemas.openxmlformats.org/officeDocument/2006/relationships" id="2147483649" r:id="R422659b84faf4131"/>
+    <p:sldLayoutId xmlns:r="http://schemas.openxmlformats.org/officeDocument/2006/relationships" id="2147483649" r:id="Rccab59d42afa4df1"/>
   </p:sldLayoutIdLst>
   <p:txStyles>
     <p:titleStyle>
@@ -1840,7 +1840,7 @@
           <p:nvPr/>
         </p:nvPicPr>
         <p:blipFill>
-          <a:blip xmlns:r="http://schemas.openxmlformats.org/officeDocument/2006/relationships" xmlns:a="http://schemas.openxmlformats.org/drawingml/2006/main" r:embed="R3c6034a429e14509"/>
+          <a:blip xmlns:r="http://schemas.openxmlformats.org/officeDocument/2006/relationships" xmlns:a="http://schemas.openxmlformats.org/drawingml/2006/main" r:embed="R5fb0730724aa4f55"/>
           <a:srcRect xmlns:a="http://schemas.openxmlformats.org/drawingml/2006/main" l="7" t="0" r="7" b="0"/>
           <a:stretch xmlns:a="http://schemas.openxmlformats.org/drawingml/2006/main">
             <a:fillRect l="0" t="0" r="0" b="0"/>
@@ -1859,7 +1859,7 @@
     </p:spTree>
     <p:extLst>
       <p:ext uri="{BB962C8B-B14F-4D97-AF65-F5344CB8AC3E}">
-        <p14:creationId xmlns:p14="http://schemas.microsoft.com/office/powerpoint/2010/main" val="626212809"/>
+        <p14:creationId xmlns:p14="http://schemas.microsoft.com/office/powerpoint/2010/main" val="390945636"/>
       </p:ext>
     </p:extLst>
   </p:cSld>
@@ -1890,7 +1890,7 @@
           <p:cNvPr id="1" name="">
             <a:extLst xmlns:a="http://schemas.openxmlformats.org/drawingml/2006/main">
               <a:ext uri="{FF2B5EF4-FFF2-40B4-BE49-F238E27FC236}">
-                <a16:creationId xmlns:a16="http://schemas.microsoft.com/office/drawing/2014/main" id="{A03F390F-CE89-460F-B094-F63FE9758B29}"/>
+                <a16:creationId xmlns:a16="http://schemas.microsoft.com/office/drawing/2014/main" id="{29FCED7F-AFCA-42AF-8B92-B1A88BADDB3A}"/>
               </a:ext>
             </a:extLst>
           </p:cNvPr>
@@ -1923,7 +1923,7 @@
           <p:cNvPr id="2" name="">
             <a:extLst xmlns:a="http://schemas.openxmlformats.org/drawingml/2006/main">
               <a:ext uri="{FF2B5EF4-FFF2-40B4-BE49-F238E27FC236}">
-                <a16:creationId xmlns:a16="http://schemas.microsoft.com/office/drawing/2014/main" id="{63E4F2B6-F9F1-453D-B2D2-188C13704793}"/>
+                <a16:creationId xmlns:a16="http://schemas.microsoft.com/office/drawing/2014/main" id="{7C68074D-F152-4DEE-929A-3D4982445F7E}"/>
               </a:ext>
             </a:extLst>
           </p:cNvPr>
@@ -1956,7 +1956,7 @@
           <p:cNvPr id="3" name="">
             <a:extLst xmlns:a="http://schemas.openxmlformats.org/drawingml/2006/main">
               <a:ext uri="{FF2B5EF4-FFF2-40B4-BE49-F238E27FC236}">
-                <a16:creationId xmlns:a16="http://schemas.microsoft.com/office/drawing/2014/main" id="{81A6B097-EFFD-41E7-A9FC-240F0DE86114}"/>
+                <a16:creationId xmlns:a16="http://schemas.microsoft.com/office/drawing/2014/main" id="{259CFE7F-1637-4ECE-B4A1-4DEE4F75DE28}"/>
               </a:ext>
             </a:extLst>
           </p:cNvPr>
@@ -2006,7 +2006,7 @@
           <p:cNvPr id="4" name="">
             <a:extLst xmlns:a="http://schemas.openxmlformats.org/drawingml/2006/main">
               <a:ext uri="{FF2B5EF4-FFF2-40B4-BE49-F238E27FC236}">
-                <a16:creationId xmlns:a16="http://schemas.microsoft.com/office/drawing/2014/main" id="{06670AC9-716D-4A7A-90B7-D4B5F39BE09E}"/>
+                <a16:creationId xmlns:a16="http://schemas.microsoft.com/office/drawing/2014/main" id="{B0C39C5B-A52B-43A2-90E6-7A7B68A90908}"/>
               </a:ext>
             </a:extLst>
           </p:cNvPr>
@@ -2056,7 +2056,7 @@
           <p:cNvPr id="5" name="">
             <a:extLst xmlns:a="http://schemas.openxmlformats.org/drawingml/2006/main">
               <a:ext uri="{FF2B5EF4-FFF2-40B4-BE49-F238E27FC236}">
-                <a16:creationId xmlns:a16="http://schemas.microsoft.com/office/drawing/2014/main" id="{70600F8E-8B29-41F9-B8C7-C362F066B8A4}"/>
+                <a16:creationId xmlns:a16="http://schemas.microsoft.com/office/drawing/2014/main" id="{9118285B-0668-43AF-A81B-C980E271E3AD}"/>
               </a:ext>
             </a:extLst>
           </p:cNvPr>
@@ -2106,7 +2106,7 @@
           <p:cNvPr id="6" name="">
             <a:extLst xmlns:a="http://schemas.openxmlformats.org/drawingml/2006/main">
               <a:ext uri="{FF2B5EF4-FFF2-40B4-BE49-F238E27FC236}">
-                <a16:creationId xmlns:a16="http://schemas.microsoft.com/office/drawing/2014/main" id="{0CE5A1A3-10BD-4D02-AA69-3F5722DCCC2D}"/>
+                <a16:creationId xmlns:a16="http://schemas.microsoft.com/office/drawing/2014/main" id="{87B0CE78-054A-4059-BE53-B9AED8393C10}"/>
               </a:ext>
             </a:extLst>
           </p:cNvPr>
@@ -2139,7 +2139,7 @@
           <p:cNvPr id="7" name="">
             <a:extLst xmlns:a="http://schemas.openxmlformats.org/drawingml/2006/main">
               <a:ext uri="{FF2B5EF4-FFF2-40B4-BE49-F238E27FC236}">
-                <a16:creationId xmlns:a16="http://schemas.microsoft.com/office/drawing/2014/main" id="{8326F67C-26B6-4B3C-9679-AEB8D8C70932}"/>
+                <a16:creationId xmlns:a16="http://schemas.microsoft.com/office/drawing/2014/main" id="{36E45613-4572-438F-9B70-46D1D94A0CC8}"/>
               </a:ext>
             </a:extLst>
           </p:cNvPr>
@@ -2212,7 +2212,7 @@
           <p:cNvPr id="8" name="">
             <a:extLst xmlns:a="http://schemas.openxmlformats.org/drawingml/2006/main">
               <a:ext uri="{FF2B5EF4-FFF2-40B4-BE49-F238E27FC236}">
-                <a16:creationId xmlns:a16="http://schemas.microsoft.com/office/drawing/2014/main" id="{30FA06B1-C7B8-44F0-A9CA-99AA97D69A47}"/>
+                <a16:creationId xmlns:a16="http://schemas.microsoft.com/office/drawing/2014/main" id="{95B32431-AAC2-47E4-9BE9-1C5BA906CB5B}"/>
               </a:ext>
             </a:extLst>
           </p:cNvPr>
@@ -2285,7 +2285,7 @@
           <p:cNvPr id="9" name="">
             <a:extLst xmlns:a="http://schemas.openxmlformats.org/drawingml/2006/main">
               <a:ext uri="{FF2B5EF4-FFF2-40B4-BE49-F238E27FC236}">
-                <a16:creationId xmlns:a16="http://schemas.microsoft.com/office/drawing/2014/main" id="{2200AF00-A6DA-42C5-ADE7-61CCDBB7276B}"/>
+                <a16:creationId xmlns:a16="http://schemas.microsoft.com/office/drawing/2014/main" id="{1811EC74-94C5-4942-B803-858BB4E4F2D1}"/>
               </a:ext>
             </a:extLst>
           </p:cNvPr>
@@ -2358,7 +2358,7 @@
           <p:cNvPr id="10" name="">
             <a:extLst xmlns:a="http://schemas.openxmlformats.org/drawingml/2006/main">
               <a:ext uri="{FF2B5EF4-FFF2-40B4-BE49-F238E27FC236}">
-                <a16:creationId xmlns:a16="http://schemas.microsoft.com/office/drawing/2014/main" id="{47152A31-5B13-48EF-A677-5F715927DD21}"/>
+                <a16:creationId xmlns:a16="http://schemas.microsoft.com/office/drawing/2014/main" id="{7C3A14EE-0FED-452C-837A-0F9F525E5A69}"/>
               </a:ext>
             </a:extLst>
           </p:cNvPr>
@@ -2408,7 +2408,7 @@
           <p:cNvPr id="11" name="">
             <a:extLst xmlns:a="http://schemas.openxmlformats.org/drawingml/2006/main">
               <a:ext uri="{FF2B5EF4-FFF2-40B4-BE49-F238E27FC236}">
-                <a16:creationId xmlns:a16="http://schemas.microsoft.com/office/drawing/2014/main" id="{F40221D7-32F9-4B41-AAE5-ECBE8632F9A6}"/>
+                <a16:creationId xmlns:a16="http://schemas.microsoft.com/office/drawing/2014/main" id="{FC2F8937-FD4E-4391-809F-B73834F01015}"/>
               </a:ext>
             </a:extLst>
           </p:cNvPr>
@@ -2458,7 +2458,7 @@
           <p:cNvPr id="12" name="">
             <a:extLst xmlns:a="http://schemas.openxmlformats.org/drawingml/2006/main">
               <a:ext uri="{FF2B5EF4-FFF2-40B4-BE49-F238E27FC236}">
-                <a16:creationId xmlns:a16="http://schemas.microsoft.com/office/drawing/2014/main" id="{1A002555-7FA2-4283-9D8F-409F3EBE4E2D}"/>
+                <a16:creationId xmlns:a16="http://schemas.microsoft.com/office/drawing/2014/main" id="{7A00BED1-C639-45AB-9D30-76619213F090}"/>
               </a:ext>
             </a:extLst>
           </p:cNvPr>
@@ -2508,7 +2508,7 @@
           <p:cNvPr id="13" name="">
             <a:extLst xmlns:a="http://schemas.openxmlformats.org/drawingml/2006/main">
               <a:ext uri="{FF2B5EF4-FFF2-40B4-BE49-F238E27FC236}">
-                <a16:creationId xmlns:a16="http://schemas.microsoft.com/office/drawing/2014/main" id="{E7B87548-4B95-4BED-8715-F9F12A5ECF9B}"/>
+                <a16:creationId xmlns:a16="http://schemas.microsoft.com/office/drawing/2014/main" id="{5667A4AE-BC34-491F-8F51-41E3CB4CD91C}"/>
               </a:ext>
             </a:extLst>
           </p:cNvPr>
@@ -2558,7 +2558,7 @@
           <p:cNvPr id="14" name="">
             <a:extLst xmlns:a="http://schemas.openxmlformats.org/drawingml/2006/main">
               <a:ext uri="{FF2B5EF4-FFF2-40B4-BE49-F238E27FC236}">
-                <a16:creationId xmlns:a16="http://schemas.microsoft.com/office/drawing/2014/main" id="{D7523F2D-A24A-4CE6-ABA8-D96647E59DA3}"/>
+                <a16:creationId xmlns:a16="http://schemas.microsoft.com/office/drawing/2014/main" id="{C242014A-1489-4A9C-94A3-4706B2125441}"/>
               </a:ext>
             </a:extLst>
           </p:cNvPr>
@@ -2608,7 +2608,7 @@
           <p:cNvPr id="15" name="">
             <a:extLst xmlns:a="http://schemas.openxmlformats.org/drawingml/2006/main">
               <a:ext uri="{FF2B5EF4-FFF2-40B4-BE49-F238E27FC236}">
-                <a16:creationId xmlns:a16="http://schemas.microsoft.com/office/drawing/2014/main" id="{B03BBDE1-0F16-4D8B-9BD8-D9D60413ABE9}"/>
+                <a16:creationId xmlns:a16="http://schemas.microsoft.com/office/drawing/2014/main" id="{4772B7DB-FFE5-4B23-80EE-61AD5AEF22E9}"/>
               </a:ext>
             </a:extLst>
           </p:cNvPr>
@@ -2658,7 +2658,7 @@
           <p:cNvPr id="16" name="">
             <a:extLst xmlns:a="http://schemas.openxmlformats.org/drawingml/2006/main">
               <a:ext uri="{FF2B5EF4-FFF2-40B4-BE49-F238E27FC236}">
-                <a16:creationId xmlns:a16="http://schemas.microsoft.com/office/drawing/2014/main" id="{730D0954-3B77-4A1B-A9BF-4F73C7F1DDEA}"/>
+                <a16:creationId xmlns:a16="http://schemas.microsoft.com/office/drawing/2014/main" id="{806AF20D-365D-4AC9-8224-21AA37BD54DE}"/>
               </a:ext>
             </a:extLst>
           </p:cNvPr>
@@ -2708,7 +2708,7 @@
           <p:cNvPr id="17" name="">
             <a:extLst xmlns:a="http://schemas.openxmlformats.org/drawingml/2006/main">
               <a:ext uri="{FF2B5EF4-FFF2-40B4-BE49-F238E27FC236}">
-                <a16:creationId xmlns:a16="http://schemas.microsoft.com/office/drawing/2014/main" id="{BFA248C2-D0AA-43B3-8D9A-6A5B63BDE09C}"/>
+                <a16:creationId xmlns:a16="http://schemas.microsoft.com/office/drawing/2014/main" id="{D6EAD8AC-A301-445E-B3E9-09879E8393A6}"/>
               </a:ext>
             </a:extLst>
           </p:cNvPr>
@@ -2756,7 +2756,7 @@
     </p:spTree>
     <p:extLst>
       <p:ext uri="{BB962C8B-B14F-4D97-AF65-F5344CB8AC3E}">
-        <p14:creationId xmlns:p14="http://schemas.microsoft.com/office/powerpoint/2010/main" val="47410639"/>
+        <p14:creationId xmlns:p14="http://schemas.microsoft.com/office/powerpoint/2010/main" val="322850923"/>
       </p:ext>
     </p:extLst>
   </p:cSld>
@@ -2787,7 +2787,7 @@
           <p:cNvPr id="1" name="">
             <a:extLst xmlns:a="http://schemas.openxmlformats.org/drawingml/2006/main">
               <a:ext uri="{FF2B5EF4-FFF2-40B4-BE49-F238E27FC236}">
-                <a16:creationId xmlns:a16="http://schemas.microsoft.com/office/drawing/2014/main" id="{89D47186-A17F-40E4-ACD2-DF1434EEC21A}"/>
+                <a16:creationId xmlns:a16="http://schemas.microsoft.com/office/drawing/2014/main" id="{FFB22A4A-D1DA-4556-B2FA-6AF6189F0537}"/>
               </a:ext>
             </a:extLst>
           </p:cNvPr>
@@ -2820,7 +2820,7 @@
           <p:cNvPr id="2" name="">
             <a:extLst xmlns:a="http://schemas.openxmlformats.org/drawingml/2006/main">
               <a:ext uri="{FF2B5EF4-FFF2-40B4-BE49-F238E27FC236}">
-                <a16:creationId xmlns:a16="http://schemas.microsoft.com/office/drawing/2014/main" id="{6EE3202C-FB8D-41C1-946D-555723A4DB67}"/>
+                <a16:creationId xmlns:a16="http://schemas.microsoft.com/office/drawing/2014/main" id="{040C5612-1EB6-4E20-8B70-95ABB2CFA8D7}"/>
               </a:ext>
             </a:extLst>
           </p:cNvPr>
@@ -2853,7 +2853,7 @@
           <p:cNvPr id="3" name="">
             <a:extLst xmlns:a="http://schemas.openxmlformats.org/drawingml/2006/main">
               <a:ext uri="{FF2B5EF4-FFF2-40B4-BE49-F238E27FC236}">
-                <a16:creationId xmlns:a16="http://schemas.microsoft.com/office/drawing/2014/main" id="{6CF78C84-554F-443B-8E45-2909B94E6D11}"/>
+                <a16:creationId xmlns:a16="http://schemas.microsoft.com/office/drawing/2014/main" id="{12E0BABB-0B58-4AFB-8273-FB3A9D5AB5D5}"/>
               </a:ext>
             </a:extLst>
           </p:cNvPr>
@@ -2903,7 +2903,7 @@
           <p:cNvPr id="4" name="">
             <a:extLst xmlns:a="http://schemas.openxmlformats.org/drawingml/2006/main">
               <a:ext uri="{FF2B5EF4-FFF2-40B4-BE49-F238E27FC236}">
-                <a16:creationId xmlns:a16="http://schemas.microsoft.com/office/drawing/2014/main" id="{D67E438D-5E49-43FF-8F7E-848DE3303D1E}"/>
+                <a16:creationId xmlns:a16="http://schemas.microsoft.com/office/drawing/2014/main" id="{803BAB30-7C65-4868-8633-2999494CC4FD}"/>
               </a:ext>
             </a:extLst>
           </p:cNvPr>
@@ -2953,7 +2953,7 @@
           <p:cNvPr id="5" name="">
             <a:extLst xmlns:a="http://schemas.openxmlformats.org/drawingml/2006/main">
               <a:ext uri="{FF2B5EF4-FFF2-40B4-BE49-F238E27FC236}">
-                <a16:creationId xmlns:a16="http://schemas.microsoft.com/office/drawing/2014/main" id="{CBAA012F-0B95-47A2-8DC3-05C4E259A5CF}"/>
+                <a16:creationId xmlns:a16="http://schemas.microsoft.com/office/drawing/2014/main" id="{F02E1DAB-C73A-4AFC-BA06-CA135B09735E}"/>
               </a:ext>
             </a:extLst>
           </p:cNvPr>
@@ -3003,7 +3003,7 @@
           <p:cNvPr id="6" name="">
             <a:extLst xmlns:a="http://schemas.openxmlformats.org/drawingml/2006/main">
               <a:ext uri="{FF2B5EF4-FFF2-40B4-BE49-F238E27FC236}">
-                <a16:creationId xmlns:a16="http://schemas.microsoft.com/office/drawing/2014/main" id="{D548B235-5F84-4AC4-B144-0F3C40260EE8}"/>
+                <a16:creationId xmlns:a16="http://schemas.microsoft.com/office/drawing/2014/main" id="{B1F0F4EC-D114-4E52-95AB-E872CA44EAA7}"/>
               </a:ext>
             </a:extLst>
           </p:cNvPr>
@@ -3036,7 +3036,7 @@
           <p:cNvPr id="7" name="">
             <a:extLst xmlns:a="http://schemas.openxmlformats.org/drawingml/2006/main">
               <a:ext uri="{FF2B5EF4-FFF2-40B4-BE49-F238E27FC236}">
-                <a16:creationId xmlns:a16="http://schemas.microsoft.com/office/drawing/2014/main" id="{DDB77D43-0204-40D2-B593-171844EB206A}"/>
+                <a16:creationId xmlns:a16="http://schemas.microsoft.com/office/drawing/2014/main" id="{1E6DC212-8253-45FB-900F-C74092762652}"/>
               </a:ext>
             </a:extLst>
           </p:cNvPr>
@@ -3086,7 +3086,7 @@
           <p:cNvPr id="8" name="">
             <a:extLst xmlns:a="http://schemas.openxmlformats.org/drawingml/2006/main">
               <a:ext uri="{FF2B5EF4-FFF2-40B4-BE49-F238E27FC236}">
-                <a16:creationId xmlns:a16="http://schemas.microsoft.com/office/drawing/2014/main" id="{A0241DA1-92C6-46B3-81F4-99ABD4510C42}"/>
+                <a16:creationId xmlns:a16="http://schemas.microsoft.com/office/drawing/2014/main" id="{878F3843-0362-4BCC-8052-36C1C559D2C8}"/>
               </a:ext>
             </a:extLst>
           </p:cNvPr>
@@ -3136,7 +3136,7 @@
           <p:cNvPr id="9" name="">
             <a:extLst xmlns:a="http://schemas.openxmlformats.org/drawingml/2006/main">
               <a:ext uri="{FF2B5EF4-FFF2-40B4-BE49-F238E27FC236}">
-                <a16:creationId xmlns:a16="http://schemas.microsoft.com/office/drawing/2014/main" id="{EB5696A6-FA74-4278-8D6B-D08D4B27A349}"/>
+                <a16:creationId xmlns:a16="http://schemas.microsoft.com/office/drawing/2014/main" id="{E348DEF6-2049-466E-A692-BA43317E8CE5}"/>
               </a:ext>
             </a:extLst>
           </p:cNvPr>
@@ -3186,7 +3186,7 @@
           <p:cNvPr id="10" name="">
             <a:extLst xmlns:a="http://schemas.openxmlformats.org/drawingml/2006/main">
               <a:ext uri="{FF2B5EF4-FFF2-40B4-BE49-F238E27FC236}">
-                <a16:creationId xmlns:a16="http://schemas.microsoft.com/office/drawing/2014/main" id="{A65E46EA-BC4A-4A21-8A27-7AE90F887D8B}"/>
+                <a16:creationId xmlns:a16="http://schemas.microsoft.com/office/drawing/2014/main" id="{08C6CA52-8DBE-448E-BB4A-D1023050085A}"/>
               </a:ext>
             </a:extLst>
           </p:cNvPr>
@@ -3236,7 +3236,7 @@
           <p:cNvPr id="11" name="">
             <a:extLst xmlns:a="http://schemas.openxmlformats.org/drawingml/2006/main">
               <a:ext uri="{FF2B5EF4-FFF2-40B4-BE49-F238E27FC236}">
-                <a16:creationId xmlns:a16="http://schemas.microsoft.com/office/drawing/2014/main" id="{2D90F92D-FEE0-4BC8-8D1B-64BC2624D6E2}"/>
+                <a16:creationId xmlns:a16="http://schemas.microsoft.com/office/drawing/2014/main" id="{5100F8D9-E4AA-4831-ABFD-EB6B1F1E8B06}"/>
               </a:ext>
             </a:extLst>
           </p:cNvPr>
@@ -3286,7 +3286,7 @@
           <p:cNvPr id="12" name="">
             <a:extLst xmlns:a="http://schemas.openxmlformats.org/drawingml/2006/main">
               <a:ext uri="{FF2B5EF4-FFF2-40B4-BE49-F238E27FC236}">
-                <a16:creationId xmlns:a16="http://schemas.microsoft.com/office/drawing/2014/main" id="{19CF1A67-A177-4EE9-B94A-1261F9A071F7}"/>
+                <a16:creationId xmlns:a16="http://schemas.microsoft.com/office/drawing/2014/main" id="{C6C8FA12-D45B-4EFB-B075-DE1D9D86DE1F}"/>
               </a:ext>
             </a:extLst>
           </p:cNvPr>
@@ -3336,7 +3336,7 @@
           <p:cNvPr id="13" name="">
             <a:extLst xmlns:a="http://schemas.openxmlformats.org/drawingml/2006/main">
               <a:ext uri="{FF2B5EF4-FFF2-40B4-BE49-F238E27FC236}">
-                <a16:creationId xmlns:a16="http://schemas.microsoft.com/office/drawing/2014/main" id="{9BD9B112-1BD7-4C86-9676-C199955E0CFA}"/>
+                <a16:creationId xmlns:a16="http://schemas.microsoft.com/office/drawing/2014/main" id="{209541A9-820C-47E5-A9AD-D5050936C67C}"/>
               </a:ext>
             </a:extLst>
           </p:cNvPr>
@@ -3409,7 +3409,7 @@
           <p:cNvPr id="14" name="">
             <a:extLst xmlns:a="http://schemas.openxmlformats.org/drawingml/2006/main">
               <a:ext uri="{FF2B5EF4-FFF2-40B4-BE49-F238E27FC236}">
-                <a16:creationId xmlns:a16="http://schemas.microsoft.com/office/drawing/2014/main" id="{DDEBCE89-46D3-41DA-ABDF-3468B70F323E}"/>
+                <a16:creationId xmlns:a16="http://schemas.microsoft.com/office/drawing/2014/main" id="{3B17C25D-BF57-46D6-978F-7CCFE0EA50C1}"/>
               </a:ext>
             </a:extLst>
           </p:cNvPr>
@@ -3482,7 +3482,7 @@
           <p:cNvPr id="15" name="">
             <a:extLst xmlns:a="http://schemas.openxmlformats.org/drawingml/2006/main">
               <a:ext uri="{FF2B5EF4-FFF2-40B4-BE49-F238E27FC236}">
-                <a16:creationId xmlns:a16="http://schemas.microsoft.com/office/drawing/2014/main" id="{1223E719-65D1-44C8-98C4-827F31FDB4E9}"/>
+                <a16:creationId xmlns:a16="http://schemas.microsoft.com/office/drawing/2014/main" id="{8777F4F8-1A97-4154-ABB8-CFF636B51847}"/>
               </a:ext>
             </a:extLst>
           </p:cNvPr>
@@ -3555,7 +3555,7 @@
           <p:cNvPr id="16" name="">
             <a:extLst xmlns:a="http://schemas.openxmlformats.org/drawingml/2006/main">
               <a:ext uri="{FF2B5EF4-FFF2-40B4-BE49-F238E27FC236}">
-                <a16:creationId xmlns:a16="http://schemas.microsoft.com/office/drawing/2014/main" id="{E5957105-7793-4BFD-8CDB-E8FF1DBB360D}"/>
+                <a16:creationId xmlns:a16="http://schemas.microsoft.com/office/drawing/2014/main" id="{FEADC5A1-41EE-4EBF-90C4-7D50D27921BE}"/>
               </a:ext>
             </a:extLst>
           </p:cNvPr>
@@ -3605,7 +3605,7 @@
           <p:cNvPr id="17" name="">
             <a:extLst xmlns:a="http://schemas.openxmlformats.org/drawingml/2006/main">
               <a:ext uri="{FF2B5EF4-FFF2-40B4-BE49-F238E27FC236}">
-                <a16:creationId xmlns:a16="http://schemas.microsoft.com/office/drawing/2014/main" id="{382A2E24-99D7-4936-9D8F-3BEBA87E6E8A}"/>
+                <a16:creationId xmlns:a16="http://schemas.microsoft.com/office/drawing/2014/main" id="{582581ED-F1A2-4488-91F2-2C345E8A826D}"/>
               </a:ext>
             </a:extLst>
           </p:cNvPr>
@@ -3653,7 +3653,7 @@
     </p:spTree>
     <p:extLst>
       <p:ext uri="{BB962C8B-B14F-4D97-AF65-F5344CB8AC3E}">
-        <p14:creationId xmlns:p14="http://schemas.microsoft.com/office/powerpoint/2010/main" val="839456318"/>
+        <p14:creationId xmlns:p14="http://schemas.microsoft.com/office/powerpoint/2010/main" val="1643309535"/>
       </p:ext>
     </p:extLst>
   </p:cSld>
@@ -3684,7 +3684,7 @@
           <p:cNvPr id="1" name="">
             <a:extLst xmlns:a="http://schemas.openxmlformats.org/drawingml/2006/main">
               <a:ext uri="{FF2B5EF4-FFF2-40B4-BE49-F238E27FC236}">
-                <a16:creationId xmlns:a16="http://schemas.microsoft.com/office/drawing/2014/main" id="{6A553D68-94C7-433F-A307-051F495A127E}"/>
+                <a16:creationId xmlns:a16="http://schemas.microsoft.com/office/drawing/2014/main" id="{9F96B9B3-D44B-4E4E-A756-ADC6EAF75363}"/>
               </a:ext>
             </a:extLst>
           </p:cNvPr>
@@ -3717,7 +3717,7 @@
           <p:cNvPr id="2" name="">
             <a:extLst xmlns:a="http://schemas.openxmlformats.org/drawingml/2006/main">
               <a:ext uri="{FF2B5EF4-FFF2-40B4-BE49-F238E27FC236}">
-                <a16:creationId xmlns:a16="http://schemas.microsoft.com/office/drawing/2014/main" id="{CB2F06E3-27D8-4D0F-8266-348C4995F294}"/>
+                <a16:creationId xmlns:a16="http://schemas.microsoft.com/office/drawing/2014/main" id="{F28F91DC-FE2D-4DE4-BFDB-26B44B0C287E}"/>
               </a:ext>
             </a:extLst>
           </p:cNvPr>
@@ -3750,7 +3750,7 @@
           <p:cNvPr id="3" name="">
             <a:extLst xmlns:a="http://schemas.openxmlformats.org/drawingml/2006/main">
               <a:ext uri="{FF2B5EF4-FFF2-40B4-BE49-F238E27FC236}">
-                <a16:creationId xmlns:a16="http://schemas.microsoft.com/office/drawing/2014/main" id="{178F740A-8CAC-4E7B-9253-08000B151E3D}"/>
+                <a16:creationId xmlns:a16="http://schemas.microsoft.com/office/drawing/2014/main" id="{9353EBD8-CF0B-4E64-97E0-4DBCA434540A}"/>
               </a:ext>
             </a:extLst>
           </p:cNvPr>
@@ -3800,7 +3800,7 @@
           <p:cNvPr id="4" name="">
             <a:extLst xmlns:a="http://schemas.openxmlformats.org/drawingml/2006/main">
               <a:ext uri="{FF2B5EF4-FFF2-40B4-BE49-F238E27FC236}">
-                <a16:creationId xmlns:a16="http://schemas.microsoft.com/office/drawing/2014/main" id="{6CDDAE4D-FDF1-48BA-A8E0-D055E8BCB0D5}"/>
+                <a16:creationId xmlns:a16="http://schemas.microsoft.com/office/drawing/2014/main" id="{5D3E844D-858F-466A-97AC-E5B63A722623}"/>
               </a:ext>
             </a:extLst>
           </p:cNvPr>
@@ -3850,7 +3850,7 @@
           <p:cNvPr id="5" name="">
             <a:extLst xmlns:a="http://schemas.openxmlformats.org/drawingml/2006/main">
               <a:ext uri="{FF2B5EF4-FFF2-40B4-BE49-F238E27FC236}">
-                <a16:creationId xmlns:a16="http://schemas.microsoft.com/office/drawing/2014/main" id="{8FE2DD2B-8F83-4100-9431-A9C7B15BFD0B}"/>
+                <a16:creationId xmlns:a16="http://schemas.microsoft.com/office/drawing/2014/main" id="{0FBF192D-51B8-488C-B021-DAF628742604}"/>
               </a:ext>
             </a:extLst>
           </p:cNvPr>
@@ -3900,7 +3900,7 @@
           <p:cNvPr id="6" name="">
             <a:extLst xmlns:a="http://schemas.openxmlformats.org/drawingml/2006/main">
               <a:ext uri="{FF2B5EF4-FFF2-40B4-BE49-F238E27FC236}">
-                <a16:creationId xmlns:a16="http://schemas.microsoft.com/office/drawing/2014/main" id="{F8A46BC2-B3F5-4EE5-8368-F49BE73F65C6}"/>
+                <a16:creationId xmlns:a16="http://schemas.microsoft.com/office/drawing/2014/main" id="{121317BF-431D-4C85-8E21-72E020DB41B0}"/>
               </a:ext>
             </a:extLst>
           </p:cNvPr>
@@ -3933,7 +3933,7 @@
           <p:cNvPr id="7" name="">
             <a:extLst xmlns:a="http://schemas.openxmlformats.org/drawingml/2006/main">
               <a:ext uri="{FF2B5EF4-FFF2-40B4-BE49-F238E27FC236}">
-                <a16:creationId xmlns:a16="http://schemas.microsoft.com/office/drawing/2014/main" id="{69C9F0BD-0C5F-4F74-8560-0647907ABE6D}"/>
+                <a16:creationId xmlns:a16="http://schemas.microsoft.com/office/drawing/2014/main" id="{38FB6343-DB89-4575-91A9-7B9352A1487D}"/>
               </a:ext>
             </a:extLst>
           </p:cNvPr>
@@ -4006,7 +4006,7 @@
           <p:cNvPr id="8" name="">
             <a:extLst xmlns:a="http://schemas.openxmlformats.org/drawingml/2006/main">
               <a:ext uri="{FF2B5EF4-FFF2-40B4-BE49-F238E27FC236}">
-                <a16:creationId xmlns:a16="http://schemas.microsoft.com/office/drawing/2014/main" id="{2210B215-69D9-42DF-946D-0E69B334747E}"/>
+                <a16:creationId xmlns:a16="http://schemas.microsoft.com/office/drawing/2014/main" id="{2D770EBA-B403-4B52-9105-9F589D9E6FCC}"/>
               </a:ext>
             </a:extLst>
           </p:cNvPr>
@@ -4079,7 +4079,7 @@
           <p:cNvPr id="9" name="">
             <a:extLst xmlns:a="http://schemas.openxmlformats.org/drawingml/2006/main">
               <a:ext uri="{FF2B5EF4-FFF2-40B4-BE49-F238E27FC236}">
-                <a16:creationId xmlns:a16="http://schemas.microsoft.com/office/drawing/2014/main" id="{11976134-2839-4008-B655-66E07271698A}"/>
+                <a16:creationId xmlns:a16="http://schemas.microsoft.com/office/drawing/2014/main" id="{6983120E-F712-4755-9AD5-3E60B4455CC8}"/>
               </a:ext>
             </a:extLst>
           </p:cNvPr>
@@ -4152,7 +4152,7 @@
           <p:cNvPr id="10" name="">
             <a:extLst xmlns:a="http://schemas.openxmlformats.org/drawingml/2006/main">
               <a:ext uri="{FF2B5EF4-FFF2-40B4-BE49-F238E27FC236}">
-                <a16:creationId xmlns:a16="http://schemas.microsoft.com/office/drawing/2014/main" id="{CBA99BDA-01CC-4E39-99AD-A8D3C7ED3EC1}"/>
+                <a16:creationId xmlns:a16="http://schemas.microsoft.com/office/drawing/2014/main" id="{0775EEDA-DE4C-45AE-89D7-9B9C820F0D9C}"/>
               </a:ext>
             </a:extLst>
           </p:cNvPr>
@@ -4202,7 +4202,7 @@
           <p:cNvPr id="11" name="">
             <a:extLst xmlns:a="http://schemas.openxmlformats.org/drawingml/2006/main">
               <a:ext uri="{FF2B5EF4-FFF2-40B4-BE49-F238E27FC236}">
-                <a16:creationId xmlns:a16="http://schemas.microsoft.com/office/drawing/2014/main" id="{2B555291-DFA3-45C3-9C73-435FFDE72F6F}"/>
+                <a16:creationId xmlns:a16="http://schemas.microsoft.com/office/drawing/2014/main" id="{AFBEB18F-B308-4152-B571-6E98B4457AA0}"/>
               </a:ext>
             </a:extLst>
           </p:cNvPr>
@@ -4252,7 +4252,7 @@
           <p:cNvPr id="12" name="">
             <a:extLst xmlns:a="http://schemas.openxmlformats.org/drawingml/2006/main">
               <a:ext uri="{FF2B5EF4-FFF2-40B4-BE49-F238E27FC236}">
-                <a16:creationId xmlns:a16="http://schemas.microsoft.com/office/drawing/2014/main" id="{F5E67281-A453-47C8-AE8F-8697DC3975E6}"/>
+                <a16:creationId xmlns:a16="http://schemas.microsoft.com/office/drawing/2014/main" id="{981AD8C3-9517-48DF-B360-DDF979764FEF}"/>
               </a:ext>
             </a:extLst>
           </p:cNvPr>
@@ -4302,7 +4302,7 @@
           <p:cNvPr id="13" name="">
             <a:extLst xmlns:a="http://schemas.openxmlformats.org/drawingml/2006/main">
               <a:ext uri="{FF2B5EF4-FFF2-40B4-BE49-F238E27FC236}">
-                <a16:creationId xmlns:a16="http://schemas.microsoft.com/office/drawing/2014/main" id="{01BB40F2-691E-4304-8856-76A2E7B1BD11}"/>
+                <a16:creationId xmlns:a16="http://schemas.microsoft.com/office/drawing/2014/main" id="{0ACB7E04-5A94-40BB-BA76-167FC954EB0C}"/>
               </a:ext>
             </a:extLst>
           </p:cNvPr>
@@ -4352,7 +4352,7 @@
           <p:cNvPr id="14" name="">
             <a:extLst xmlns:a="http://schemas.openxmlformats.org/drawingml/2006/main">
               <a:ext uri="{FF2B5EF4-FFF2-40B4-BE49-F238E27FC236}">
-                <a16:creationId xmlns:a16="http://schemas.microsoft.com/office/drawing/2014/main" id="{DEA1E794-E240-4098-AA94-2EA5E4324313}"/>
+                <a16:creationId xmlns:a16="http://schemas.microsoft.com/office/drawing/2014/main" id="{4B2CFB74-6D47-45E0-8E5C-F410A4374430}"/>
               </a:ext>
             </a:extLst>
           </p:cNvPr>
@@ -4402,7 +4402,7 @@
           <p:cNvPr id="15" name="">
             <a:extLst xmlns:a="http://schemas.openxmlformats.org/drawingml/2006/main">
               <a:ext uri="{FF2B5EF4-FFF2-40B4-BE49-F238E27FC236}">
-                <a16:creationId xmlns:a16="http://schemas.microsoft.com/office/drawing/2014/main" id="{5BEB625B-2050-4FEB-A632-3915D4CFC245}"/>
+                <a16:creationId xmlns:a16="http://schemas.microsoft.com/office/drawing/2014/main" id="{1FBFFD6D-E1E3-418F-834C-F01DDD963F91}"/>
               </a:ext>
             </a:extLst>
           </p:cNvPr>
@@ -4452,7 +4452,7 @@
           <p:cNvPr id="16" name="">
             <a:extLst xmlns:a="http://schemas.openxmlformats.org/drawingml/2006/main">
               <a:ext uri="{FF2B5EF4-FFF2-40B4-BE49-F238E27FC236}">
-                <a16:creationId xmlns:a16="http://schemas.microsoft.com/office/drawing/2014/main" id="{6F08A541-1B74-4D85-BFF7-E77CE6D673A8}"/>
+                <a16:creationId xmlns:a16="http://schemas.microsoft.com/office/drawing/2014/main" id="{0365E979-1860-422F-8507-B814348B0549}"/>
               </a:ext>
             </a:extLst>
           </p:cNvPr>
@@ -4502,7 +4502,7 @@
           <p:cNvPr id="17" name="">
             <a:extLst xmlns:a="http://schemas.openxmlformats.org/drawingml/2006/main">
               <a:ext uri="{FF2B5EF4-FFF2-40B4-BE49-F238E27FC236}">
-                <a16:creationId xmlns:a16="http://schemas.microsoft.com/office/drawing/2014/main" id="{E64B2408-73BA-4E6D-99ED-05DEB51BB234}"/>
+                <a16:creationId xmlns:a16="http://schemas.microsoft.com/office/drawing/2014/main" id="{41AA6DA4-D0CB-4CEE-91E8-5702DB10F404}"/>
               </a:ext>
             </a:extLst>
           </p:cNvPr>
@@ -4550,7 +4550,7 @@
     </p:spTree>
     <p:extLst>
       <p:ext uri="{BB962C8B-B14F-4D97-AF65-F5344CB8AC3E}">
-        <p14:creationId xmlns:p14="http://schemas.microsoft.com/office/powerpoint/2010/main" val="922235970"/>
+        <p14:creationId xmlns:p14="http://schemas.microsoft.com/office/powerpoint/2010/main" val="919634816"/>
       </p:ext>
     </p:extLst>
   </p:cSld>
@@ -4581,7 +4581,7 @@
           <p:cNvPr id="1" name="">
             <a:extLst xmlns:a="http://schemas.openxmlformats.org/drawingml/2006/main">
               <a:ext uri="{FF2B5EF4-FFF2-40B4-BE49-F238E27FC236}">
-                <a16:creationId xmlns:a16="http://schemas.microsoft.com/office/drawing/2014/main" id="{88E1561A-C8B2-460E-B2C5-3E3C66B71B21}"/>
+                <a16:creationId xmlns:a16="http://schemas.microsoft.com/office/drawing/2014/main" id="{3BEDC386-FEE1-4681-A0EE-779EB4DBD6CA}"/>
               </a:ext>
             </a:extLst>
           </p:cNvPr>
@@ -4614,7 +4614,7 @@
           <p:cNvPr id="2" name="">
             <a:extLst xmlns:a="http://schemas.openxmlformats.org/drawingml/2006/main">
               <a:ext uri="{FF2B5EF4-FFF2-40B4-BE49-F238E27FC236}">
-                <a16:creationId xmlns:a16="http://schemas.microsoft.com/office/drawing/2014/main" id="{071003EC-5ED7-4F0C-B80A-C6AFC6DDACB3}"/>
+                <a16:creationId xmlns:a16="http://schemas.microsoft.com/office/drawing/2014/main" id="{B43848BA-92B8-4263-8F6E-9DC398C7A1D3}"/>
               </a:ext>
             </a:extLst>
           </p:cNvPr>
@@ -4647,7 +4647,7 @@
           <p:cNvPr id="3" name="">
             <a:extLst xmlns:a="http://schemas.openxmlformats.org/drawingml/2006/main">
               <a:ext uri="{FF2B5EF4-FFF2-40B4-BE49-F238E27FC236}">
-                <a16:creationId xmlns:a16="http://schemas.microsoft.com/office/drawing/2014/main" id="{7A8786B5-A18C-49B6-BDB9-8CEE7DD2CC2D}"/>
+                <a16:creationId xmlns:a16="http://schemas.microsoft.com/office/drawing/2014/main" id="{B4EE1A5E-9DA0-4F76-9293-3361A27DA549}"/>
               </a:ext>
             </a:extLst>
           </p:cNvPr>
@@ -4697,7 +4697,7 @@
           <p:cNvPr id="4" name="">
             <a:extLst xmlns:a="http://schemas.openxmlformats.org/drawingml/2006/main">
               <a:ext uri="{FF2B5EF4-FFF2-40B4-BE49-F238E27FC236}">
-                <a16:creationId xmlns:a16="http://schemas.microsoft.com/office/drawing/2014/main" id="{4A3C3455-1E11-458B-BFE5-2E698302023D}"/>
+                <a16:creationId xmlns:a16="http://schemas.microsoft.com/office/drawing/2014/main" id="{0CEAEEA4-65D1-44B0-8F40-8AB983AD6A79}"/>
               </a:ext>
             </a:extLst>
           </p:cNvPr>
@@ -4747,7 +4747,7 @@
           <p:cNvPr id="5" name="">
             <a:extLst xmlns:a="http://schemas.openxmlformats.org/drawingml/2006/main">
               <a:ext uri="{FF2B5EF4-FFF2-40B4-BE49-F238E27FC236}">
-                <a16:creationId xmlns:a16="http://schemas.microsoft.com/office/drawing/2014/main" id="{DAD85349-9BDA-4C71-95BD-D7806CE42CBF}"/>
+                <a16:creationId xmlns:a16="http://schemas.microsoft.com/office/drawing/2014/main" id="{0C3E8392-D6A6-412A-9EE2-C73A5E556A50}"/>
               </a:ext>
             </a:extLst>
           </p:cNvPr>
@@ -4797,7 +4797,7 @@
           <p:cNvPr id="6" name="">
             <a:extLst xmlns:a="http://schemas.openxmlformats.org/drawingml/2006/main">
               <a:ext uri="{FF2B5EF4-FFF2-40B4-BE49-F238E27FC236}">
-                <a16:creationId xmlns:a16="http://schemas.microsoft.com/office/drawing/2014/main" id="{50143179-F7CB-4828-A75A-88586BE0774D}"/>
+                <a16:creationId xmlns:a16="http://schemas.microsoft.com/office/drawing/2014/main" id="{2E0835A1-03BB-42FB-98D1-37085FB1C56F}"/>
               </a:ext>
             </a:extLst>
           </p:cNvPr>
@@ -4834,7 +4834,7 @@
           <p:nvPr/>
         </p:nvPicPr>
         <p:blipFill>
-          <a:blip xmlns:r="http://schemas.openxmlformats.org/officeDocument/2006/relationships" xmlns:a="http://schemas.openxmlformats.org/drawingml/2006/main" r:embed="Rc70bd3169750469f"/>
+          <a:blip xmlns:r="http://schemas.openxmlformats.org/officeDocument/2006/relationships" xmlns:a="http://schemas.openxmlformats.org/drawingml/2006/main" r:embed="R862613548af14adc"/>
           <a:stretch xmlns:a="http://schemas.openxmlformats.org/drawingml/2006/main"/>
         </p:blipFill>
         <p:spPr>
@@ -4852,7 +4852,7 @@
           <p:cNvPr id="8" name="">
             <a:extLst xmlns:a="http://schemas.openxmlformats.org/drawingml/2006/main">
               <a:ext uri="{FF2B5EF4-FFF2-40B4-BE49-F238E27FC236}">
-                <a16:creationId xmlns:a16="http://schemas.microsoft.com/office/drawing/2014/main" id="{39B605EF-0151-4B20-8C30-2605D7512E2A}"/>
+                <a16:creationId xmlns:a16="http://schemas.microsoft.com/office/drawing/2014/main" id="{177E9753-977D-4993-A589-862B6CDE634F}"/>
               </a:ext>
             </a:extLst>
           </p:cNvPr>
@@ -4902,7 +4902,7 @@
           <p:cNvPr id="9" name="">
             <a:extLst xmlns:a="http://schemas.openxmlformats.org/drawingml/2006/main">
               <a:ext uri="{FF2B5EF4-FFF2-40B4-BE49-F238E27FC236}">
-                <a16:creationId xmlns:a16="http://schemas.microsoft.com/office/drawing/2014/main" id="{A93D7919-6985-4E25-BA20-5002B17FBECA}"/>
+                <a16:creationId xmlns:a16="http://schemas.microsoft.com/office/drawing/2014/main" id="{02F8EC7B-BFC1-44EE-99EF-B5A014FA3201}"/>
               </a:ext>
             </a:extLst>
           </p:cNvPr>
@@ -4952,7 +4952,7 @@
           <p:cNvPr id="10" name="">
             <a:extLst xmlns:a="http://schemas.openxmlformats.org/drawingml/2006/main">
               <a:ext uri="{FF2B5EF4-FFF2-40B4-BE49-F238E27FC236}">
-                <a16:creationId xmlns:a16="http://schemas.microsoft.com/office/drawing/2014/main" id="{1C0B543C-27BD-4BCC-930B-4A208C8897F8}"/>
+                <a16:creationId xmlns:a16="http://schemas.microsoft.com/office/drawing/2014/main" id="{C2E4B1EF-3513-4FAB-A976-8159B2C321EF}"/>
               </a:ext>
             </a:extLst>
           </p:cNvPr>
@@ -5002,7 +5002,7 @@
           <p:cNvPr id="11" name="">
             <a:extLst xmlns:a="http://schemas.openxmlformats.org/drawingml/2006/main">
               <a:ext uri="{FF2B5EF4-FFF2-40B4-BE49-F238E27FC236}">
-                <a16:creationId xmlns:a16="http://schemas.microsoft.com/office/drawing/2014/main" id="{5E82BE6D-5664-4498-AD04-4755C7658B0E}"/>
+                <a16:creationId xmlns:a16="http://schemas.microsoft.com/office/drawing/2014/main" id="{D0ABD336-247A-4C1D-8229-85845A4A2B07}"/>
               </a:ext>
             </a:extLst>
           </p:cNvPr>
@@ -5052,7 +5052,7 @@
           <p:cNvPr id="12" name="">
             <a:extLst xmlns:a="http://schemas.openxmlformats.org/drawingml/2006/main">
               <a:ext uri="{FF2B5EF4-FFF2-40B4-BE49-F238E27FC236}">
-                <a16:creationId xmlns:a16="http://schemas.microsoft.com/office/drawing/2014/main" id="{2B1533AB-CE9D-41EE-830E-93B7FD5E9949}"/>
+                <a16:creationId xmlns:a16="http://schemas.microsoft.com/office/drawing/2014/main" id="{6DED604E-1973-4A33-97D1-BF0AC79BC8A7}"/>
               </a:ext>
             </a:extLst>
           </p:cNvPr>
@@ -5102,7 +5102,7 @@
           <p:cNvPr id="13" name="">
             <a:extLst xmlns:a="http://schemas.openxmlformats.org/drawingml/2006/main">
               <a:ext uri="{FF2B5EF4-FFF2-40B4-BE49-F238E27FC236}">
-                <a16:creationId xmlns:a16="http://schemas.microsoft.com/office/drawing/2014/main" id="{542410E0-A920-456E-A766-CBF8723AD93C}"/>
+                <a16:creationId xmlns:a16="http://schemas.microsoft.com/office/drawing/2014/main" id="{27E88128-AFC6-4F1D-A39C-8502EDB8F384}"/>
               </a:ext>
             </a:extLst>
           </p:cNvPr>
@@ -5152,7 +5152,7 @@
           <p:cNvPr id="14" name="">
             <a:extLst xmlns:a="http://schemas.openxmlformats.org/drawingml/2006/main">
               <a:ext uri="{FF2B5EF4-FFF2-40B4-BE49-F238E27FC236}">
-                <a16:creationId xmlns:a16="http://schemas.microsoft.com/office/drawing/2014/main" id="{9DBF1E3E-DB6F-462F-86C6-2D13BFAB8542}"/>
+                <a16:creationId xmlns:a16="http://schemas.microsoft.com/office/drawing/2014/main" id="{7B0CA871-E602-42BD-ABF1-EA7EE84F903C}"/>
               </a:ext>
             </a:extLst>
           </p:cNvPr>
@@ -5202,7 +5202,7 @@
           <p:cNvPr id="15" name="">
             <a:extLst xmlns:a="http://schemas.openxmlformats.org/drawingml/2006/main">
               <a:ext uri="{FF2B5EF4-FFF2-40B4-BE49-F238E27FC236}">
-                <a16:creationId xmlns:a16="http://schemas.microsoft.com/office/drawing/2014/main" id="{1999A53D-0F3A-4A86-B079-26D5D16153C2}"/>
+                <a16:creationId xmlns:a16="http://schemas.microsoft.com/office/drawing/2014/main" id="{13934270-284B-42E7-926F-9F3A6568563D}"/>
               </a:ext>
             </a:extLst>
           </p:cNvPr>
@@ -5252,7 +5252,7 @@
           <p:cNvPr id="16" name="">
             <a:extLst xmlns:a="http://schemas.openxmlformats.org/drawingml/2006/main">
               <a:ext uri="{FF2B5EF4-FFF2-40B4-BE49-F238E27FC236}">
-                <a16:creationId xmlns:a16="http://schemas.microsoft.com/office/drawing/2014/main" id="{E506AF41-D583-449E-8CD5-A59B77EA76D8}"/>
+                <a16:creationId xmlns:a16="http://schemas.microsoft.com/office/drawing/2014/main" id="{275C05F5-FF39-402C-A7EE-EEDA2FC60B03}"/>
               </a:ext>
             </a:extLst>
           </p:cNvPr>
@@ -5302,7 +5302,7 @@
           <p:cNvPr id="17" name="">
             <a:extLst xmlns:a="http://schemas.openxmlformats.org/drawingml/2006/main">
               <a:ext uri="{FF2B5EF4-FFF2-40B4-BE49-F238E27FC236}">
-                <a16:creationId xmlns:a16="http://schemas.microsoft.com/office/drawing/2014/main" id="{F9ADDDEB-7FD6-4F63-9818-482DB5EA0606}"/>
+                <a16:creationId xmlns:a16="http://schemas.microsoft.com/office/drawing/2014/main" id="{99ECCE21-3CBE-4B79-A9B2-BBB7337D2FCB}"/>
               </a:ext>
             </a:extLst>
           </p:cNvPr>
@@ -5352,7 +5352,7 @@
           <p:cNvPr id="18" name="">
             <a:extLst xmlns:a="http://schemas.openxmlformats.org/drawingml/2006/main">
               <a:ext uri="{FF2B5EF4-FFF2-40B4-BE49-F238E27FC236}">
-                <a16:creationId xmlns:a16="http://schemas.microsoft.com/office/drawing/2014/main" id="{BEE10190-13C1-4049-B787-0DC1FB5923BC}"/>
+                <a16:creationId xmlns:a16="http://schemas.microsoft.com/office/drawing/2014/main" id="{0F20B7F1-FF12-450D-B249-F1D72358C522}"/>
               </a:ext>
             </a:extLst>
           </p:cNvPr>
@@ -5400,7 +5400,7 @@
     </p:spTree>
     <p:extLst>
       <p:ext uri="{BB962C8B-B14F-4D97-AF65-F5344CB8AC3E}">
-        <p14:creationId xmlns:p14="http://schemas.microsoft.com/office/powerpoint/2010/main" val="177402652"/>
+        <p14:creationId xmlns:p14="http://schemas.microsoft.com/office/powerpoint/2010/main" val="64392873"/>
       </p:ext>
     </p:extLst>
   </p:cSld>
@@ -5431,7 +5431,7 @@
           <p:cNvPr id="1" name="">
             <a:extLst xmlns:a="http://schemas.openxmlformats.org/drawingml/2006/main">
               <a:ext uri="{FF2B5EF4-FFF2-40B4-BE49-F238E27FC236}">
-                <a16:creationId xmlns:a16="http://schemas.microsoft.com/office/drawing/2014/main" id="{FF453478-6457-4280-9BF2-A39B2AB3780E}"/>
+                <a16:creationId xmlns:a16="http://schemas.microsoft.com/office/drawing/2014/main" id="{9CBAFAFD-A81F-493D-B8FA-91E0383DD97A}"/>
               </a:ext>
             </a:extLst>
           </p:cNvPr>
@@ -5464,7 +5464,7 @@
           <p:cNvPr id="2" name="">
             <a:extLst xmlns:a="http://schemas.openxmlformats.org/drawingml/2006/main">
               <a:ext uri="{FF2B5EF4-FFF2-40B4-BE49-F238E27FC236}">
-                <a16:creationId xmlns:a16="http://schemas.microsoft.com/office/drawing/2014/main" id="{E4250C83-045C-49DB-8E1B-13BD020628D3}"/>
+                <a16:creationId xmlns:a16="http://schemas.microsoft.com/office/drawing/2014/main" id="{B7B837F3-D5FF-475E-A157-8CF22106076D}"/>
               </a:ext>
             </a:extLst>
           </p:cNvPr>
@@ -5497,7 +5497,7 @@
           <p:cNvPr id="3" name="">
             <a:extLst xmlns:a="http://schemas.openxmlformats.org/drawingml/2006/main">
               <a:ext uri="{FF2B5EF4-FFF2-40B4-BE49-F238E27FC236}">
-                <a16:creationId xmlns:a16="http://schemas.microsoft.com/office/drawing/2014/main" id="{02EA3AD7-4D1B-43DC-A6E3-A37C250CF4BB}"/>
+                <a16:creationId xmlns:a16="http://schemas.microsoft.com/office/drawing/2014/main" id="{35E752B2-F24B-44C9-9873-0000A2EDDB7D}"/>
               </a:ext>
             </a:extLst>
           </p:cNvPr>
@@ -5547,7 +5547,7 @@
           <p:cNvPr id="4" name="">
             <a:extLst xmlns:a="http://schemas.openxmlformats.org/drawingml/2006/main">
               <a:ext uri="{FF2B5EF4-FFF2-40B4-BE49-F238E27FC236}">
-                <a16:creationId xmlns:a16="http://schemas.microsoft.com/office/drawing/2014/main" id="{12DB0A88-47CD-4F48-9D97-E9BD99128C4D}"/>
+                <a16:creationId xmlns:a16="http://schemas.microsoft.com/office/drawing/2014/main" id="{D642CB7A-28EB-4655-A545-E7A71CA7EC11}"/>
               </a:ext>
             </a:extLst>
           </p:cNvPr>
@@ -5597,7 +5597,7 @@
           <p:cNvPr id="5" name="">
             <a:extLst xmlns:a="http://schemas.openxmlformats.org/drawingml/2006/main">
               <a:ext uri="{FF2B5EF4-FFF2-40B4-BE49-F238E27FC236}">
-                <a16:creationId xmlns:a16="http://schemas.microsoft.com/office/drawing/2014/main" id="{0A5D623F-FA86-49EA-B672-B4481525CB26}"/>
+                <a16:creationId xmlns:a16="http://schemas.microsoft.com/office/drawing/2014/main" id="{4F5957B3-5E1D-449E-A05B-9C649363B4E7}"/>
               </a:ext>
             </a:extLst>
           </p:cNvPr>
@@ -5647,7 +5647,7 @@
           <p:cNvPr id="6" name="">
             <a:extLst xmlns:a="http://schemas.openxmlformats.org/drawingml/2006/main">
               <a:ext uri="{FF2B5EF4-FFF2-40B4-BE49-F238E27FC236}">
-                <a16:creationId xmlns:a16="http://schemas.microsoft.com/office/drawing/2014/main" id="{48490944-1577-41AB-B0BB-67E533BC30B1}"/>
+                <a16:creationId xmlns:a16="http://schemas.microsoft.com/office/drawing/2014/main" id="{A12A5684-AD94-4678-B4B0-438925B7729A}"/>
               </a:ext>
             </a:extLst>
           </p:cNvPr>
@@ -5680,7 +5680,7 @@
           <p:cNvPr id="7" name="">
             <a:extLst xmlns:a="http://schemas.openxmlformats.org/drawingml/2006/main">
               <a:ext uri="{FF2B5EF4-FFF2-40B4-BE49-F238E27FC236}">
-                <a16:creationId xmlns:a16="http://schemas.microsoft.com/office/drawing/2014/main" id="{E9F32574-0B27-4B66-A833-088358CECC15}"/>
+                <a16:creationId xmlns:a16="http://schemas.microsoft.com/office/drawing/2014/main" id="{E3CB6880-9CAC-44F2-9653-E081884CE182}"/>
               </a:ext>
             </a:extLst>
           </p:cNvPr>
@@ -5770,7 +5770,7 @@
           <p:cNvPr id="8" name="">
             <a:extLst xmlns:a="http://schemas.openxmlformats.org/drawingml/2006/main">
               <a:ext uri="{FF2B5EF4-FFF2-40B4-BE49-F238E27FC236}">
-                <a16:creationId xmlns:a16="http://schemas.microsoft.com/office/drawing/2014/main" id="{079F3F67-CD12-4354-8C0A-C9E300DA4B8A}"/>
+                <a16:creationId xmlns:a16="http://schemas.microsoft.com/office/drawing/2014/main" id="{532C6773-7307-41BD-931C-A1DC3E315DAE}"/>
               </a:ext>
             </a:extLst>
           </p:cNvPr>
@@ -5820,7 +5820,7 @@
           <p:cNvPr id="9" name="">
             <a:extLst xmlns:a="http://schemas.openxmlformats.org/drawingml/2006/main">
               <a:ext uri="{FF2B5EF4-FFF2-40B4-BE49-F238E27FC236}">
-                <a16:creationId xmlns:a16="http://schemas.microsoft.com/office/drawing/2014/main" id="{ED94D913-D19B-44C4-91BD-EA8B19C53510}"/>
+                <a16:creationId xmlns:a16="http://schemas.microsoft.com/office/drawing/2014/main" id="{2E582808-37B1-4C8A-998F-5913FF752FE4}"/>
               </a:ext>
             </a:extLst>
           </p:cNvPr>
@@ -5910,7 +5910,7 @@
           <p:cNvPr id="10" name="">
             <a:extLst xmlns:a="http://schemas.openxmlformats.org/drawingml/2006/main">
               <a:ext uri="{FF2B5EF4-FFF2-40B4-BE49-F238E27FC236}">
-                <a16:creationId xmlns:a16="http://schemas.microsoft.com/office/drawing/2014/main" id="{C08383DC-ACF6-4B66-843D-22093241CA2B}"/>
+                <a16:creationId xmlns:a16="http://schemas.microsoft.com/office/drawing/2014/main" id="{728A0D4C-D400-4038-B624-5DA2B16E8EB6}"/>
               </a:ext>
             </a:extLst>
           </p:cNvPr>
@@ -5960,7 +5960,7 @@
           <p:cNvPr id="11" name="">
             <a:extLst xmlns:a="http://schemas.openxmlformats.org/drawingml/2006/main">
               <a:ext uri="{FF2B5EF4-FFF2-40B4-BE49-F238E27FC236}">
-                <a16:creationId xmlns:a16="http://schemas.microsoft.com/office/drawing/2014/main" id="{556B4FAB-05FA-4DD0-B386-EE4141BD3080}"/>
+                <a16:creationId xmlns:a16="http://schemas.microsoft.com/office/drawing/2014/main" id="{68C0324E-21E6-4235-AF78-BAB2FD1C88B4}"/>
               </a:ext>
             </a:extLst>
           </p:cNvPr>
@@ -6050,7 +6050,7 @@
           <p:cNvPr id="12" name="">
             <a:extLst xmlns:a="http://schemas.openxmlformats.org/drawingml/2006/main">
               <a:ext uri="{FF2B5EF4-FFF2-40B4-BE49-F238E27FC236}">
-                <a16:creationId xmlns:a16="http://schemas.microsoft.com/office/drawing/2014/main" id="{FECF3BBB-6349-4D57-99AC-B48B6DA6DDEC}"/>
+                <a16:creationId xmlns:a16="http://schemas.microsoft.com/office/drawing/2014/main" id="{C5CF6F84-C1F7-40BA-A6EC-B2DA789ACD89}"/>
               </a:ext>
             </a:extLst>
           </p:cNvPr>
@@ -6100,7 +6100,7 @@
           <p:cNvPr id="13" name="">
             <a:extLst xmlns:a="http://schemas.openxmlformats.org/drawingml/2006/main">
               <a:ext uri="{FF2B5EF4-FFF2-40B4-BE49-F238E27FC236}">
-                <a16:creationId xmlns:a16="http://schemas.microsoft.com/office/drawing/2014/main" id="{8042C6AE-0F4B-4788-83AF-FC021C31A3F4}"/>
+                <a16:creationId xmlns:a16="http://schemas.microsoft.com/office/drawing/2014/main" id="{A5B2A2D4-B30E-4A6E-82D0-9FC8D96D84C8}"/>
               </a:ext>
             </a:extLst>
           </p:cNvPr>
@@ -6190,7 +6190,7 @@
           <p:cNvPr id="14" name="">
             <a:extLst xmlns:a="http://schemas.openxmlformats.org/drawingml/2006/main">
               <a:ext uri="{FF2B5EF4-FFF2-40B4-BE49-F238E27FC236}">
-                <a16:creationId xmlns:a16="http://schemas.microsoft.com/office/drawing/2014/main" id="{5B1F2F27-40A4-42B1-89FB-E22269A87D78}"/>
+                <a16:creationId xmlns:a16="http://schemas.microsoft.com/office/drawing/2014/main" id="{5B061DFD-D019-4278-8954-5AD067CD78C3}"/>
               </a:ext>
             </a:extLst>
           </p:cNvPr>
@@ -6240,7 +6240,7 @@
           <p:cNvPr id="15" name="">
             <a:extLst xmlns:a="http://schemas.openxmlformats.org/drawingml/2006/main">
               <a:ext uri="{FF2B5EF4-FFF2-40B4-BE49-F238E27FC236}">
-                <a16:creationId xmlns:a16="http://schemas.microsoft.com/office/drawing/2014/main" id="{047023EF-26DA-41DB-B0C4-3A11735AF5FF}"/>
+                <a16:creationId xmlns:a16="http://schemas.microsoft.com/office/drawing/2014/main" id="{0D79A33B-6433-4829-A7F8-DBECAACDF5B2}"/>
               </a:ext>
             </a:extLst>
           </p:cNvPr>
@@ -6330,7 +6330,7 @@
           <p:cNvPr id="16" name="">
             <a:extLst xmlns:a="http://schemas.openxmlformats.org/drawingml/2006/main">
               <a:ext uri="{FF2B5EF4-FFF2-40B4-BE49-F238E27FC236}">
-                <a16:creationId xmlns:a16="http://schemas.microsoft.com/office/drawing/2014/main" id="{85E31584-63A3-41BD-8E6B-E106EC1BA5D9}"/>
+                <a16:creationId xmlns:a16="http://schemas.microsoft.com/office/drawing/2014/main" id="{ECB0C970-77A6-4C97-BFF2-5CC36D875C97}"/>
               </a:ext>
             </a:extLst>
           </p:cNvPr>
@@ -6403,7 +6403,7 @@
           <p:cNvPr id="17" name="">
             <a:extLst xmlns:a="http://schemas.openxmlformats.org/drawingml/2006/main">
               <a:ext uri="{FF2B5EF4-FFF2-40B4-BE49-F238E27FC236}">
-                <a16:creationId xmlns:a16="http://schemas.microsoft.com/office/drawing/2014/main" id="{D2D7C889-0C25-45F2-A9D6-8DF4802C1388}"/>
+                <a16:creationId xmlns:a16="http://schemas.microsoft.com/office/drawing/2014/main" id="{06B8DB4F-E43C-4D76-B27F-4151E6DE501E}"/>
               </a:ext>
             </a:extLst>
           </p:cNvPr>
@@ -6493,7 +6493,7 @@
           <p:cNvPr id="18" name="">
             <a:extLst xmlns:a="http://schemas.openxmlformats.org/drawingml/2006/main">
               <a:ext uri="{FF2B5EF4-FFF2-40B4-BE49-F238E27FC236}">
-                <a16:creationId xmlns:a16="http://schemas.microsoft.com/office/drawing/2014/main" id="{58559EFA-2C06-4101-BC1D-EB4F82570759}"/>
+                <a16:creationId xmlns:a16="http://schemas.microsoft.com/office/drawing/2014/main" id="{0D8FC31A-6A56-4EEC-987E-DD640996F153}"/>
               </a:ext>
             </a:extLst>
           </p:cNvPr>
@@ -6583,7 +6583,7 @@
           <p:cNvPr id="19" name="">
             <a:extLst xmlns:a="http://schemas.openxmlformats.org/drawingml/2006/main">
               <a:ext uri="{FF2B5EF4-FFF2-40B4-BE49-F238E27FC236}">
-                <a16:creationId xmlns:a16="http://schemas.microsoft.com/office/drawing/2014/main" id="{1D9FAC79-1617-45E4-81B1-B6A371FC068D}"/>
+                <a16:creationId xmlns:a16="http://schemas.microsoft.com/office/drawing/2014/main" id="{51B00907-6BF4-40FF-A951-7FF43D668E81}"/>
               </a:ext>
             </a:extLst>
           </p:cNvPr>
@@ -6633,7 +6633,7 @@
           <p:cNvPr id="20" name="">
             <a:extLst xmlns:a="http://schemas.openxmlformats.org/drawingml/2006/main">
               <a:ext uri="{FF2B5EF4-FFF2-40B4-BE49-F238E27FC236}">
-                <a16:creationId xmlns:a16="http://schemas.microsoft.com/office/drawing/2014/main" id="{966F98FC-74C7-470B-92AA-D2B962826EB9}"/>
+                <a16:creationId xmlns:a16="http://schemas.microsoft.com/office/drawing/2014/main" id="{4CCD02A5-0586-494D-8D21-023550C17674}"/>
               </a:ext>
             </a:extLst>
           </p:cNvPr>
@@ -6683,7 +6683,7 @@
           <p:cNvPr id="21" name="">
             <a:extLst xmlns:a="http://schemas.openxmlformats.org/drawingml/2006/main">
               <a:ext uri="{FF2B5EF4-FFF2-40B4-BE49-F238E27FC236}">
-                <a16:creationId xmlns:a16="http://schemas.microsoft.com/office/drawing/2014/main" id="{7C20E410-FAEE-4560-92F1-504D9120B854}"/>
+                <a16:creationId xmlns:a16="http://schemas.microsoft.com/office/drawing/2014/main" id="{48EE9C9B-48EB-462C-A043-868C0254F710}"/>
               </a:ext>
             </a:extLst>
           </p:cNvPr>
@@ -6733,7 +6733,7 @@
           <p:cNvPr id="22" name="">
             <a:extLst xmlns:a="http://schemas.openxmlformats.org/drawingml/2006/main">
               <a:ext uri="{FF2B5EF4-FFF2-40B4-BE49-F238E27FC236}">
-                <a16:creationId xmlns:a16="http://schemas.microsoft.com/office/drawing/2014/main" id="{68A3716D-6D13-467A-84AF-73673535494D}"/>
+                <a16:creationId xmlns:a16="http://schemas.microsoft.com/office/drawing/2014/main" id="{57DF71D8-6F6C-413F-A64B-BA60A562BB40}"/>
               </a:ext>
             </a:extLst>
           </p:cNvPr>
@@ -6783,7 +6783,7 @@
           <p:cNvPr id="23" name="">
             <a:extLst xmlns:a="http://schemas.openxmlformats.org/drawingml/2006/main">
               <a:ext uri="{FF2B5EF4-FFF2-40B4-BE49-F238E27FC236}">
-                <a16:creationId xmlns:a16="http://schemas.microsoft.com/office/drawing/2014/main" id="{653BB4B5-DAE1-465A-9CF2-DF40B84EF9A8}"/>
+                <a16:creationId xmlns:a16="http://schemas.microsoft.com/office/drawing/2014/main" id="{9FF9D85A-D8E0-42B7-92EC-88B39B62209F}"/>
               </a:ext>
             </a:extLst>
           </p:cNvPr>
@@ -6831,7 +6831,7 @@
     </p:spTree>
     <p:extLst>
       <p:ext uri="{BB962C8B-B14F-4D97-AF65-F5344CB8AC3E}">
-        <p14:creationId xmlns:p14="http://schemas.microsoft.com/office/powerpoint/2010/main" val="836638747"/>
+        <p14:creationId xmlns:p14="http://schemas.microsoft.com/office/powerpoint/2010/main" val="1490840027"/>
       </p:ext>
     </p:extLst>
   </p:cSld>
@@ -6862,7 +6862,7 @@
           <p:cNvPr id="1" name="">
             <a:extLst xmlns:a="http://schemas.openxmlformats.org/drawingml/2006/main">
               <a:ext uri="{FF2B5EF4-FFF2-40B4-BE49-F238E27FC236}">
-                <a16:creationId xmlns:a16="http://schemas.microsoft.com/office/drawing/2014/main" id="{39A1E04F-1218-4B3C-BED4-2B49A2F3E763}"/>
+                <a16:creationId xmlns:a16="http://schemas.microsoft.com/office/drawing/2014/main" id="{C4C9683D-C986-4CBC-89FF-A40FEEDE3BE2}"/>
               </a:ext>
             </a:extLst>
           </p:cNvPr>
@@ -6895,7 +6895,7 @@
           <p:cNvPr id="2" name="">
             <a:extLst xmlns:a="http://schemas.openxmlformats.org/drawingml/2006/main">
               <a:ext uri="{FF2B5EF4-FFF2-40B4-BE49-F238E27FC236}">
-                <a16:creationId xmlns:a16="http://schemas.microsoft.com/office/drawing/2014/main" id="{5BF50ECC-5E22-4D9D-9DF1-49F84360DADE}"/>
+                <a16:creationId xmlns:a16="http://schemas.microsoft.com/office/drawing/2014/main" id="{2674BABE-E17A-4149-9B1E-77C1D4BCDACC}"/>
               </a:ext>
             </a:extLst>
           </p:cNvPr>
@@ -6928,7 +6928,7 @@
           <p:cNvPr id="3" name="">
             <a:extLst xmlns:a="http://schemas.openxmlformats.org/drawingml/2006/main">
               <a:ext uri="{FF2B5EF4-FFF2-40B4-BE49-F238E27FC236}">
-                <a16:creationId xmlns:a16="http://schemas.microsoft.com/office/drawing/2014/main" id="{96895B87-0BB4-428E-868B-9DCCFE8BB0DE}"/>
+                <a16:creationId xmlns:a16="http://schemas.microsoft.com/office/drawing/2014/main" id="{638363C9-1B7E-4798-B79E-A4029D66CDBF}"/>
               </a:ext>
             </a:extLst>
           </p:cNvPr>
@@ -6978,7 +6978,7 @@
           <p:cNvPr id="4" name="">
             <a:extLst xmlns:a="http://schemas.openxmlformats.org/drawingml/2006/main">
               <a:ext uri="{FF2B5EF4-FFF2-40B4-BE49-F238E27FC236}">
-                <a16:creationId xmlns:a16="http://schemas.microsoft.com/office/drawing/2014/main" id="{152F3859-BB02-4279-94EF-15489B6683E9}"/>
+                <a16:creationId xmlns:a16="http://schemas.microsoft.com/office/drawing/2014/main" id="{F0A45FD3-8A9B-4AFB-B86F-0F626D262681}"/>
               </a:ext>
             </a:extLst>
           </p:cNvPr>
@@ -7028,7 +7028,7 @@
           <p:cNvPr id="5" name="">
             <a:extLst xmlns:a="http://schemas.openxmlformats.org/drawingml/2006/main">
               <a:ext uri="{FF2B5EF4-FFF2-40B4-BE49-F238E27FC236}">
-                <a16:creationId xmlns:a16="http://schemas.microsoft.com/office/drawing/2014/main" id="{D51AFB68-8FF7-486C-9853-5B304BED38BD}"/>
+                <a16:creationId xmlns:a16="http://schemas.microsoft.com/office/drawing/2014/main" id="{7A78877A-2349-4E08-B27B-13B417CCCFFC}"/>
               </a:ext>
             </a:extLst>
           </p:cNvPr>
@@ -7078,7 +7078,7 @@
           <p:cNvPr id="6" name="">
             <a:extLst xmlns:a="http://schemas.openxmlformats.org/drawingml/2006/main">
               <a:ext uri="{FF2B5EF4-FFF2-40B4-BE49-F238E27FC236}">
-                <a16:creationId xmlns:a16="http://schemas.microsoft.com/office/drawing/2014/main" id="{393E2E16-7558-4624-99A2-B08D2983D0B0}"/>
+                <a16:creationId xmlns:a16="http://schemas.microsoft.com/office/drawing/2014/main" id="{8283DE99-BA82-49D4-9EA9-8C9CBF9D8919}"/>
               </a:ext>
             </a:extLst>
           </p:cNvPr>
@@ -7111,7 +7111,7 @@
           <p:cNvPr id="7" name="">
             <a:extLst xmlns:a="http://schemas.openxmlformats.org/drawingml/2006/main">
               <a:ext uri="{FF2B5EF4-FFF2-40B4-BE49-F238E27FC236}">
-                <a16:creationId xmlns:a16="http://schemas.microsoft.com/office/drawing/2014/main" id="{4B104EBF-CD1E-4617-9030-1D80B26AA0E0}"/>
+                <a16:creationId xmlns:a16="http://schemas.microsoft.com/office/drawing/2014/main" id="{1100490E-7EF3-497A-A58A-DFA081D4F23C}"/>
               </a:ext>
             </a:extLst>
           </p:cNvPr>
@@ -7201,7 +7201,7 @@
           <p:cNvPr id="8" name="">
             <a:extLst xmlns:a="http://schemas.openxmlformats.org/drawingml/2006/main">
               <a:ext uri="{FF2B5EF4-FFF2-40B4-BE49-F238E27FC236}">
-                <a16:creationId xmlns:a16="http://schemas.microsoft.com/office/drawing/2014/main" id="{903BEEEB-6ABD-4DC1-823F-7273C510167E}"/>
+                <a16:creationId xmlns:a16="http://schemas.microsoft.com/office/drawing/2014/main" id="{B86FBB62-F031-4BDC-8E7F-58B79ACA28B8}"/>
               </a:ext>
             </a:extLst>
           </p:cNvPr>
@@ -7251,7 +7251,7 @@
           <p:cNvPr id="9" name="">
             <a:extLst xmlns:a="http://schemas.openxmlformats.org/drawingml/2006/main">
               <a:ext uri="{FF2B5EF4-FFF2-40B4-BE49-F238E27FC236}">
-                <a16:creationId xmlns:a16="http://schemas.microsoft.com/office/drawing/2014/main" id="{189CCFC4-32BA-4B95-966D-8883D12DDBE8}"/>
+                <a16:creationId xmlns:a16="http://schemas.microsoft.com/office/drawing/2014/main" id="{4676F0FF-5EC9-4851-9BC2-226EF51F6A97}"/>
               </a:ext>
             </a:extLst>
           </p:cNvPr>
@@ -7341,7 +7341,7 @@
           <p:cNvPr id="10" name="">
             <a:extLst xmlns:a="http://schemas.openxmlformats.org/drawingml/2006/main">
               <a:ext uri="{FF2B5EF4-FFF2-40B4-BE49-F238E27FC236}">
-                <a16:creationId xmlns:a16="http://schemas.microsoft.com/office/drawing/2014/main" id="{09D90D0D-A08D-40EC-8B2D-09B7FFCE18CC}"/>
+                <a16:creationId xmlns:a16="http://schemas.microsoft.com/office/drawing/2014/main" id="{B3121E17-BA01-4824-90DC-1B5D56B5DBF5}"/>
               </a:ext>
             </a:extLst>
           </p:cNvPr>
@@ -7391,7 +7391,7 @@
           <p:cNvPr id="11" name="">
             <a:extLst xmlns:a="http://schemas.openxmlformats.org/drawingml/2006/main">
               <a:ext uri="{FF2B5EF4-FFF2-40B4-BE49-F238E27FC236}">
-                <a16:creationId xmlns:a16="http://schemas.microsoft.com/office/drawing/2014/main" id="{BF5E672A-B6EE-48B9-B4B3-B3FB1B9B4E55}"/>
+                <a16:creationId xmlns:a16="http://schemas.microsoft.com/office/drawing/2014/main" id="{E97A3326-54F9-4518-A42A-F44F02114541}"/>
               </a:ext>
             </a:extLst>
           </p:cNvPr>
@@ -7481,7 +7481,7 @@
           <p:cNvPr id="12" name="">
             <a:extLst xmlns:a="http://schemas.openxmlformats.org/drawingml/2006/main">
               <a:ext uri="{FF2B5EF4-FFF2-40B4-BE49-F238E27FC236}">
-                <a16:creationId xmlns:a16="http://schemas.microsoft.com/office/drawing/2014/main" id="{B48C794C-AFC5-4115-8350-76EF89BACB55}"/>
+                <a16:creationId xmlns:a16="http://schemas.microsoft.com/office/drawing/2014/main" id="{E8C94867-633F-48BB-83A6-137D3EB08BE7}"/>
               </a:ext>
             </a:extLst>
           </p:cNvPr>
@@ -7531,7 +7531,7 @@
           <p:cNvPr id="13" name="">
             <a:extLst xmlns:a="http://schemas.openxmlformats.org/drawingml/2006/main">
               <a:ext uri="{FF2B5EF4-FFF2-40B4-BE49-F238E27FC236}">
-                <a16:creationId xmlns:a16="http://schemas.microsoft.com/office/drawing/2014/main" id="{76125E12-4432-4DA3-AF96-FF4F21A23E2B}"/>
+                <a16:creationId xmlns:a16="http://schemas.microsoft.com/office/drawing/2014/main" id="{1AB201F8-7C0B-4E2B-8D46-1F702EA0FF2D}"/>
               </a:ext>
             </a:extLst>
           </p:cNvPr>
@@ -7621,7 +7621,7 @@
           <p:cNvPr id="14" name="">
             <a:extLst xmlns:a="http://schemas.openxmlformats.org/drawingml/2006/main">
               <a:ext uri="{FF2B5EF4-FFF2-40B4-BE49-F238E27FC236}">
-                <a16:creationId xmlns:a16="http://schemas.microsoft.com/office/drawing/2014/main" id="{15CCF3B1-CF28-4431-92BE-5DB84329B1B0}"/>
+                <a16:creationId xmlns:a16="http://schemas.microsoft.com/office/drawing/2014/main" id="{72B6B5A2-37CB-4D3B-B021-734307F04526}"/>
               </a:ext>
             </a:extLst>
           </p:cNvPr>
@@ -7671,7 +7671,7 @@
           <p:cNvPr id="15" name="">
             <a:extLst xmlns:a="http://schemas.openxmlformats.org/drawingml/2006/main">
               <a:ext uri="{FF2B5EF4-FFF2-40B4-BE49-F238E27FC236}">
-                <a16:creationId xmlns:a16="http://schemas.microsoft.com/office/drawing/2014/main" id="{BAF88C9A-47CC-4B7B-8B08-E260C8F2E0EF}"/>
+                <a16:creationId xmlns:a16="http://schemas.microsoft.com/office/drawing/2014/main" id="{321BF1F6-BCB6-420E-903F-DE1F49C93E26}"/>
               </a:ext>
             </a:extLst>
           </p:cNvPr>
@@ -7761,7 +7761,7 @@
           <p:cNvPr id="16" name="">
             <a:extLst xmlns:a="http://schemas.openxmlformats.org/drawingml/2006/main">
               <a:ext uri="{FF2B5EF4-FFF2-40B4-BE49-F238E27FC236}">
-                <a16:creationId xmlns:a16="http://schemas.microsoft.com/office/drawing/2014/main" id="{7EE25DCA-FD46-4E2C-A587-5DE478133D5E}"/>
+                <a16:creationId xmlns:a16="http://schemas.microsoft.com/office/drawing/2014/main" id="{2004A352-AA76-41B5-A26A-7C647DDB6CBF}"/>
               </a:ext>
             </a:extLst>
           </p:cNvPr>
@@ -7851,7 +7851,7 @@
           <p:cNvPr id="17" name="">
             <a:extLst xmlns:a="http://schemas.openxmlformats.org/drawingml/2006/main">
               <a:ext uri="{FF2B5EF4-FFF2-40B4-BE49-F238E27FC236}">
-                <a16:creationId xmlns:a16="http://schemas.microsoft.com/office/drawing/2014/main" id="{4247D6AF-208E-4E1A-AB69-876373E2F2ED}"/>
+                <a16:creationId xmlns:a16="http://schemas.microsoft.com/office/drawing/2014/main" id="{219C8D18-E266-41E2-8326-0D82F94A199A}"/>
               </a:ext>
             </a:extLst>
           </p:cNvPr>
@@ -7941,7 +7941,7 @@
           <p:cNvPr id="18" name="">
             <a:extLst xmlns:a="http://schemas.openxmlformats.org/drawingml/2006/main">
               <a:ext uri="{FF2B5EF4-FFF2-40B4-BE49-F238E27FC236}">
-                <a16:creationId xmlns:a16="http://schemas.microsoft.com/office/drawing/2014/main" id="{0AC59324-A3E1-457D-BBFF-4524787E1545}"/>
+                <a16:creationId xmlns:a16="http://schemas.microsoft.com/office/drawing/2014/main" id="{63DE9FCE-6F64-4572-B311-7F885670286F}"/>
               </a:ext>
             </a:extLst>
           </p:cNvPr>
@@ -8031,7 +8031,7 @@
           <p:cNvPr id="19" name="">
             <a:extLst xmlns:a="http://schemas.openxmlformats.org/drawingml/2006/main">
               <a:ext uri="{FF2B5EF4-FFF2-40B4-BE49-F238E27FC236}">
-                <a16:creationId xmlns:a16="http://schemas.microsoft.com/office/drawing/2014/main" id="{7E358FED-A60E-4081-90E8-EF89A48C3B44}"/>
+                <a16:creationId xmlns:a16="http://schemas.microsoft.com/office/drawing/2014/main" id="{399E5706-6C48-4157-838F-9B5366C1BC2E}"/>
               </a:ext>
             </a:extLst>
           </p:cNvPr>
@@ -8081,7 +8081,7 @@
           <p:cNvPr id="20" name="">
             <a:extLst xmlns:a="http://schemas.openxmlformats.org/drawingml/2006/main">
               <a:ext uri="{FF2B5EF4-FFF2-40B4-BE49-F238E27FC236}">
-                <a16:creationId xmlns:a16="http://schemas.microsoft.com/office/drawing/2014/main" id="{9A1B00AD-6195-4082-9872-C1B3A708D167}"/>
+                <a16:creationId xmlns:a16="http://schemas.microsoft.com/office/drawing/2014/main" id="{21520F40-66BC-46DC-A88A-1C76D013C8B9}"/>
               </a:ext>
             </a:extLst>
           </p:cNvPr>
@@ -8131,7 +8131,7 @@
           <p:cNvPr id="21" name="">
             <a:extLst xmlns:a="http://schemas.openxmlformats.org/drawingml/2006/main">
               <a:ext uri="{FF2B5EF4-FFF2-40B4-BE49-F238E27FC236}">
-                <a16:creationId xmlns:a16="http://schemas.microsoft.com/office/drawing/2014/main" id="{BDF1328F-4205-49A4-A52E-DC87E78E18CB}"/>
+                <a16:creationId xmlns:a16="http://schemas.microsoft.com/office/drawing/2014/main" id="{A2A42CF8-1C43-4E88-AA73-F9C03269C90A}"/>
               </a:ext>
             </a:extLst>
           </p:cNvPr>
@@ -8179,7 +8179,7 @@
     </p:spTree>
     <p:extLst>
       <p:ext uri="{BB962C8B-B14F-4D97-AF65-F5344CB8AC3E}">
-        <p14:creationId xmlns:p14="http://schemas.microsoft.com/office/powerpoint/2010/main" val="1797131423"/>
+        <p14:creationId xmlns:p14="http://schemas.microsoft.com/office/powerpoint/2010/main" val="99577533"/>
       </p:ext>
     </p:extLst>
   </p:cSld>
@@ -8210,7 +8210,7 @@
           <p:cNvPr id="1" name="">
             <a:extLst xmlns:a="http://schemas.openxmlformats.org/drawingml/2006/main">
               <a:ext uri="{FF2B5EF4-FFF2-40B4-BE49-F238E27FC236}">
-                <a16:creationId xmlns:a16="http://schemas.microsoft.com/office/drawing/2014/main" id="{9BCA5B21-AF06-4BFB-8718-12328EFDFB72}"/>
+                <a16:creationId xmlns:a16="http://schemas.microsoft.com/office/drawing/2014/main" id="{56F793A3-E0EB-42ED-A976-6C14A5BA75D5}"/>
               </a:ext>
             </a:extLst>
           </p:cNvPr>
@@ -8243,7 +8243,7 @@
           <p:cNvPr id="2" name="">
             <a:extLst xmlns:a="http://schemas.openxmlformats.org/drawingml/2006/main">
               <a:ext uri="{FF2B5EF4-FFF2-40B4-BE49-F238E27FC236}">
-                <a16:creationId xmlns:a16="http://schemas.microsoft.com/office/drawing/2014/main" id="{3FDEF52D-8C06-4AFA-8662-6239C4FB6276}"/>
+                <a16:creationId xmlns:a16="http://schemas.microsoft.com/office/drawing/2014/main" id="{27B8A128-AB88-4341-89C1-7DBFC39E0480}"/>
               </a:ext>
             </a:extLst>
           </p:cNvPr>
@@ -8276,7 +8276,7 @@
           <p:cNvPr id="3" name="">
             <a:extLst xmlns:a="http://schemas.openxmlformats.org/drawingml/2006/main">
               <a:ext uri="{FF2B5EF4-FFF2-40B4-BE49-F238E27FC236}">
-                <a16:creationId xmlns:a16="http://schemas.microsoft.com/office/drawing/2014/main" id="{A4762E20-73F5-487B-AC72-B7F02A67F2EE}"/>
+                <a16:creationId xmlns:a16="http://schemas.microsoft.com/office/drawing/2014/main" id="{15A3AE4A-98D3-4311-BF93-D51745CD5C0E}"/>
               </a:ext>
             </a:extLst>
           </p:cNvPr>
@@ -8326,7 +8326,7 @@
           <p:cNvPr id="4" name="">
             <a:extLst xmlns:a="http://schemas.openxmlformats.org/drawingml/2006/main">
               <a:ext uri="{FF2B5EF4-FFF2-40B4-BE49-F238E27FC236}">
-                <a16:creationId xmlns:a16="http://schemas.microsoft.com/office/drawing/2014/main" id="{4F95CFB0-12FA-47F0-BA62-04604DB8C4B9}"/>
+                <a16:creationId xmlns:a16="http://schemas.microsoft.com/office/drawing/2014/main" id="{ED4B5DEC-1C71-4C84-8E9A-EA597B81D822}"/>
               </a:ext>
             </a:extLst>
           </p:cNvPr>
@@ -8376,7 +8376,7 @@
           <p:cNvPr id="5" name="">
             <a:extLst xmlns:a="http://schemas.openxmlformats.org/drawingml/2006/main">
               <a:ext uri="{FF2B5EF4-FFF2-40B4-BE49-F238E27FC236}">
-                <a16:creationId xmlns:a16="http://schemas.microsoft.com/office/drawing/2014/main" id="{D61507D1-1CB4-452A-8640-A45FB31AE605}"/>
+                <a16:creationId xmlns:a16="http://schemas.microsoft.com/office/drawing/2014/main" id="{8C12D1AD-7A59-4FA1-BB35-E696B9190A83}"/>
               </a:ext>
             </a:extLst>
           </p:cNvPr>
@@ -8426,7 +8426,7 @@
           <p:cNvPr id="6" name="">
             <a:extLst xmlns:a="http://schemas.openxmlformats.org/drawingml/2006/main">
               <a:ext uri="{FF2B5EF4-FFF2-40B4-BE49-F238E27FC236}">
-                <a16:creationId xmlns:a16="http://schemas.microsoft.com/office/drawing/2014/main" id="{C1BD4D97-792E-46B3-8741-B9760BDCDBBF}"/>
+                <a16:creationId xmlns:a16="http://schemas.microsoft.com/office/drawing/2014/main" id="{0B6DDE87-679F-4356-9B7B-1E54E5C72B15}"/>
               </a:ext>
             </a:extLst>
           </p:cNvPr>
@@ -8459,7 +8459,7 @@
           <p:cNvPr id="7" name="">
             <a:extLst xmlns:a="http://schemas.openxmlformats.org/drawingml/2006/main">
               <a:ext uri="{FF2B5EF4-FFF2-40B4-BE49-F238E27FC236}">
-                <a16:creationId xmlns:a16="http://schemas.microsoft.com/office/drawing/2014/main" id="{EDAFB348-A953-440E-B6D4-1732DAF9F837}"/>
+                <a16:creationId xmlns:a16="http://schemas.microsoft.com/office/drawing/2014/main" id="{0670158D-F532-49CF-AD2E-97084F4DBC06}"/>
               </a:ext>
             </a:extLst>
           </p:cNvPr>
@@ -8532,7 +8532,7 @@
           <p:cNvPr id="8" name="">
             <a:extLst xmlns:a="http://schemas.openxmlformats.org/drawingml/2006/main">
               <a:ext uri="{FF2B5EF4-FFF2-40B4-BE49-F238E27FC236}">
-                <a16:creationId xmlns:a16="http://schemas.microsoft.com/office/drawing/2014/main" id="{41CC40F0-1D64-450B-85D2-09CCC4AE2557}"/>
+                <a16:creationId xmlns:a16="http://schemas.microsoft.com/office/drawing/2014/main" id="{99D3B99A-644A-4061-AB7A-F918BCB6686D}"/>
               </a:ext>
             </a:extLst>
           </p:cNvPr>
@@ -8605,7 +8605,7 @@
           <p:cNvPr id="9" name="">
             <a:extLst xmlns:a="http://schemas.openxmlformats.org/drawingml/2006/main">
               <a:ext uri="{FF2B5EF4-FFF2-40B4-BE49-F238E27FC236}">
-                <a16:creationId xmlns:a16="http://schemas.microsoft.com/office/drawing/2014/main" id="{FE9E6C39-A8E2-4A2F-A1A3-117F298EA719}"/>
+                <a16:creationId xmlns:a16="http://schemas.microsoft.com/office/drawing/2014/main" id="{ED3A4888-CBEE-4E7D-8552-1249A122D1AD}"/>
               </a:ext>
             </a:extLst>
           </p:cNvPr>
@@ -8678,7 +8678,7 @@
           <p:cNvPr id="10" name="">
             <a:extLst xmlns:a="http://schemas.openxmlformats.org/drawingml/2006/main">
               <a:ext uri="{FF2B5EF4-FFF2-40B4-BE49-F238E27FC236}">
-                <a16:creationId xmlns:a16="http://schemas.microsoft.com/office/drawing/2014/main" id="{74A3A819-9AC4-4A04-93EA-D7E79433DA2C}"/>
+                <a16:creationId xmlns:a16="http://schemas.microsoft.com/office/drawing/2014/main" id="{6B82829F-51F0-49A2-8D90-5BF4EE5E24ED}"/>
               </a:ext>
             </a:extLst>
           </p:cNvPr>
@@ -8751,7 +8751,7 @@
           <p:cNvPr id="11" name="">
             <a:extLst xmlns:a="http://schemas.openxmlformats.org/drawingml/2006/main">
               <a:ext uri="{FF2B5EF4-FFF2-40B4-BE49-F238E27FC236}">
-                <a16:creationId xmlns:a16="http://schemas.microsoft.com/office/drawing/2014/main" id="{B81A3423-3CAB-4F80-8A21-F5A37F18CD6D}"/>
+                <a16:creationId xmlns:a16="http://schemas.microsoft.com/office/drawing/2014/main" id="{79857320-0192-42B3-A939-631E541E4688}"/>
               </a:ext>
             </a:extLst>
           </p:cNvPr>
@@ -8801,7 +8801,7 @@
           <p:cNvPr id="12" name="">
             <a:extLst xmlns:a="http://schemas.openxmlformats.org/drawingml/2006/main">
               <a:ext uri="{FF2B5EF4-FFF2-40B4-BE49-F238E27FC236}">
-                <a16:creationId xmlns:a16="http://schemas.microsoft.com/office/drawing/2014/main" id="{AA72A28B-BE1D-4630-8C32-E8617A5512FF}"/>
+                <a16:creationId xmlns:a16="http://schemas.microsoft.com/office/drawing/2014/main" id="{210CDA69-A1F9-4882-A8E8-03B0DEE1F078}"/>
               </a:ext>
             </a:extLst>
           </p:cNvPr>
@@ -8851,7 +8851,7 @@
           <p:cNvPr id="13" name="">
             <a:extLst xmlns:a="http://schemas.openxmlformats.org/drawingml/2006/main">
               <a:ext uri="{FF2B5EF4-FFF2-40B4-BE49-F238E27FC236}">
-                <a16:creationId xmlns:a16="http://schemas.microsoft.com/office/drawing/2014/main" id="{567BFC6A-30DF-4F2E-887E-27DD4DD5E7CE}"/>
+                <a16:creationId xmlns:a16="http://schemas.microsoft.com/office/drawing/2014/main" id="{C98F7C8C-018E-4347-B225-0EEBB3A8A162}"/>
               </a:ext>
             </a:extLst>
           </p:cNvPr>
@@ -8901,7 +8901,7 @@
           <p:cNvPr id="14" name="">
             <a:extLst xmlns:a="http://schemas.openxmlformats.org/drawingml/2006/main">
               <a:ext uri="{FF2B5EF4-FFF2-40B4-BE49-F238E27FC236}">
-                <a16:creationId xmlns:a16="http://schemas.microsoft.com/office/drawing/2014/main" id="{306D1AFC-E109-4244-8678-28A061994D35}"/>
+                <a16:creationId xmlns:a16="http://schemas.microsoft.com/office/drawing/2014/main" id="{D5CFDA7C-0214-49A5-92B0-838AB370B6B8}"/>
               </a:ext>
             </a:extLst>
           </p:cNvPr>
@@ -8951,7 +8951,7 @@
           <p:cNvPr id="15" name="">
             <a:extLst xmlns:a="http://schemas.openxmlformats.org/drawingml/2006/main">
               <a:ext uri="{FF2B5EF4-FFF2-40B4-BE49-F238E27FC236}">
-                <a16:creationId xmlns:a16="http://schemas.microsoft.com/office/drawing/2014/main" id="{EF4A1466-73EC-47D1-8E0E-AC42199E1B4D}"/>
+                <a16:creationId xmlns:a16="http://schemas.microsoft.com/office/drawing/2014/main" id="{F323114A-7654-4402-BA52-36CC81C68296}"/>
               </a:ext>
             </a:extLst>
           </p:cNvPr>
@@ -9001,7 +9001,7 @@
           <p:cNvPr id="16" name="">
             <a:extLst xmlns:a="http://schemas.openxmlformats.org/drawingml/2006/main">
               <a:ext uri="{FF2B5EF4-FFF2-40B4-BE49-F238E27FC236}">
-                <a16:creationId xmlns:a16="http://schemas.microsoft.com/office/drawing/2014/main" id="{D723D8FC-CB4C-4FF2-A26B-E919C2C05D35}"/>
+                <a16:creationId xmlns:a16="http://schemas.microsoft.com/office/drawing/2014/main" id="{6CBFF0F6-278F-4420-BA85-3E034E1DC0A6}"/>
               </a:ext>
             </a:extLst>
           </p:cNvPr>
@@ -9051,7 +9051,7 @@
           <p:cNvPr id="17" name="">
             <a:extLst xmlns:a="http://schemas.openxmlformats.org/drawingml/2006/main">
               <a:ext uri="{FF2B5EF4-FFF2-40B4-BE49-F238E27FC236}">
-                <a16:creationId xmlns:a16="http://schemas.microsoft.com/office/drawing/2014/main" id="{75A56ECC-F66D-4B69-B478-F9480E4567FD}"/>
+                <a16:creationId xmlns:a16="http://schemas.microsoft.com/office/drawing/2014/main" id="{17582F55-B92D-4F3B-A4C8-C8F0D2E58F9C}"/>
               </a:ext>
             </a:extLst>
           </p:cNvPr>
@@ -9101,7 +9101,7 @@
           <p:cNvPr id="18" name="">
             <a:extLst xmlns:a="http://schemas.openxmlformats.org/drawingml/2006/main">
               <a:ext uri="{FF2B5EF4-FFF2-40B4-BE49-F238E27FC236}">
-                <a16:creationId xmlns:a16="http://schemas.microsoft.com/office/drawing/2014/main" id="{20F659C3-91BE-459D-95AF-7747D6AA4ABE}"/>
+                <a16:creationId xmlns:a16="http://schemas.microsoft.com/office/drawing/2014/main" id="{D090F625-4DA5-43B9-B2C5-FE8C03F29534}"/>
               </a:ext>
             </a:extLst>
           </p:cNvPr>
@@ -9149,7 +9149,7 @@
     </p:spTree>
     <p:extLst>
       <p:ext uri="{BB962C8B-B14F-4D97-AF65-F5344CB8AC3E}">
-        <p14:creationId xmlns:p14="http://schemas.microsoft.com/office/powerpoint/2010/main" val="1840370542"/>
+        <p14:creationId xmlns:p14="http://schemas.microsoft.com/office/powerpoint/2010/main" val="225010080"/>
       </p:ext>
     </p:extLst>
   </p:cSld>
@@ -9180,7 +9180,7 @@
           <p:cNvPr id="1" name="">
             <a:extLst xmlns:a="http://schemas.openxmlformats.org/drawingml/2006/main">
               <a:ext uri="{FF2B5EF4-FFF2-40B4-BE49-F238E27FC236}">
-                <a16:creationId xmlns:a16="http://schemas.microsoft.com/office/drawing/2014/main" id="{7ABB204B-B51F-48AF-9D5B-CDFB802200F1}"/>
+                <a16:creationId xmlns:a16="http://schemas.microsoft.com/office/drawing/2014/main" id="{D109B81D-F01A-4A2E-9815-0CF98B0CDADB}"/>
               </a:ext>
             </a:extLst>
           </p:cNvPr>
@@ -9213,7 +9213,7 @@
           <p:cNvPr id="2" name="">
             <a:extLst xmlns:a="http://schemas.openxmlformats.org/drawingml/2006/main">
               <a:ext uri="{FF2B5EF4-FFF2-40B4-BE49-F238E27FC236}">
-                <a16:creationId xmlns:a16="http://schemas.microsoft.com/office/drawing/2014/main" id="{07DB763A-B72D-4F9A-B9EB-80FC8346A2FB}"/>
+                <a16:creationId xmlns:a16="http://schemas.microsoft.com/office/drawing/2014/main" id="{EDB7775E-5E99-46DD-B960-270F22490C2F}"/>
               </a:ext>
             </a:extLst>
           </p:cNvPr>
@@ -9246,7 +9246,7 @@
           <p:cNvPr id="3" name="">
             <a:extLst xmlns:a="http://schemas.openxmlformats.org/drawingml/2006/main">
               <a:ext uri="{FF2B5EF4-FFF2-40B4-BE49-F238E27FC236}">
-                <a16:creationId xmlns:a16="http://schemas.microsoft.com/office/drawing/2014/main" id="{9F44F04C-904A-4622-A5BC-3D66C0678117}"/>
+                <a16:creationId xmlns:a16="http://schemas.microsoft.com/office/drawing/2014/main" id="{C895C710-7D09-4538-87AE-2EE74DD45AED}"/>
               </a:ext>
             </a:extLst>
           </p:cNvPr>
@@ -9296,7 +9296,7 @@
           <p:cNvPr id="4" name="">
             <a:extLst xmlns:a="http://schemas.openxmlformats.org/drawingml/2006/main">
               <a:ext uri="{FF2B5EF4-FFF2-40B4-BE49-F238E27FC236}">
-                <a16:creationId xmlns:a16="http://schemas.microsoft.com/office/drawing/2014/main" id="{710BDB90-49ED-431B-B276-333D7E810816}"/>
+                <a16:creationId xmlns:a16="http://schemas.microsoft.com/office/drawing/2014/main" id="{6B4209C1-B58C-446F-9D50-E70A985EAD09}"/>
               </a:ext>
             </a:extLst>
           </p:cNvPr>
@@ -9346,7 +9346,7 @@
           <p:cNvPr id="5" name="">
             <a:extLst xmlns:a="http://schemas.openxmlformats.org/drawingml/2006/main">
               <a:ext uri="{FF2B5EF4-FFF2-40B4-BE49-F238E27FC236}">
-                <a16:creationId xmlns:a16="http://schemas.microsoft.com/office/drawing/2014/main" id="{D909E167-849B-4E76-9ED6-532053FDA8B6}"/>
+                <a16:creationId xmlns:a16="http://schemas.microsoft.com/office/drawing/2014/main" id="{6E0F94CD-2A1B-4CA6-B353-017942A0EC0E}"/>
               </a:ext>
             </a:extLst>
           </p:cNvPr>
@@ -9396,7 +9396,7 @@
           <p:cNvPr id="6" name="">
             <a:extLst xmlns:a="http://schemas.openxmlformats.org/drawingml/2006/main">
               <a:ext uri="{FF2B5EF4-FFF2-40B4-BE49-F238E27FC236}">
-                <a16:creationId xmlns:a16="http://schemas.microsoft.com/office/drawing/2014/main" id="{E4CDE3F1-3851-4A1B-A30D-2751959D0A30}"/>
+                <a16:creationId xmlns:a16="http://schemas.microsoft.com/office/drawing/2014/main" id="{881F2FFE-35C5-4E83-A056-CD528AB04C3A}"/>
               </a:ext>
             </a:extLst>
           </p:cNvPr>
@@ -9433,7 +9433,7 @@
           <p:nvPr/>
         </p:nvPicPr>
         <p:blipFill>
-          <a:blip xmlns:r="http://schemas.openxmlformats.org/officeDocument/2006/relationships" xmlns:a="http://schemas.openxmlformats.org/drawingml/2006/main" r:embed="Rbae0463816004ce6"/>
+          <a:blip xmlns:r="http://schemas.openxmlformats.org/officeDocument/2006/relationships" xmlns:a="http://schemas.openxmlformats.org/drawingml/2006/main" r:embed="R4cfa4f85db074f3c"/>
           <a:stretch xmlns:a="http://schemas.openxmlformats.org/drawingml/2006/main"/>
         </p:blipFill>
         <p:spPr>
@@ -9455,7 +9455,7 @@
           <p:nvPr/>
         </p:nvPicPr>
         <p:blipFill>
-          <a:blip xmlns:r="http://schemas.openxmlformats.org/officeDocument/2006/relationships" xmlns:a="http://schemas.openxmlformats.org/drawingml/2006/main" r:embed="R4680dce22fea4f87"/>
+          <a:blip xmlns:r="http://schemas.openxmlformats.org/officeDocument/2006/relationships" xmlns:a="http://schemas.openxmlformats.org/drawingml/2006/main" r:embed="Rdbe8a587b81448e8"/>
           <a:stretch xmlns:a="http://schemas.openxmlformats.org/drawingml/2006/main"/>
         </p:blipFill>
         <p:spPr>
@@ -9473,7 +9473,7 @@
           <p:cNvPr id="9" name="">
             <a:extLst xmlns:a="http://schemas.openxmlformats.org/drawingml/2006/main">
               <a:ext uri="{FF2B5EF4-FFF2-40B4-BE49-F238E27FC236}">
-                <a16:creationId xmlns:a16="http://schemas.microsoft.com/office/drawing/2014/main" id="{3EBE6B27-622C-4304-B8CD-E026D1842150}"/>
+                <a16:creationId xmlns:a16="http://schemas.microsoft.com/office/drawing/2014/main" id="{A571B977-87C8-448E-A8FA-E2576DA26852}"/>
               </a:ext>
             </a:extLst>
           </p:cNvPr>
@@ -9523,7 +9523,7 @@
           <p:cNvPr id="10" name="">
             <a:extLst xmlns:a="http://schemas.openxmlformats.org/drawingml/2006/main">
               <a:ext uri="{FF2B5EF4-FFF2-40B4-BE49-F238E27FC236}">
-                <a16:creationId xmlns:a16="http://schemas.microsoft.com/office/drawing/2014/main" id="{A9875317-F603-4AAB-8589-363757D1E080}"/>
+                <a16:creationId xmlns:a16="http://schemas.microsoft.com/office/drawing/2014/main" id="{5B5C7251-BDF7-4079-AEFF-3EE0FF46A966}"/>
               </a:ext>
             </a:extLst>
           </p:cNvPr>
@@ -9573,7 +9573,7 @@
           <p:cNvPr id="11" name="">
             <a:extLst xmlns:a="http://schemas.openxmlformats.org/drawingml/2006/main">
               <a:ext uri="{FF2B5EF4-FFF2-40B4-BE49-F238E27FC236}">
-                <a16:creationId xmlns:a16="http://schemas.microsoft.com/office/drawing/2014/main" id="{251CAB95-2734-4012-84C5-4227A4DF1A54}"/>
+                <a16:creationId xmlns:a16="http://schemas.microsoft.com/office/drawing/2014/main" id="{8FA2DB02-530C-4444-A0E8-1DA436B8C237}"/>
               </a:ext>
             </a:extLst>
           </p:cNvPr>
@@ -9621,7 +9621,7 @@
     </p:spTree>
     <p:extLst>
       <p:ext uri="{BB962C8B-B14F-4D97-AF65-F5344CB8AC3E}">
-        <p14:creationId xmlns:p14="http://schemas.microsoft.com/office/powerpoint/2010/main" val="2027460347"/>
+        <p14:creationId xmlns:p14="http://schemas.microsoft.com/office/powerpoint/2010/main" val="426294307"/>
       </p:ext>
     </p:extLst>
   </p:cSld>
@@ -9652,7 +9652,7 @@
           <p:cNvPr id="1" name="">
             <a:extLst xmlns:a="http://schemas.openxmlformats.org/drawingml/2006/main">
               <a:ext uri="{FF2B5EF4-FFF2-40B4-BE49-F238E27FC236}">
-                <a16:creationId xmlns:a16="http://schemas.microsoft.com/office/drawing/2014/main" id="{9F27E282-E35B-4425-A9BA-F2615A773C9B}"/>
+                <a16:creationId xmlns:a16="http://schemas.microsoft.com/office/drawing/2014/main" id="{16A277A7-C8E3-4F3B-90BE-2BE745C4B599}"/>
               </a:ext>
             </a:extLst>
           </p:cNvPr>
@@ -9685,7 +9685,7 @@
           <p:cNvPr id="2" name="">
             <a:extLst xmlns:a="http://schemas.openxmlformats.org/drawingml/2006/main">
               <a:ext uri="{FF2B5EF4-FFF2-40B4-BE49-F238E27FC236}">
-                <a16:creationId xmlns:a16="http://schemas.microsoft.com/office/drawing/2014/main" id="{5EF28BC0-ABC9-4B87-84EB-78313CC66D18}"/>
+                <a16:creationId xmlns:a16="http://schemas.microsoft.com/office/drawing/2014/main" id="{CE493852-9D08-41A3-9502-E2675EAD176D}"/>
               </a:ext>
             </a:extLst>
           </p:cNvPr>
@@ -9718,7 +9718,7 @@
           <p:cNvPr id="3" name="">
             <a:extLst xmlns:a="http://schemas.openxmlformats.org/drawingml/2006/main">
               <a:ext uri="{FF2B5EF4-FFF2-40B4-BE49-F238E27FC236}">
-                <a16:creationId xmlns:a16="http://schemas.microsoft.com/office/drawing/2014/main" id="{0233269A-9448-4CBD-9D0D-E7E971DF1BDE}"/>
+                <a16:creationId xmlns:a16="http://schemas.microsoft.com/office/drawing/2014/main" id="{F37D372B-A1CF-4161-ADF2-750EB73B96C5}"/>
               </a:ext>
             </a:extLst>
           </p:cNvPr>
@@ -9768,7 +9768,7 @@
           <p:cNvPr id="4" name="">
             <a:extLst xmlns:a="http://schemas.openxmlformats.org/drawingml/2006/main">
               <a:ext uri="{FF2B5EF4-FFF2-40B4-BE49-F238E27FC236}">
-                <a16:creationId xmlns:a16="http://schemas.microsoft.com/office/drawing/2014/main" id="{1BC4D69C-E2CF-463C-803B-466A05A01938}"/>
+                <a16:creationId xmlns:a16="http://schemas.microsoft.com/office/drawing/2014/main" id="{CA6FD37E-DEA5-42C4-BDC7-2A9C0BA86591}"/>
               </a:ext>
             </a:extLst>
           </p:cNvPr>
@@ -9818,7 +9818,7 @@
           <p:cNvPr id="5" name="">
             <a:extLst xmlns:a="http://schemas.openxmlformats.org/drawingml/2006/main">
               <a:ext uri="{FF2B5EF4-FFF2-40B4-BE49-F238E27FC236}">
-                <a16:creationId xmlns:a16="http://schemas.microsoft.com/office/drawing/2014/main" id="{0B989576-EB8A-42E7-B839-350AD591E044}"/>
+                <a16:creationId xmlns:a16="http://schemas.microsoft.com/office/drawing/2014/main" id="{8B46D4DD-0503-47B9-94E0-3F6D0482C285}"/>
               </a:ext>
             </a:extLst>
           </p:cNvPr>
@@ -9868,7 +9868,7 @@
           <p:cNvPr id="6" name="">
             <a:extLst xmlns:a="http://schemas.openxmlformats.org/drawingml/2006/main">
               <a:ext uri="{FF2B5EF4-FFF2-40B4-BE49-F238E27FC236}">
-                <a16:creationId xmlns:a16="http://schemas.microsoft.com/office/drawing/2014/main" id="{72217F6C-CA62-4A06-A44A-F61ADD922131}"/>
+                <a16:creationId xmlns:a16="http://schemas.microsoft.com/office/drawing/2014/main" id="{818EC82F-B0A3-47A4-8B7E-6FC9EB2F31C7}"/>
               </a:ext>
             </a:extLst>
           </p:cNvPr>
@@ -9905,7 +9905,7 @@
           <p:nvPr/>
         </p:nvPicPr>
         <p:blipFill>
-          <a:blip xmlns:r="http://schemas.openxmlformats.org/officeDocument/2006/relationships" xmlns:a="http://schemas.openxmlformats.org/drawingml/2006/main" r:embed="Rb8c43e95394a46c4"/>
+          <a:blip xmlns:r="http://schemas.openxmlformats.org/officeDocument/2006/relationships" xmlns:a="http://schemas.openxmlformats.org/drawingml/2006/main" r:embed="R62922ab8ac7549c2"/>
           <a:stretch xmlns:a="http://schemas.openxmlformats.org/drawingml/2006/main"/>
         </p:blipFill>
         <p:spPr>
@@ -9927,7 +9927,7 @@
           <p:nvPr/>
         </p:nvPicPr>
         <p:blipFill>
-          <a:blip xmlns:r="http://schemas.openxmlformats.org/officeDocument/2006/relationships" xmlns:a="http://schemas.openxmlformats.org/drawingml/2006/main" r:embed="R932d2cc19c0c4bd9"/>
+          <a:blip xmlns:r="http://schemas.openxmlformats.org/officeDocument/2006/relationships" xmlns:a="http://schemas.openxmlformats.org/drawingml/2006/main" r:embed="R7c8371996849453b"/>
           <a:stretch xmlns:a="http://schemas.openxmlformats.org/drawingml/2006/main"/>
         </p:blipFill>
         <p:spPr>
@@ -9945,7 +9945,7 @@
           <p:cNvPr id="9" name="">
             <a:extLst xmlns:a="http://schemas.openxmlformats.org/drawingml/2006/main">
               <a:ext uri="{FF2B5EF4-FFF2-40B4-BE49-F238E27FC236}">
-                <a16:creationId xmlns:a16="http://schemas.microsoft.com/office/drawing/2014/main" id="{ECBFA49F-F4C7-4840-B585-28D016A40392}"/>
+                <a16:creationId xmlns:a16="http://schemas.microsoft.com/office/drawing/2014/main" id="{15C2933A-FE25-4815-A4CF-BB6F9A825253}"/>
               </a:ext>
             </a:extLst>
           </p:cNvPr>
@@ -9995,7 +9995,7 @@
           <p:cNvPr id="10" name="">
             <a:extLst xmlns:a="http://schemas.openxmlformats.org/drawingml/2006/main">
               <a:ext uri="{FF2B5EF4-FFF2-40B4-BE49-F238E27FC236}">
-                <a16:creationId xmlns:a16="http://schemas.microsoft.com/office/drawing/2014/main" id="{B6681A35-0E0B-4028-918D-87EAE7116A38}"/>
+                <a16:creationId xmlns:a16="http://schemas.microsoft.com/office/drawing/2014/main" id="{D93EACE2-C480-4CFE-B9AD-D6A9390AC24B}"/>
               </a:ext>
             </a:extLst>
           </p:cNvPr>
@@ -10045,7 +10045,7 @@
           <p:cNvPr id="11" name="">
             <a:extLst xmlns:a="http://schemas.openxmlformats.org/drawingml/2006/main">
               <a:ext uri="{FF2B5EF4-FFF2-40B4-BE49-F238E27FC236}">
-                <a16:creationId xmlns:a16="http://schemas.microsoft.com/office/drawing/2014/main" id="{35F41270-5A5B-4A6F-BF70-8E7CA6626997}"/>
+                <a16:creationId xmlns:a16="http://schemas.microsoft.com/office/drawing/2014/main" id="{AE1FDD17-8947-496F-96C2-DCCD1DCB4B59}"/>
               </a:ext>
             </a:extLst>
           </p:cNvPr>
@@ -10095,7 +10095,7 @@
           <p:cNvPr id="12" name="">
             <a:extLst xmlns:a="http://schemas.openxmlformats.org/drawingml/2006/main">
               <a:ext uri="{FF2B5EF4-FFF2-40B4-BE49-F238E27FC236}">
-                <a16:creationId xmlns:a16="http://schemas.microsoft.com/office/drawing/2014/main" id="{8DEDA2AA-04E3-4D3E-8B24-E15B7B445A4A}"/>
+                <a16:creationId xmlns:a16="http://schemas.microsoft.com/office/drawing/2014/main" id="{2FFC0B45-DB6B-45F4-B2E1-694B65C62F7B}"/>
               </a:ext>
             </a:extLst>
           </p:cNvPr>
@@ -10145,7 +10145,7 @@
           <p:cNvPr id="13" name="">
             <a:extLst xmlns:a="http://schemas.openxmlformats.org/drawingml/2006/main">
               <a:ext uri="{FF2B5EF4-FFF2-40B4-BE49-F238E27FC236}">
-                <a16:creationId xmlns:a16="http://schemas.microsoft.com/office/drawing/2014/main" id="{9E2A2AF4-F476-49ED-94BA-42A65E1DD6C0}"/>
+                <a16:creationId xmlns:a16="http://schemas.microsoft.com/office/drawing/2014/main" id="{A2D3C7B5-4DC3-483A-BC59-16380720DA1C}"/>
               </a:ext>
             </a:extLst>
           </p:cNvPr>
@@ -10195,7 +10195,7 @@
           <p:cNvPr id="14" name="">
             <a:extLst xmlns:a="http://schemas.openxmlformats.org/drawingml/2006/main">
               <a:ext uri="{FF2B5EF4-FFF2-40B4-BE49-F238E27FC236}">
-                <a16:creationId xmlns:a16="http://schemas.microsoft.com/office/drawing/2014/main" id="{CC94488B-9748-4F2D-B6F1-ECA94E776B28}"/>
+                <a16:creationId xmlns:a16="http://schemas.microsoft.com/office/drawing/2014/main" id="{6E06914E-2E43-498F-B8E8-037A4D5FAFB1}"/>
               </a:ext>
             </a:extLst>
           </p:cNvPr>
@@ -10245,7 +10245,7 @@
           <p:cNvPr id="15" name="">
             <a:extLst xmlns:a="http://schemas.openxmlformats.org/drawingml/2006/main">
               <a:ext uri="{FF2B5EF4-FFF2-40B4-BE49-F238E27FC236}">
-                <a16:creationId xmlns:a16="http://schemas.microsoft.com/office/drawing/2014/main" id="{0B3CA7FC-57CA-4206-8AFE-9B0D9DB7D8C0}"/>
+                <a16:creationId xmlns:a16="http://schemas.microsoft.com/office/drawing/2014/main" id="{E86F5DD0-8C54-4C69-854D-C94867BBFE9C}"/>
               </a:ext>
             </a:extLst>
           </p:cNvPr>
@@ -10295,7 +10295,7 @@
           <p:cNvPr id="16" name="">
             <a:extLst xmlns:a="http://schemas.openxmlformats.org/drawingml/2006/main">
               <a:ext uri="{FF2B5EF4-FFF2-40B4-BE49-F238E27FC236}">
-                <a16:creationId xmlns:a16="http://schemas.microsoft.com/office/drawing/2014/main" id="{0708F80C-E6CA-459A-A48E-2DFB04BB9358}"/>
+                <a16:creationId xmlns:a16="http://schemas.microsoft.com/office/drawing/2014/main" id="{DA6B0680-4A43-4E0B-8E32-512474304E37}"/>
               </a:ext>
             </a:extLst>
           </p:cNvPr>
@@ -10343,7 +10343,7 @@
     </p:spTree>
     <p:extLst>
       <p:ext uri="{BB962C8B-B14F-4D97-AF65-F5344CB8AC3E}">
-        <p14:creationId xmlns:p14="http://schemas.microsoft.com/office/powerpoint/2010/main" val="496628497"/>
+        <p14:creationId xmlns:p14="http://schemas.microsoft.com/office/powerpoint/2010/main" val="1069473366"/>
       </p:ext>
     </p:extLst>
   </p:cSld>

</xml_diff>